<commit_message>
Deck: add walk-forward CIs and M6 evidence, research-process disclosure, merged costs slide
Co-authored-by: Cursor <cursoragent@cursor.com>
</commit_message>
<xml_diff>
--- a/presentation/nba_agent_deck.pptx
+++ b/presentation/nba_agent_deck.pptx
@@ -516,7 +516,7 @@
           <a:lstStyle/>
           <a:p>
             <a:r>
-              <a:t>Good morning, we are Group 12. Many people believe that if they follow NBA injury news closely, they can beat sports prediction markets. We took that belief seriously and built the best agent we could to try. What we found is that the game is structurally tilted against the consumer, and that shaped what our product does: it protects and educates rather than encourages betting.</a:t>
+              <a:t>Good morning, we are Group 12. Many people believe that if they follow NBA injury news closely, they can beat sports prediction markets. We took that belief seriously and built the best agent we could. What we found is that the game is structurally tilted against the consumer, so our product protects and educates rather than encourages betting.</a:t>
             </a:r>
           </a:p>
         </p:txBody>
@@ -586,7 +586,7 @@
           <a:lstStyle/>
           <a:p>
             <a:r>
-              <a:t>This slide is context, not our measurement. In most electronic markets, professional traders and market makers have faster data feeds, automated pricing, larger models and, on many venues, special fee or liquidity programmes. A retail user typically reads public news on a phone and pays the full taker price. We are not saying anyone breaks rules; this is how market structure usually works, and it is consistent with the speed and cost results we measured.</a:t>
+              <a:t>Quick context, and this is general industry knowledge, not our measurement. Professional traders and market makers usually have faster data, automated pricing and, on many venues, special fee or liquidity programmes. A retail user reads public news and pays the full taker price. We are not saying anyone breaks rules; it is consistent with the speed and cost results we measured.</a:t>
             </a:r>
           </a:p>
         </p:txBody>
@@ -656,7 +656,7 @@
           <a:lstStyle/>
           <a:p>
             <a:r>
-              <a:t>So we reframed the product around protection. The agent passes by default: it declined about 90% of decision points. Retail briefs show the bid and ask next to our estimate, and when there is no order they say why: the gap after fees is too small or the price already moved. The Coach shows the full break-even after spread and fee. Risk limits and banned words are code the LLM cannot override, and all 9 / 9 planted violations were blocked. Even the learned rules ended up protective: skip long shots, and skip chasing a price that already moved.</a:t>
+              <a:t>So the product is built around protection. The agent passes by default: it declined about 90% of decision points, and on the play-off holdout it did not trade at all. Retail briefs show the bid and ask next to our estimate, and when there is no order they say why. The Coach shows the full break-even after spread and fee. Risk limits and banned words are code the LLM cannot override; all 9 / 9 planted violations were blocked. Even the learned rules ended up protective.</a:t>
             </a:r>
           </a:p>
         </p:txBody>
@@ -726,7 +726,7 @@
           <a:lstStyle/>
           <a:p>
             <a:r>
-              <a:t>The Coach tab turns the same evidence into lessons. At a chosen moment it explains the game using only what was public, and shows the break-even after spread and fee. Lesson cards appear when the situation calls for them: a price is a probability, costs move your break-even, news may be priced in, long shots look cheap. Users make a paper call, see the closing price and what the agent did, and get feedback on habits. Paper money only.</a:t>
+              <a:t>The Coach turns this evidence into lessons. At a chosen moment it explains the game using only what was public and shows the break-even after spread and fee. Lesson cards appear when relevant: price is a probability, costs move your break-even, news may be priced in, long shots look cheap. Users make a paper call and see the close and what the agent did. Paper money only.</a:t>
             </a:r>
           </a:p>
         </p:txBody>
@@ -796,7 +796,7 @@
           <a:lstStyle/>
           <a:p>
             <a:r>
-              <a:t>We want to be precise. Unfair here means structural disadvantages, namely costs, speed and expertise. It does not mean manipulation or fraud, and we make no accusation against Kalshi. Our sample is one season of public data and game-winner markets only, and the news timestamp is a proxy. The long-shot test is underpowered. Our statistical rigour work and the M6 market-impact model are in progress, so these numbers will be updated.</a:t>
+              <a:t>To be precise: unfair here means structural disadvantages, namely costs, speed and expertise. It does not mean manipulation or fraud, and we make no accusation against Kalshi. One disclosure: we designed the market anchor and the reviewer after seeing the first February-to-April results, so that window is not a clean holdout. That is why the walk-forward season and the untouched play-off holdout are our headline tests. Other caveats: one season, game-winner markets only, and a proxy news timestamp.</a:t>
             </a:r>
           </a:p>
         </p:txBody>
@@ -866,7 +866,7 @@
           <a:lstStyle/>
           <a:p>
             <a:r>
-              <a:t>Now the demo, focused on protection. On the replayed night, watch the agent see the news, compare its estimate with the bid and ask, and usually decline with a reason. In the Coach, I'll make a paper call and compare it with the close. Then a quick look at the briefs, the learned rules, and planted violations being blocked. If anything fails, we have a backup recording.</a:t>
+              <a:t>Now the demo, focused on protection. On the replayed night, watch the agent see the news, compare its estimate with the bid and ask, and usually decline with a reason. In the Coach, I'll make a paper call and compare it with the close. Then a quick look at the learned rules and planted violations being blocked. If anything fails, we have a backup recording.</a:t>
             </a:r>
           </a:p>
         </p:txBody>
@@ -936,7 +936,7 @@
           <a:lstStyle/>
           <a:p>
             <a:r>
-              <a:t>Our recommendations follow from the evidence. Before any order, show the all-in cost and the break-even probability, not just the price. Warn by default when news is likely already priced in. Put education, like our Coach, in front of the first trade, with sensible default limits. For our own work, next we finish the statistical tests and M6, enforce a daily-loss stop, and use timestamped injury reports. Thank you, we are happy to take questions.</a:t>
+              <a:t>Our recommendations follow from the evidence. Before any order, show the all-in cost and the break-even probability, not just the price. Warn by default when news is likely already priced in. Put education, like our Coach, in front of the first trade, with sensible default limits. For our own work: enforce a daily-loss stop, use timestamped injury reports, and extend to player-prop markets. Thank you, we are happy to take questions.</a:t>
             </a:r>
           </a:p>
         </p:txBody>
@@ -1006,7 +1006,7 @@
           <a:lstStyle/>
           <a:p>
             <a:r>
-              <a:t>Retail users see an injury headline and think the price is wrong. So we gave an agent every advantage a careful consumer could have: public news, trained models, an agent loop that can use an LLM, risk controls, and rules it learns from its own mistakes. We replayed a full season of real Kalshi prices. If this agent cannot beat the market after costs, a typical consumer is unlikely to.</a:t>
+              <a:t>Retail users see an injury headline and think the price is wrong. So we gave an agent every advantage a careful consumer could have: public news, trained models, an LLM-capable agent loop, risk controls, and rules it learns from its own mistakes, and we replayed a full season of real Kalshi prices. We then tested the results with confidence intervals. The short answer: no edge, and not trading wins.</a:t>
             </a:r>
           </a:p>
         </p:txBody>
@@ -1076,7 +1076,7 @@
           <a:lstStyle/>
           <a:p>
             <a:r>
-              <a:t>Briefly, the system. Public data on the left; models trained once; a replay that walks the season day by day and only shows the agent what was public at that moment; the agent that decides and reviews nightly; and outputs to channel briefs, paper orders, the Coach and evaluation. Because the replay uses recorded prices, every trade pays the real ask and the real Kalshi fee. That is what lets us measure what a consumer would actually face.</a:t>
+              <a:t>Briefly, the system. Public data on the left; models trained once; a replay that walks the season day by day and only shows the agent what was public at that moment; then the agent and its outputs. Because the replay uses recorded prices, every trade pays the real ask and the real Kalshi fee, which is what lets us measure what a consumer would actually face.</a:t>
             </a:r>
           </a:p>
         </p:txBody>
@@ -1146,7 +1146,7 @@
           <a:lstStyle/>
           <a:p>
             <a:r>
-              <a:t>First, costs. At one hour before tip a $20 order pays half the bid-ask spread plus the Kalshi fee, seven percent times p times one minus p. On average that is 1.92 cents per contract, or 5.0% of the price, so you must be right that many points more often than the price says just to break even. On cheap contracts it is 9–14% of the price. On the right: our best agent would have made +$36 at the mid, but fees and spread turned that into −$32.</a:t>
+              <a:t>First, costs. One hour before tip a $20 order pays half the bid-ask spread plus the Kalshi fee. On average that is 1.92 cents per contract, 5.0% of the price, and 9–14% on cheap contracts. You must beat the price by that much just to break even. On the right, our best agent would have made +$36 at the mid but lost −$32 after costs. Even being very selective, 74 trades out of 771 decision points, only 27 (36%) beat or matched the closing price.</a:t>
             </a:r>
           </a:p>
         </p:txBody>
@@ -1216,7 +1216,7 @@
           <a:lstStyle/>
           <a:p>
             <a:r>
-              <a:t>To clear that hurdle the agent has to be very selective. Of 771 decision points in the test period, only 153 showed a gap above 4 points after fees, and 74 became trades. Even then only 27 (36%) of those trades beat or matched the closing price. The close is the market's final answer, so beating it is the real test of an edge, and most trades did not.</a:t>
+              <a:t>Second, speed. On the 193 test games where the inactive list changed our win model by at least a point, the price had already moved 1.80 points in the news direction before the list was public, and only 0.18 after. About 91% of the move happened before a retail user reading the list could act.</a:t>
             </a:r>
           </a:p>
         </p:txBody>
@@ -1286,7 +1286,7 @@
           <a:lstStyle/>
           <a:p>
             <a:r>
-              <a:t>Second, speed. We took the 193 test games where the inactive list changed our win model by at least a point, and measured the price move in the direction of that news. From 24 hours before tip to the moment the list was public, the price had already moved 1.80 points; after it, only 0.18. So about 91% of the move happened before a retail user reading the list could act. Others had the information earlier.</a:t>
+              <a:t>Third, expertise. On 501 test games our win model's Brier score one hour before tip is 0.186, against 0.164 for the market at the same moment; lower is better. When they disagree by more than five points, the market is right in both directions.</a:t>
             </a:r>
           </a:p>
         </p:txBody>
@@ -1356,7 +1356,7 @@
           <a:lstStyle/>
           <a:p>
             <a:r>
-              <a:t>Third, expertise. Our win model is a reasonable model, but on 501 test games its Brier score one hour before tip is 0.186, against 0.164 for the market at the same moment. Lower is better. When they disagree by more than five points, the market is right, in both directions. A consumer's gut feeling is usually a weaker model than ours.</a:t>
+              <a:t>Fourth, we trained M6, a neural network whose only job is to predict how the price moves between our decision time and tip-off, using the market's own past reactions. It cannot beat the simplest guess, that the price will not move: 0.867 cents average error against 0.833, and R squared about zero on both test and holdout. After the inactive list the price moves only about 2.5% of what our win model implies. The M6 agent therefore makes no trades; forced to trade, it loses −$652. The price already contains the public information; what is left for the consumer is the cost.</a:t>
             </a:r>
           </a:p>
         </p:txBody>
@@ -1426,7 +1426,7 @@
           <a:lstStyle/>
           <a:p>
             <a:r>
-              <a:t>Fourth, we checked for the classic long-shot bias, where cheap contracts win less often than their price implies. Honestly, our data does not clearly show it: prices are well calibrated, and only the cheapest bucket hints at it, with one win in 66 contracts priced around 7.4%. What does show is that long shots lose more per dollar, because costs are a bigger share of a cheap price: −13.4% for contracts at 25 cents or less, against −2.2% for heavy favourites.</a:t>
+              <a:t>Finally, the honest test. We re-ran the whole season walk-forward, retraining the win model every month, with day-clustered bootstrap confidence intervals. Mean closing-line value is below zero for every setup, and every interval lies entirely below zero. The full agent's −$25 is indistinguishable from never trading, p 0.53; the raw model loses −$2,475. The market anchor is a real improvement, +$2,450 with p 0.002, but learning only means trading less. On the play-off holdout the full agent made no trades at all.</a:t>
             </a:r>
           </a:p>
         </p:txBody>
@@ -1496,7 +1496,7 @@
           <a:lstStyle/>
           <a:p>
             <a:r>
-              <a:t>Finally, outcomes on the test period, same prices for every setup. Trading the raw model loses −$2,087. Anchoring to the market cuts that to −$247, and our best agent with learning loses −$32 on 74 trades. Mean closing-line value is negative in every setup. Not trading at all scores zero and beats them all. Our interpretation, not a measurement: a consumer who trades whenever they disagree with the price looks like the raw-model row.</a:t>
+              <a:t>We also checked for long-shot bias. Honestly, our data does not clearly show it: prices are well calibrated, and only the cheapest bucket hints at it. What does show is that long shots lose more per dollar, −13.4% against −2.2% for heavy favourites, because costs are a bigger share of a cheap price.</a:t>
             </a:r>
           </a:p>
         </p:txBody>
@@ -5056,7 +5056,7 @@
         <p:spPr>
           <a:xfrm>
             <a:off x="457200" y="2011680"/>
-            <a:ext cx="5440680" cy="4206240"/>
+            <a:ext cx="5440680" cy="3291840"/>
           </a:xfrm>
           <a:prstGeom prst="roundRect">
             <a:avLst>
@@ -5104,7 +5104,7 @@
         <p:spPr>
           <a:xfrm>
             <a:off x="457200" y="2011680"/>
-            <a:ext cx="109728" cy="4206240"/>
+            <a:ext cx="109728" cy="3291840"/>
           </a:xfrm>
           <a:prstGeom prst="rect">
             <a:avLst/>
@@ -5187,7 +5187,7 @@
         <p:spPr>
           <a:xfrm>
             <a:off x="640080" y="2542032"/>
-            <a:ext cx="5166360" cy="3602735"/>
+            <a:ext cx="5166360" cy="2688336"/>
           </a:xfrm>
           <a:prstGeom prst="rect">
             <a:avLst/>
@@ -5213,7 +5213,7 @@
                 </a:solidFill>
                 <a:latin typeface="Arial"/>
               </a:rPr>
-              <a:t>Low-latency data feeds and automated pricing</a:t>
+              <a:t>Fast data feeds and automated pricing</a:t>
             </a:r>
           </a:p>
           <a:p>
@@ -5250,23 +5250,6 @@
               <a:t>On many venues, maker fee or liquidity programmes</a:t>
             </a:r>
           </a:p>
-          <a:p>
-            <a:pPr algn="l" marL="292608" indent="-256032">
-              <a:spcAft>
-                <a:spcPts val="600"/>
-              </a:spcAft>
-              <a:buChar char="•"/>
-            </a:pPr>
-            <a:r>
-              <a:rPr sz="1800" b="0" i="0">
-                <a:solidFill>
-                  <a:srgbClr val="0F172A"/>
-                </a:solidFill>
-                <a:latin typeface="Arial"/>
-              </a:rPr>
-              <a:t>Post prices, so they earn the spread</a:t>
-            </a:r>
-          </a:p>
         </p:txBody>
       </p:sp>
       <p:sp>
@@ -5278,7 +5261,7 @@
         <p:spPr>
           <a:xfrm>
             <a:off x="6291072" y="2011680"/>
-            <a:ext cx="5443423" cy="4206240"/>
+            <a:ext cx="5443423" cy="3291840"/>
           </a:xfrm>
           <a:prstGeom prst="roundRect">
             <a:avLst>
@@ -5326,7 +5309,7 @@
         <p:spPr>
           <a:xfrm>
             <a:off x="6291072" y="2011680"/>
-            <a:ext cx="109728" cy="4206240"/>
+            <a:ext cx="109728" cy="3291840"/>
           </a:xfrm>
           <a:prstGeom prst="rect">
             <a:avLst/>
@@ -5409,7 +5392,7 @@
         <p:spPr>
           <a:xfrm>
             <a:off x="6473952" y="2542032"/>
-            <a:ext cx="5169103" cy="3602735"/>
+            <a:ext cx="5169103" cy="2688336"/>
           </a:xfrm>
           <a:prstGeom prst="rect">
             <a:avLst/>
@@ -5452,7 +5435,7 @@
                 </a:solidFill>
                 <a:latin typeface="Arial"/>
               </a:rPr>
-              <a:t>No model; intuition and headlines</a:t>
+              <a:t>Intuition and headlines, no model</a:t>
             </a:r>
           </a:p>
           <a:p>
@@ -5470,23 +5453,6 @@
                 <a:latin typeface="Arial"/>
               </a:rPr>
               <a:t>Pays the spread and the taker fee</a:t>
-            </a:r>
-          </a:p>
-          <a:p>
-            <a:pPr algn="l" marL="292608" indent="-256032">
-              <a:spcAft>
-                <a:spcPts val="600"/>
-              </a:spcAft>
-              <a:buChar char="•"/>
-            </a:pPr>
-            <a:r>
-              <a:rPr sz="1800" b="0" i="0">
-                <a:solidFill>
-                  <a:srgbClr val="0F172A"/>
-                </a:solidFill>
-                <a:latin typeface="Arial"/>
-              </a:rPr>
-              <a:t>Small, emotional, repeated bets</a:t>
             </a:r>
           </a:p>
         </p:txBody>
@@ -7566,7 +7532,7 @@
                 </a:solidFill>
                 <a:latin typeface="Arial"/>
               </a:rPr>
-              <a:t>Caveats</a:t>
+              <a:t>Caveats and disclosure</a:t>
             </a:r>
           </a:p>
         </p:txBody>
@@ -7600,13 +7566,22 @@
               <a:buChar char="•"/>
             </a:pPr>
             <a:r>
+              <a:rPr sz="1800" b="1" i="0">
+                <a:solidFill>
+                  <a:srgbClr val="0F172A"/>
+                </a:solidFill>
+                <a:latin typeface="Arial"/>
+              </a:rPr>
+              <a:t>Disclosure:</a:t>
+            </a:r>
+            <a:r>
               <a:rPr sz="1800" b="0" i="0">
                 <a:solidFill>
                   <a:srgbClr val="0F172A"/>
                 </a:solidFill>
                 <a:latin typeface="Arial"/>
               </a:rPr>
-              <a:t>One season (1,316 games), game-winner markets only</a:t>
+              <a:t> anchor and reviewer designed after seeing Feb–Apr results, so that window is not a clean holdout; walk-forward and play-off holdout are the honest checks</a:t>
             </a:r>
           </a:p>
           <a:p>
@@ -7623,7 +7598,7 @@
                 </a:solidFill>
                 <a:latin typeface="Arial"/>
               </a:rPr>
-              <a:t>News stamped tip − 30 min (proxy; real reports come earlier)</a:t>
+              <a:t>One season (1,316 games), game-winner markets only</a:t>
             </a:r>
           </a:p>
           <a:p>
@@ -7640,7 +7615,7 @@
                 </a:solidFill>
                 <a:latin typeface="Arial"/>
               </a:rPr>
-              <a:t>Costs measured for a $20 order at tip − 60 min</a:t>
+              <a:t>News stamped tip − 30 min (proxy; real reports come earlier)</a:t>
             </a:r>
           </a:p>
           <a:p>
@@ -7657,24 +7632,7 @@
                 </a:solidFill>
                 <a:latin typeface="Arial"/>
               </a:rPr>
-              <a:t>Long-shot test underpowered; agent CLV within ~1 s.e. of zero</a:t>
-            </a:r>
-          </a:p>
-          <a:p>
-            <a:pPr algn="l" marL="292608" indent="-256032">
-              <a:spcAft>
-                <a:spcPts val="600"/>
-              </a:spcAft>
-              <a:buChar char="•"/>
-            </a:pPr>
-            <a:r>
-              <a:rPr sz="1800" b="0" i="0">
-                <a:solidFill>
-                  <a:srgbClr val="0F172A"/>
-                </a:solidFill>
-                <a:latin typeface="Arial"/>
-              </a:rPr>
-              <a:t>In progress: statistical rigour and the M6 market-impact model; numbers will update</a:t>
+              <a:t>Costs measured for a $20 order at tip − 60 min; long-shot test underpowered</a:t>
             </a:r>
           </a:p>
         </p:txBody>
@@ -8943,23 +8901,6 @@
                 </a:solidFill>
                 <a:latin typeface="Arial"/>
               </a:rPr>
-              <a:t>Finish the statistical tests and the M6 market-impact model</a:t>
-            </a:r>
-          </a:p>
-          <a:p>
-            <a:pPr algn="l" marL="292608" indent="-256032">
-              <a:spcAft>
-                <a:spcPts val="600"/>
-              </a:spcAft>
-              <a:buChar char="•"/>
-            </a:pPr>
-            <a:r>
-              <a:rPr sz="1800" b="0" i="0">
-                <a:solidFill>
-                  <a:srgbClr val="0F172A"/>
-                </a:solidFill>
-                <a:latin typeface="Arial"/>
-              </a:rPr>
               <a:t>Show the full break-even in every retail brief</a:t>
             </a:r>
           </a:p>
@@ -9329,7 +9270,7 @@
                 </a:solidFill>
                 <a:latin typeface="Arial"/>
               </a:rPr>
-              <a:t>Learned models: GRU player model, play classifier, win model</a:t>
+              <a:t>Learned models, including a neural net trained on the market's own moves</a:t>
             </a:r>
           </a:p>
           <a:p>
@@ -9481,7 +9422,7 @@
                 </a:solidFill>
                 <a:latin typeface="Arial"/>
               </a:rPr>
-              <a:t>Even this agent does not beat the market after costs.</a:t>
+              <a:t>Tested with confidence intervals: no edge. Never trading is the winner.</a:t>
             </a:r>
           </a:p>
           <a:p>
@@ -10043,8 +9984,8 @@
         </p:blipFill>
         <p:spPr>
           <a:xfrm>
-            <a:off x="1180947" y="1097280"/>
-            <a:ext cx="9829799" cy="3931920"/>
+            <a:off x="1352397" y="1097280"/>
+            <a:ext cx="9486900" cy="3794760"/>
           </a:xfrm>
           <a:prstGeom prst="rect">
             <a:avLst/>
@@ -10059,8 +10000,8 @@
         </p:nvSpPr>
         <p:spPr>
           <a:xfrm>
-            <a:off x="457200" y="5120640"/>
-            <a:ext cx="5547207" cy="1234440"/>
+            <a:off x="457200" y="4983480"/>
+            <a:ext cx="5547207" cy="1371600"/>
           </a:xfrm>
           <a:prstGeom prst="rect">
             <a:avLst/>
@@ -10095,7 +10036,25 @@
                 </a:solidFill>
                 <a:latin typeface="Arial"/>
               </a:rPr>
-              <a:t> = 5.0% of price (spread 0.53¢ + fee 1.39¢)</a:t>
+              <a:t> = 5.0% of price; </a:t>
+            </a:r>
+            <a:r>
+              <a:rPr sz="1800" b="1" i="0">
+                <a:solidFill>
+                  <a:srgbClr val="0F172A"/>
+                </a:solidFill>
+                <a:latin typeface="Arial"/>
+              </a:rPr>
+              <a:t>9–14%</a:t>
+            </a:r>
+            <a:r>
+              <a:rPr sz="1800" b="0" i="0">
+                <a:solidFill>
+                  <a:srgbClr val="0F172A"/>
+                </a:solidFill>
+                <a:latin typeface="Arial"/>
+              </a:rPr>
+              <a:t> under 20¢</a:t>
             </a:r>
           </a:p>
           <a:p>
@@ -10112,7 +10071,7 @@
                 </a:solidFill>
                 <a:latin typeface="Arial"/>
               </a:rPr>
-              <a:t>Under 20¢: </a:t>
+              <a:t>Best agent, Feb–Apr: +$36 at mid → </a:t>
             </a:r>
             <a:r>
               <a:rPr sz="1800" b="1" i="0">
@@ -10121,7 +10080,7 @@
                 </a:solidFill>
                 <a:latin typeface="Arial"/>
               </a:rPr>
-              <a:t>9–14%</a:t>
+              <a:t>−$32</a:t>
             </a:r>
             <a:r>
               <a:rPr sz="1800" b="0" i="0">
@@ -10130,7 +10089,7 @@
                 </a:solidFill>
                 <a:latin typeface="Arial"/>
               </a:rPr>
-              <a:t> of the price</a:t>
+              <a:t> after costs</a:t>
             </a:r>
           </a:p>
         </p:txBody>
@@ -10143,8 +10102,8 @@
         </p:nvSpPr>
         <p:spPr>
           <a:xfrm>
-            <a:off x="6187287" y="5120640"/>
-            <a:ext cx="5547207" cy="1234440"/>
+            <a:off x="6187287" y="4983480"/>
+            <a:ext cx="5547207" cy="1371600"/>
           </a:xfrm>
           <a:prstGeom prst="rect">
             <a:avLst/>
@@ -10170,7 +10129,7 @@
                 </a:solidFill>
                 <a:latin typeface="Arial"/>
               </a:rPr>
-              <a:t>Best agent: </a:t>
+              <a:t>771 decision points → 153 with gap &gt; 4 pts → </a:t>
             </a:r>
             <a:r>
               <a:rPr sz="1800" b="1" i="0">
@@ -10179,34 +10138,7 @@
                 </a:solidFill>
                 <a:latin typeface="Arial"/>
               </a:rPr>
-              <a:t>+$36</a:t>
-            </a:r>
-            <a:r>
-              <a:rPr sz="1800" b="0" i="0">
-                <a:solidFill>
-                  <a:srgbClr val="0F172A"/>
-                </a:solidFill>
-                <a:latin typeface="Arial"/>
-              </a:rPr>
-              <a:t> at the mid → </a:t>
-            </a:r>
-            <a:r>
-              <a:rPr sz="1800" b="1" i="0">
-                <a:solidFill>
-                  <a:srgbClr val="0F172A"/>
-                </a:solidFill>
-                <a:latin typeface="Arial"/>
-              </a:rPr>
-              <a:t>−$32</a:t>
-            </a:r>
-            <a:r>
-              <a:rPr sz="1800" b="0" i="0">
-                <a:solidFill>
-                  <a:srgbClr val="0F172A"/>
-                </a:solidFill>
-                <a:latin typeface="Arial"/>
-              </a:rPr>
-              <a:t> after costs</a:t>
+              <a:t>74 trades</a:t>
             </a:r>
           </a:p>
           <a:p>
@@ -10223,7 +10155,25 @@
                 </a:solidFill>
                 <a:latin typeface="Arial"/>
               </a:rPr>
-              <a:t>Raw model: −$1,540 → −$2,087</a:t>
+              <a:t>Only </a:t>
+            </a:r>
+            <a:r>
+              <a:rPr sz="1800" b="1" i="0">
+                <a:solidFill>
+                  <a:srgbClr val="0F172A"/>
+                </a:solidFill>
+                <a:latin typeface="Arial"/>
+              </a:rPr>
+              <a:t>27 (36%)</a:t>
+            </a:r>
+            <a:r>
+              <a:rPr sz="1800" b="0" i="0">
+                <a:solidFill>
+                  <a:srgbClr val="0F172A"/>
+                </a:solidFill>
+                <a:latin typeface="Arial"/>
+              </a:rPr>
+              <a:t> beat or matched the close</a:t>
             </a:r>
           </a:p>
         </p:txBody>
@@ -10368,7 +10318,7 @@
                 </a:solidFill>
                 <a:latin typeface="Arial"/>
               </a:rPr>
-              <a:t>Even a selective agent rarely beats the closing price</a:t>
+              <a:t>Evidence 2: the price moves before the news reaches you</a:t>
             </a:r>
           </a:p>
         </p:txBody>
@@ -10453,7 +10403,7 @@
       </p:sp>
       <p:pic>
         <p:nvPicPr>
-          <p:cNvPr id="7" name="Picture 6" descr="trade_funnel.png"/>
+          <p:cNvPr id="7" name="Picture 6" descr="price_discovery.png"/>
           <p:cNvPicPr>
             <a:picLocks noChangeAspect="1"/>
           </p:cNvPicPr>
@@ -10467,8 +10417,8 @@
         </p:blipFill>
         <p:spPr>
           <a:xfrm>
-            <a:off x="457200" y="1533698"/>
-            <a:ext cx="7955279" cy="4339243"/>
+            <a:off x="895197" y="1097280"/>
+            <a:ext cx="10401299" cy="4160520"/>
           </a:xfrm>
           <a:prstGeom prst="rect">
             <a:avLst/>
@@ -10483,8 +10433,8 @@
         </p:nvSpPr>
         <p:spPr>
           <a:xfrm>
-            <a:off x="8549640" y="1463040"/>
-            <a:ext cx="3184855" cy="4846320"/>
+            <a:off x="457200" y="5349240"/>
+            <a:ext cx="11277295" cy="1005840"/>
           </a:xfrm>
           <a:prstGeom prst="rect">
             <a:avLst/>
@@ -10499,140 +10449,44 @@
           <a:p>
             <a:pPr algn="l" marL="292608" indent="-256032">
               <a:spcAft>
-                <a:spcPts val="1200"/>
+                <a:spcPts val="400"/>
               </a:spcAft>
               <a:buChar char="•"/>
             </a:pPr>
             <a:r>
-              <a:rPr sz="2000" b="1" i="0">
+              <a:rPr sz="1800" b="1" i="0">
                 <a:solidFill>
                   <a:srgbClr val="0F172A"/>
                 </a:solidFill>
                 <a:latin typeface="Arial"/>
               </a:rPr>
-              <a:t>771</a:t>
-            </a:r>
-            <a:r>
-              <a:rPr sz="2000" b="0" i="0">
+              <a:t>91%</a:t>
+            </a:r>
+            <a:r>
+              <a:rPr sz="1800" b="0" i="0">
                 <a:solidFill>
                   <a:srgbClr val="0F172A"/>
                 </a:solidFill>
                 <a:latin typeface="Arial"/>
               </a:rPr>
-              <a:t> decision points</a:t>
+              <a:t> of the news-direction move was already in the price when the list was public (+1.80 vs +0.18 pts, 193 test games)</a:t>
             </a:r>
           </a:p>
           <a:p>
             <a:pPr algn="l" marL="292608" indent="-256032">
               <a:spcAft>
-                <a:spcPts val="1200"/>
+                <a:spcPts val="400"/>
               </a:spcAft>
               <a:buChar char="•"/>
             </a:pPr>
             <a:r>
-              <a:rPr sz="2000" b="1" i="0">
+              <a:rPr sz="1800" b="0" i="0">
                 <a:solidFill>
                   <a:srgbClr val="0F172A"/>
                 </a:solidFill>
                 <a:latin typeface="Arial"/>
               </a:rPr>
-              <a:t>153</a:t>
-            </a:r>
-            <a:r>
-              <a:rPr sz="2000" b="0" i="0">
-                <a:solidFill>
-                  <a:srgbClr val="0F172A"/>
-                </a:solidFill>
-                <a:latin typeface="Arial"/>
-              </a:rPr>
-              <a:t> with a gap &gt; 4 pts after fees</a:t>
-            </a:r>
-          </a:p>
-          <a:p>
-            <a:pPr algn="l" marL="292608" indent="-256032">
-              <a:spcAft>
-                <a:spcPts val="1200"/>
-              </a:spcAft>
-              <a:buChar char="•"/>
-            </a:pPr>
-            <a:r>
-              <a:rPr sz="2000" b="1" i="0">
-                <a:solidFill>
-                  <a:srgbClr val="0F172A"/>
-                </a:solidFill>
-                <a:latin typeface="Arial"/>
-              </a:rPr>
-              <a:t>74</a:t>
-            </a:r>
-            <a:r>
-              <a:rPr sz="2000" b="0" i="0">
-                <a:solidFill>
-                  <a:srgbClr val="0F172A"/>
-                </a:solidFill>
-                <a:latin typeface="Arial"/>
-              </a:rPr>
-              <a:t> trades</a:t>
-            </a:r>
-          </a:p>
-          <a:p>
-            <a:pPr algn="l" marL="292608" indent="-256032">
-              <a:spcAft>
-                <a:spcPts val="1200"/>
-              </a:spcAft>
-              <a:buChar char="•"/>
-            </a:pPr>
-            <a:r>
-              <a:rPr sz="2000" b="0" i="0">
-                <a:solidFill>
-                  <a:srgbClr val="0F172A"/>
-                </a:solidFill>
-                <a:latin typeface="Arial"/>
-              </a:rPr>
-              <a:t>Only </a:t>
-            </a:r>
-            <a:r>
-              <a:rPr sz="2000" b="1" i="0">
-                <a:solidFill>
-                  <a:srgbClr val="0F172A"/>
-                </a:solidFill>
-                <a:latin typeface="Arial"/>
-              </a:rPr>
-              <a:t>27 (36%)</a:t>
-            </a:r>
-            <a:r>
-              <a:rPr sz="2000" b="0" i="0">
-                <a:solidFill>
-                  <a:srgbClr val="0F172A"/>
-                </a:solidFill>
-                <a:latin typeface="Arial"/>
-              </a:rPr>
-              <a:t> beat or matched the close</a:t>
-            </a:r>
-          </a:p>
-          <a:p>
-            <a:pPr algn="l" marL="292608" indent="-256032">
-              <a:spcAft>
-                <a:spcPts val="1200"/>
-              </a:spcAft>
-              <a:buChar char="•"/>
-            </a:pPr>
-            <a:r>
-              <a:rPr sz="2000" b="1" i="0">
-                <a:solidFill>
-                  <a:srgbClr val="0F172A"/>
-                </a:solidFill>
-                <a:latin typeface="Arial"/>
-              </a:rPr>
-              <a:t>41 (55%)</a:t>
-            </a:r>
-            <a:r>
-              <a:rPr sz="2000" b="0" i="0">
-                <a:solidFill>
-                  <a:srgbClr val="0F172A"/>
-                </a:solidFill>
-                <a:latin typeface="Arial"/>
-              </a:rPr>
-              <a:t> won, but winning ≠ an edge</a:t>
+              <a:t>List stamped tip − 30 min: our proxy for when a retail user sees it</a:t>
             </a:r>
           </a:p>
         </p:txBody>
@@ -10777,7 +10631,7 @@
                 </a:solidFill>
                 <a:latin typeface="Arial"/>
               </a:rPr>
-              <a:t>Evidence 2: the price moves before the news reaches you</a:t>
+              <a:t>Evidence 3: the market beats our model</a:t>
             </a:r>
           </a:p>
         </p:txBody>
@@ -10862,7 +10716,7 @@
       </p:sp>
       <p:pic>
         <p:nvPicPr>
-          <p:cNvPr id="7" name="Picture 6" descr="price_discovery.png"/>
+          <p:cNvPr id="7" name="Picture 6" descr="m4_vs_market.png"/>
           <p:cNvPicPr>
             <a:picLocks noChangeAspect="1"/>
           </p:cNvPicPr>
@@ -10876,8 +10730,8 @@
         </p:blipFill>
         <p:spPr>
           <a:xfrm>
-            <a:off x="895197" y="1097280"/>
-            <a:ext cx="10401299" cy="4160520"/>
+            <a:off x="457200" y="1209821"/>
+            <a:ext cx="6949440" cy="5078436"/>
           </a:xfrm>
           <a:prstGeom prst="rect">
             <a:avLst/>
@@ -10892,8 +10746,8 @@
         </p:nvSpPr>
         <p:spPr>
           <a:xfrm>
-            <a:off x="457200" y="5349240"/>
-            <a:ext cx="11277295" cy="1005840"/>
+            <a:off x="7589520" y="1280160"/>
+            <a:ext cx="4144975" cy="5120640"/>
           </a:xfrm>
           <a:prstGeom prst="rect">
             <a:avLst/>
@@ -10908,44 +10762,104 @@
           <a:p>
             <a:pPr algn="l" marL="292608" indent="-256032">
               <a:spcAft>
-                <a:spcPts val="400"/>
+                <a:spcPts val="1000"/>
               </a:spcAft>
               <a:buChar char="•"/>
             </a:pPr>
             <a:r>
-              <a:rPr sz="1800" b="1" i="0">
+              <a:rPr sz="1900" b="0" i="0">
                 <a:solidFill>
                   <a:srgbClr val="0F172A"/>
                 </a:solidFill>
                 <a:latin typeface="Arial"/>
               </a:rPr>
-              <a:t>91%</a:t>
-            </a:r>
-            <a:r>
-              <a:rPr sz="1800" b="0" i="0">
+              <a:t>Brier, 501 test games, 1 h before tip: </a:t>
+            </a:r>
+            <a:r>
+              <a:rPr sz="1900" b="1" i="0">
                 <a:solidFill>
                   <a:srgbClr val="0F172A"/>
                 </a:solidFill>
                 <a:latin typeface="Arial"/>
               </a:rPr>
-              <a:t> of the news-direction move was already in the price when the list was public (+1.80 vs +0.18 pts, 193 test games)</a:t>
+              <a:t>market 0.164</a:t>
+            </a:r>
+            <a:r>
+              <a:rPr sz="1900" b="0" i="0">
+                <a:solidFill>
+                  <a:srgbClr val="0F172A"/>
+                </a:solidFill>
+                <a:latin typeface="Arial"/>
+              </a:rPr>
+              <a:t>, our model 0.186</a:t>
             </a:r>
           </a:p>
           <a:p>
             <a:pPr algn="l" marL="292608" indent="-256032">
               <a:spcAft>
-                <a:spcPts val="400"/>
+                <a:spcPts val="1000"/>
               </a:spcAft>
               <a:buChar char="•"/>
             </a:pPr>
             <a:r>
-              <a:rPr sz="1800" b="0" i="0">
+              <a:rPr sz="1900" b="0" i="0">
                 <a:solidFill>
                   <a:srgbClr val="0F172A"/>
                 </a:solidFill>
                 <a:latin typeface="Arial"/>
               </a:rPr>
-              <a:t>List stamped tip − 30 min: our proxy for when a retail user sees it</a:t>
+              <a:t>Disagree by more than 5 pts, and the market is right:</a:t>
+            </a:r>
+          </a:p>
+          <a:p>
+            <a:pPr algn="l" marL="612647" indent="-256032">
+              <a:spcAft>
+                <a:spcPts val="1000"/>
+              </a:spcAft>
+              <a:buChar char="–"/>
+            </a:pPr>
+            <a:r>
+              <a:rPr sz="1700" b="0" i="0">
+                <a:solidFill>
+                  <a:srgbClr val="0F172A"/>
+                </a:solidFill>
+                <a:latin typeface="Arial"/>
+              </a:rPr>
+              <a:t>model higher on home: model 48%, market 35%, actual 34%</a:t>
+            </a:r>
+          </a:p>
+          <a:p>
+            <a:pPr algn="l" marL="612647" indent="-256032">
+              <a:spcAft>
+                <a:spcPts val="1000"/>
+              </a:spcAft>
+              <a:buChar char="–"/>
+            </a:pPr>
+            <a:r>
+              <a:rPr sz="1700" b="0" i="0">
+                <a:solidFill>
+                  <a:srgbClr val="0F172A"/>
+                </a:solidFill>
+                <a:latin typeface="Arial"/>
+              </a:rPr>
+              <a:t>model lower on home: model 61%, market 73%, actual 77%</a:t>
+            </a:r>
+          </a:p>
+          <a:p>
+            <a:pPr algn="l" marL="292608" indent="-256032">
+              <a:spcAft>
+                <a:spcPts val="1000"/>
+              </a:spcAft>
+              <a:buChar char="•"/>
+            </a:pPr>
+            <a:r>
+              <a:rPr sz="1600" b="0" i="0">
+                <a:solidFill>
+                  <a:srgbClr val="64748B"/>
+                </a:solidFill>
+                <a:latin typeface="Arial"/>
+              </a:rPr>
+              <a:t>With the inactive list: model 0.183 vs market at tip 0.163</a:t>
             </a:r>
           </a:p>
         </p:txBody>
@@ -11090,7 +11004,7 @@
                 </a:solidFill>
                 <a:latin typeface="Arial"/>
               </a:rPr>
-              <a:t>Evidence 3: the market beats our model</a:t>
+              <a:t>Evidence 4: even a market-trained neural net finds nothing</a:t>
             </a:r>
           </a:p>
         </p:txBody>
@@ -11175,7 +11089,7 @@
       </p:sp>
       <p:pic>
         <p:nvPicPr>
-          <p:cNvPr id="7" name="Picture 6" descr="m4_vs_market.png"/>
+          <p:cNvPr id="7" name="Picture 6" descr="m6_vs_baselines.png"/>
           <p:cNvPicPr>
             <a:picLocks noChangeAspect="1"/>
           </p:cNvPicPr>
@@ -11189,8 +11103,8 @@
         </p:blipFill>
         <p:spPr>
           <a:xfrm>
-            <a:off x="457200" y="1209821"/>
-            <a:ext cx="6949440" cy="5078436"/>
+            <a:off x="579630" y="1097280"/>
+            <a:ext cx="11032434" cy="3383280"/>
           </a:xfrm>
           <a:prstGeom prst="rect">
             <a:avLst/>
@@ -11205,8 +11119,8 @@
         </p:nvSpPr>
         <p:spPr>
           <a:xfrm>
-            <a:off x="7589520" y="1280160"/>
-            <a:ext cx="4144975" cy="5120640"/>
+            <a:off x="457200" y="4526280"/>
+            <a:ext cx="11277295" cy="1298448"/>
           </a:xfrm>
           <a:prstGeom prst="rect">
             <a:avLst/>
@@ -11221,104 +11135,156 @@
           <a:p>
             <a:pPr algn="l" marL="292608" indent="-256032">
               <a:spcAft>
-                <a:spcPts val="1000"/>
+                <a:spcPts val="400"/>
               </a:spcAft>
               <a:buChar char="•"/>
             </a:pPr>
             <a:r>
-              <a:rPr sz="1900" b="0" i="0">
+              <a:rPr sz="1800" b="0" i="0">
                 <a:solidFill>
                   <a:srgbClr val="0F172A"/>
                 </a:solidFill>
                 <a:latin typeface="Arial"/>
               </a:rPr>
-              <a:t>Brier, 501 test games, 1 h before tip: </a:t>
-            </a:r>
-            <a:r>
-              <a:rPr sz="1900" b="1" i="0">
+              <a:t>Average error on 771 test decision times: </a:t>
+            </a:r>
+            <a:r>
+              <a:rPr sz="1800" b="1" i="0">
                 <a:solidFill>
                   <a:srgbClr val="0F172A"/>
                 </a:solidFill>
                 <a:latin typeface="Arial"/>
               </a:rPr>
-              <a:t>market 0.164</a:t>
-            </a:r>
-            <a:r>
-              <a:rPr sz="1900" b="0" i="0">
+              <a:t>M6 0.867¢</a:t>
+            </a:r>
+            <a:r>
+              <a:rPr sz="1800" b="0" i="0">
                 <a:solidFill>
                   <a:srgbClr val="0F172A"/>
                 </a:solidFill>
                 <a:latin typeface="Arial"/>
               </a:rPr>
-              <a:t>, our model 0.186</a:t>
+              <a:t> vs “price won't move” </a:t>
+            </a:r>
+            <a:r>
+              <a:rPr sz="1800" b="1" i="0">
+                <a:solidFill>
+                  <a:srgbClr val="0F172A"/>
+                </a:solidFill>
+                <a:latin typeface="Arial"/>
+              </a:rPr>
+              <a:t>0.833¢</a:t>
+            </a:r>
+            <a:r>
+              <a:rPr sz="1800" b="0" i="0">
+                <a:solidFill>
+                  <a:srgbClr val="0F172A"/>
+                </a:solidFill>
+                <a:latin typeface="Arial"/>
+              </a:rPr>
+              <a:t>; R² ≈ 0 on test and holdout</a:t>
             </a:r>
           </a:p>
           <a:p>
             <a:pPr algn="l" marL="292608" indent="-256032">
               <a:spcAft>
-                <a:spcPts val="1000"/>
+                <a:spcPts val="400"/>
               </a:spcAft>
               <a:buChar char="•"/>
             </a:pPr>
             <a:r>
-              <a:rPr sz="1900" b="0" i="0">
+              <a:rPr sz="1800" b="0" i="0">
                 <a:solidFill>
                   <a:srgbClr val="0F172A"/>
                 </a:solidFill>
                 <a:latin typeface="Arial"/>
               </a:rPr>
-              <a:t>Disagree by more than 5 pts, and the market is right:</a:t>
-            </a:r>
-          </a:p>
-          <a:p>
-            <a:pPr algn="l" marL="612647" indent="-256032">
+              <a:t>After the list, the price moves ~2.5% of the model's implied shift (coefficient 0.025); M6 agent: 0 trades. Forced: 501 trades, −$652</a:t>
+            </a:r>
+          </a:p>
+        </p:txBody>
+      </p:sp>
+      <p:sp>
+        <p:nvSpPr>
+          <p:cNvPr id="9" name="Rounded Rectangle 8"/>
+          <p:cNvSpPr/>
+          <p:nvPr/>
+        </p:nvSpPr>
+        <p:spPr>
+          <a:xfrm>
+            <a:off x="457200" y="5870448"/>
+            <a:ext cx="11277295" cy="457200"/>
+          </a:xfrm>
+          <a:prstGeom prst="roundRect">
+            <a:avLst>
+              <a:gd name="adj" fmla="val 12000"/>
+            </a:avLst>
+          </a:prstGeom>
+          <a:solidFill>
+            <a:srgbClr val="FEF3C7"/>
+          </a:solidFill>
+          <a:ln>
+            <a:noFill/>
+          </a:ln>
+          <a:effectLst/>
+        </p:spPr>
+        <p:style>
+          <a:lnRef idx="1">
+            <a:schemeClr val="accent1"/>
+          </a:lnRef>
+          <a:fillRef idx="3">
+            <a:schemeClr val="accent1"/>
+          </a:fillRef>
+          <a:effectRef idx="2">
+            <a:schemeClr val="accent1"/>
+          </a:effectRef>
+          <a:fontRef idx="minor">
+            <a:schemeClr val="lt1"/>
+          </a:fontRef>
+        </p:style>
+        <p:txBody>
+          <a:bodyPr rtlCol="0" anchor="ctr"/>
+          <a:lstStyle/>
+          <a:p>
+            <a:pPr algn="ctr"/>
+          </a:p>
+        </p:txBody>
+      </p:sp>
+      <p:sp>
+        <p:nvSpPr>
+          <p:cNvPr id="10" name="TextBox 9"/>
+          <p:cNvSpPr txBox="1"/>
+          <p:nvPr/>
+        </p:nvSpPr>
+        <p:spPr>
+          <a:xfrm>
+            <a:off x="548640" y="5870448"/>
+            <a:ext cx="11094415" cy="457200"/>
+          </a:xfrm>
+          <a:prstGeom prst="rect">
+            <a:avLst/>
+          </a:prstGeom>
+          <a:noFill/>
+        </p:spPr>
+        <p:txBody>
+          <a:bodyPr wrap="square" anchor="ctr" lIns="73152" rIns="73152" tIns="36576" bIns="36576">
+            <a:spAutoFit/>
+          </a:bodyPr>
+          <a:lstStyle/>
+          <a:p>
+            <a:pPr algn="l">
               <a:spcAft>
-                <a:spcPts val="1000"/>
+                <a:spcPts val="0"/>
               </a:spcAft>
-              <a:buChar char="–"/>
             </a:pPr>
             <a:r>
-              <a:rPr sz="1700" b="0" i="0">
+              <a:rPr sz="1800" b="0" i="0">
                 <a:solidFill>
                   <a:srgbClr val="0F172A"/>
                 </a:solidFill>
                 <a:latin typeface="Arial"/>
               </a:rPr>
-              <a:t>model higher on home: model 48%, market 35%, actual 34%</a:t>
-            </a:r>
-          </a:p>
-          <a:p>
-            <a:pPr algn="l" marL="612647" indent="-256032">
-              <a:spcAft>
-                <a:spcPts val="1000"/>
-              </a:spcAft>
-              <a:buChar char="–"/>
-            </a:pPr>
-            <a:r>
-              <a:rPr sz="1700" b="0" i="0">
-                <a:solidFill>
-                  <a:srgbClr val="0F172A"/>
-                </a:solidFill>
-                <a:latin typeface="Arial"/>
-              </a:rPr>
-              <a:t>model lower on home: model 61%, market 73%, actual 77%</a:t>
-            </a:r>
-          </a:p>
-          <a:p>
-            <a:pPr algn="l" marL="292608" indent="-256032">
-              <a:spcAft>
-                <a:spcPts val="1000"/>
-              </a:spcAft>
-              <a:buChar char="•"/>
-            </a:pPr>
-            <a:r>
-              <a:rPr sz="1600" b="0" i="0">
-                <a:solidFill>
-                  <a:srgbClr val="64748B"/>
-                </a:solidFill>
-                <a:latin typeface="Arial"/>
-              </a:rPr>
-              <a:t>With the inactive list: model 0.183 vs market at tip 0.163</a:t>
+              <a:t>The price already contains the public information; the consumer is left paying costs</a:t>
             </a:r>
           </a:p>
         </p:txBody>
@@ -11463,7 +11429,7 @@
                 </a:solidFill>
                 <a:latin typeface="Arial"/>
               </a:rPr>
-              <a:t>Evidence 4: long shots, where the data is weaker</a:t>
+              <a:t>Evidence 5: tested with CIs, never trading wins</a:t>
             </a:r>
           </a:p>
         </p:txBody>
@@ -11548,7 +11514,7 @@
       </p:sp>
       <p:pic>
         <p:nvPicPr>
-          <p:cNvPr id="7" name="Picture 6" descr="longshot_calibration.png"/>
+          <p:cNvPr id="7" name="Picture 6" descr="walkforward.png"/>
           <p:cNvPicPr>
             <a:picLocks noChangeAspect="1"/>
           </p:cNvPicPr>
@@ -11562,339 +11528,8 @@
         </p:blipFill>
         <p:spPr>
           <a:xfrm>
-            <a:off x="895197" y="1097280"/>
-            <a:ext cx="10401299" cy="4160520"/>
-          </a:xfrm>
-          <a:prstGeom prst="rect">
-            <a:avLst/>
-          </a:prstGeom>
-        </p:spPr>
-      </p:pic>
-      <p:sp>
-        <p:nvSpPr>
-          <p:cNvPr id="8" name="TextBox 7"/>
-          <p:cNvSpPr txBox="1"/>
-          <p:nvPr/>
-        </p:nvSpPr>
-        <p:spPr>
-          <a:xfrm>
-            <a:off x="457200" y="5349240"/>
-            <a:ext cx="11277295" cy="1005840"/>
-          </a:xfrm>
-          <a:prstGeom prst="rect">
-            <a:avLst/>
-          </a:prstGeom>
-          <a:noFill/>
-        </p:spPr>
-        <p:txBody>
-          <a:bodyPr wrap="square" anchor="t" lIns="73152" rIns="73152" tIns="36576" bIns="36576">
-            <a:spAutoFit/>
-          </a:bodyPr>
-          <a:lstStyle/>
-          <a:p>
-            <a:pPr algn="l" marL="292608" indent="-256032">
-              <a:spcAft>
-                <a:spcPts val="400"/>
-              </a:spcAft>
-              <a:buChar char="•"/>
-            </a:pPr>
-            <a:r>
-              <a:rPr sz="1800" b="1" i="0">
-                <a:solidFill>
-                  <a:srgbClr val="0F172A"/>
-                </a:solidFill>
-                <a:latin typeface="Arial"/>
-              </a:rPr>
-              <a:t>Not clearly supported:</a:t>
-            </a:r>
-            <a:r>
-              <a:rPr sz="1800" b="0" i="0">
-                <a:solidFill>
-                  <a:srgbClr val="0F172A"/>
-                </a:solidFill>
-                <a:latin typeface="Arial"/>
-              </a:rPr>
-              <a:t> prices are calibrated; only 0–10¢ hints (1 win in 66 vs 7.4% implied, z = −1.8)</a:t>
-            </a:r>
-          </a:p>
-          <a:p>
-            <a:pPr algn="l" marL="292608" indent="-256032">
-              <a:spcAft>
-                <a:spcPts val="400"/>
-              </a:spcAft>
-              <a:buChar char="•"/>
-            </a:pPr>
-            <a:r>
-              <a:rPr sz="1800" b="0" i="0">
-                <a:solidFill>
-                  <a:srgbClr val="0F172A"/>
-                </a:solidFill>
-                <a:latin typeface="Arial"/>
-              </a:rPr>
-              <a:t>Buying at ask + fee: long shots ≤ 25¢ </a:t>
-            </a:r>
-            <a:r>
-              <a:rPr sz="1800" b="1" i="0">
-                <a:solidFill>
-                  <a:srgbClr val="0F172A"/>
-                </a:solidFill>
-                <a:latin typeface="Arial"/>
-              </a:rPr>
-              <a:t>−13.4%</a:t>
-            </a:r>
-            <a:r>
-              <a:rPr sz="1800" b="0" i="0">
-                <a:solidFill>
-                  <a:srgbClr val="0F172A"/>
-                </a:solidFill>
-                <a:latin typeface="Arial"/>
-              </a:rPr>
-              <a:t>, heavy favourites ≥ 75¢ −2.2%</a:t>
-            </a:r>
-          </a:p>
-        </p:txBody>
-      </p:sp>
-    </p:spTree>
-  </p:cSld>
-  <p:clrMapOvr>
-    <a:masterClrMapping/>
-  </p:clrMapOvr>
-</p:sld>
-</file>
-
-<file path=ppt/slides/slide9.xml><?xml version="1.0" encoding="utf-8"?>
-<p:sld xmlns:a="http://schemas.openxmlformats.org/drawingml/2006/main" xmlns:p="http://schemas.openxmlformats.org/presentationml/2006/main" xmlns:r="http://schemas.openxmlformats.org/officeDocument/2006/relationships">
-  <p:cSld>
-    <p:spTree>
-      <p:nvGrpSpPr>
-        <p:cNvPr id="1" name=""/>
-        <p:cNvGrpSpPr/>
-        <p:nvPr/>
-      </p:nvGrpSpPr>
-      <p:grpSpPr/>
-      <p:sp>
-        <p:nvSpPr>
-          <p:cNvPr id="2" name="Rectangle 1"/>
-          <p:cNvSpPr/>
-          <p:nvPr/>
-        </p:nvSpPr>
-        <p:spPr>
-          <a:xfrm>
-            <a:off x="0" y="0"/>
-            <a:ext cx="12191695" cy="868680"/>
-          </a:xfrm>
-          <a:prstGeom prst="rect">
-            <a:avLst/>
-          </a:prstGeom>
-          <a:solidFill>
-            <a:srgbClr val="1E293B"/>
-          </a:solidFill>
-          <a:ln>
-            <a:noFill/>
-          </a:ln>
-          <a:effectLst/>
-        </p:spPr>
-        <p:style>
-          <a:lnRef idx="1">
-            <a:schemeClr val="accent1"/>
-          </a:lnRef>
-          <a:fillRef idx="3">
-            <a:schemeClr val="accent1"/>
-          </a:fillRef>
-          <a:effectRef idx="2">
-            <a:schemeClr val="accent1"/>
-          </a:effectRef>
-          <a:fontRef idx="minor">
-            <a:schemeClr val="lt1"/>
-          </a:fontRef>
-        </p:style>
-        <p:txBody>
-          <a:bodyPr rtlCol="0" anchor="ctr"/>
-          <a:lstStyle/>
-          <a:p>
-            <a:pPr algn="ctr"/>
-          </a:p>
-        </p:txBody>
-      </p:sp>
-      <p:sp>
-        <p:nvSpPr>
-          <p:cNvPr id="3" name="Rectangle 2"/>
-          <p:cNvSpPr/>
-          <p:nvPr/>
-        </p:nvSpPr>
-        <p:spPr>
-          <a:xfrm>
-            <a:off x="0" y="868680"/>
-            <a:ext cx="12191695" cy="54864"/>
-          </a:xfrm>
-          <a:prstGeom prst="rect">
-            <a:avLst/>
-          </a:prstGeom>
-          <a:solidFill>
-            <a:srgbClr val="EA580C"/>
-          </a:solidFill>
-          <a:ln>
-            <a:noFill/>
-          </a:ln>
-          <a:effectLst/>
-        </p:spPr>
-        <p:style>
-          <a:lnRef idx="1">
-            <a:schemeClr val="accent1"/>
-          </a:lnRef>
-          <a:fillRef idx="3">
-            <a:schemeClr val="accent1"/>
-          </a:fillRef>
-          <a:effectRef idx="2">
-            <a:schemeClr val="accent1"/>
-          </a:effectRef>
-          <a:fontRef idx="minor">
-            <a:schemeClr val="lt1"/>
-          </a:fontRef>
-        </p:style>
-        <p:txBody>
-          <a:bodyPr rtlCol="0" anchor="ctr"/>
-          <a:lstStyle/>
-          <a:p>
-            <a:pPr algn="ctr"/>
-          </a:p>
-        </p:txBody>
-      </p:sp>
-      <p:sp>
-        <p:nvSpPr>
-          <p:cNvPr id="4" name="TextBox 3"/>
-          <p:cNvSpPr txBox="1"/>
-          <p:nvPr/>
-        </p:nvSpPr>
-        <p:spPr>
-          <a:xfrm>
-            <a:off x="457200" y="109728"/>
-            <a:ext cx="11277295" cy="685800"/>
-          </a:xfrm>
-          <a:prstGeom prst="rect">
-            <a:avLst/>
-          </a:prstGeom>
-          <a:noFill/>
-        </p:spPr>
-        <p:txBody>
-          <a:bodyPr wrap="square" anchor="ctr" lIns="73152" rIns="73152" tIns="36576" bIns="36576">
-            <a:spAutoFit/>
-          </a:bodyPr>
-          <a:lstStyle/>
-          <a:p>
-            <a:pPr algn="l">
-              <a:spcAft>
-                <a:spcPts val="0"/>
-              </a:spcAft>
-            </a:pPr>
-            <a:r>
-              <a:rPr sz="3000" b="1" i="0">
-                <a:solidFill>
-                  <a:srgbClr val="FFFFFF"/>
-                </a:solidFill>
-                <a:latin typeface="Arial"/>
-              </a:rPr>
-              <a:t>Evidence 5: not trading beat every strategy</a:t>
-            </a:r>
-          </a:p>
-        </p:txBody>
-      </p:sp>
-      <p:sp>
-        <p:nvSpPr>
-          <p:cNvPr id="5" name="TextBox 4"/>
-          <p:cNvSpPr txBox="1"/>
-          <p:nvPr/>
-        </p:nvSpPr>
-        <p:spPr>
-          <a:xfrm>
-            <a:off x="457200" y="6446520"/>
-            <a:ext cx="9144000" cy="320040"/>
-          </a:xfrm>
-          <a:prstGeom prst="rect">
-            <a:avLst/>
-          </a:prstGeom>
-          <a:noFill/>
-        </p:spPr>
-        <p:txBody>
-          <a:bodyPr wrap="square" anchor="t" lIns="73152" rIns="73152" tIns="36576" bIns="36576">
-            <a:spAutoFit/>
-          </a:bodyPr>
-          <a:lstStyle/>
-          <a:p>
-            <a:pPr algn="l">
-              <a:spcAft>
-                <a:spcPts val="0"/>
-              </a:spcAft>
-            </a:pPr>
-            <a:r>
-              <a:rPr sz="1100" b="0" i="0">
-                <a:solidFill>
-                  <a:srgbClr val="64748B"/>
-                </a:solidFill>
-                <a:latin typeface="Arial"/>
-              </a:rPr>
-              <a:t>DASC7606C Group 12 · Can a consumer beat a sports prediction market?</a:t>
-            </a:r>
-          </a:p>
-        </p:txBody>
-      </p:sp>
-      <p:sp>
-        <p:nvSpPr>
-          <p:cNvPr id="6" name="TextBox 5"/>
-          <p:cNvSpPr txBox="1"/>
-          <p:nvPr/>
-        </p:nvSpPr>
-        <p:spPr>
-          <a:xfrm>
-            <a:off x="10820095" y="6446520"/>
-            <a:ext cx="914400" cy="320040"/>
-          </a:xfrm>
-          <a:prstGeom prst="rect">
-            <a:avLst/>
-          </a:prstGeom>
-          <a:noFill/>
-        </p:spPr>
-        <p:txBody>
-          <a:bodyPr wrap="square" anchor="t" lIns="73152" rIns="73152" tIns="36576" bIns="36576">
-            <a:spAutoFit/>
-          </a:bodyPr>
-          <a:lstStyle/>
-          <a:p>
-            <a:pPr algn="r">
-              <a:spcAft>
-                <a:spcPts val="0"/>
-              </a:spcAft>
-            </a:pPr>
-            <a:r>
-              <a:rPr sz="1100" b="0" i="0">
-                <a:solidFill>
-                  <a:srgbClr val="64748B"/>
-                </a:solidFill>
-                <a:latin typeface="Arial"/>
-              </a:rPr>
-              <a:t>9</a:t>
-            </a:r>
-          </a:p>
-        </p:txBody>
-      </p:sp>
-      <p:pic>
-        <p:nvPicPr>
-          <p:cNvPr id="7" name="Picture 6" descr="headline_clv.png"/>
-          <p:cNvPicPr>
-            <a:picLocks noChangeAspect="1"/>
-          </p:cNvPicPr>
-          <p:nvPr/>
-        </p:nvPicPr>
-        <p:blipFill>
-          <a:blip r:embed="rId3"/>
-          <a:stretch>
-            <a:fillRect/>
-          </a:stretch>
-        </p:blipFill>
-        <p:spPr>
-          <a:xfrm>
-            <a:off x="457200" y="1171575"/>
-            <a:ext cx="5669280" cy="3188970"/>
+            <a:off x="457200" y="1188719"/>
+            <a:ext cx="5943600" cy="3429000"/>
           </a:xfrm>
           <a:prstGeom prst="rect">
             <a:avLst/>
@@ -11910,8 +11545,8 @@
           <p:nvPr/>
         </p:nvGraphicFramePr>
         <p:xfrm>
-          <a:off x="6355080" y="1188720"/>
-          <a:ext cx="5376672" cy="3108960"/>
+          <a:off x="6537960" y="1188720"/>
+          <a:ext cx="5193791" cy="2871216"/>
         </p:xfrm>
         <a:graphic>
           <a:graphicData uri="http://schemas.openxmlformats.org/drawingml/2006/table">
@@ -11920,9 +11555,9 @@
                 <a:tableStyleId>{5C22544A-7EE6-4342-B048-85BDC9FD1C3A}</a:tableStyleId>
               </a:tblPr>
               <a:tblGrid>
-                <a:gridCol w="2926080"/>
-                <a:gridCol w="914400"/>
-                <a:gridCol w="1536192"/>
+                <a:gridCol w="1874519"/>
+                <a:gridCol w="868680"/>
+                <a:gridCol w="2450592"/>
               </a:tblGrid>
               <a:tr h="457200">
                 <a:tc>
@@ -11938,7 +11573,7 @@
                           </a:solidFill>
                           <a:latin typeface="Arial"/>
                         </a:rPr>
-                        <a:t>Strategy</a:t>
+                        <a:t>Nov – 12 Apr</a:t>
                       </a:r>
                     </a:p>
                   </a:txBody>
@@ -11984,7 +11619,7 @@
                           </a:solidFill>
                           <a:latin typeface="Arial"/>
                         </a:rPr>
-                        <a:t>P&amp;L</a:t>
+                        <a:t>P&amp;L [95% CI]</a:t>
                       </a:r>
                     </a:p>
                   </a:txBody>
@@ -11995,7 +11630,7 @@
                   </a:tcPr>
                 </a:tc>
               </a:tr>
-              <a:tr h="530352">
+              <a:tr h="603504">
                 <a:tc>
                   <a:txBody>
                     <a:bodyPr wrap="square"/>
@@ -12003,7 +11638,7 @@
                     <a:p>
                       <a:pPr algn="l"/>
                       <a:r>
-                        <a:rPr sz="1600" b="0" i="0">
+                        <a:rPr sz="1600" b="1" i="0">
                           <a:solidFill>
                             <a:srgbClr val="0F172A"/>
                           </a:solidFill>
@@ -12066,7 +11701,7 @@
                   </a:tcPr>
                 </a:tc>
               </a:tr>
-              <a:tr h="530352">
+              <a:tr h="603504">
                 <a:tc>
                   <a:txBody>
                     <a:bodyPr wrap="square"/>
@@ -12080,7 +11715,7 @@
                           </a:solidFill>
                           <a:latin typeface="Arial"/>
                         </a:rPr>
-                        <a:t>Full agent (anchor + learning)</a:t>
+                        <a:t>Full agent</a:t>
                       </a:r>
                     </a:p>
                   </a:txBody>
@@ -12103,7 +11738,7 @@
                           </a:solidFill>
                           <a:latin typeface="Arial"/>
                         </a:rPr>
-                        <a:t>74</a:t>
+                        <a:t>157</a:t>
                       </a:r>
                     </a:p>
                   </a:txBody>
@@ -12126,7 +11761,7 @@
                           </a:solidFill>
                           <a:latin typeface="Arial"/>
                         </a:rPr>
-                        <a:t>−$32</a:t>
+                        <a:t>−$25 [−$569 to +$564]</a:t>
                       </a:r>
                     </a:p>
                   </a:txBody>
@@ -12137,7 +11772,7 @@
                   </a:tcPr>
                 </a:tc>
               </a:tr>
-              <a:tr h="530352">
+              <a:tr h="603504">
                 <a:tc>
                   <a:txBody>
                     <a:bodyPr wrap="square"/>
@@ -12151,7 +11786,7 @@
                           </a:solidFill>
                           <a:latin typeface="Arial"/>
                         </a:rPr>
-                        <a:t>Anchor, no learning</a:t>
+                        <a:t>No learning</a:t>
                       </a:r>
                     </a:p>
                   </a:txBody>
@@ -12174,7 +11809,7 @@
                           </a:solidFill>
                           <a:latin typeface="Arial"/>
                         </a:rPr>
-                        <a:t>129</a:t>
+                        <a:t>276</a:t>
                       </a:r>
                     </a:p>
                   </a:txBody>
@@ -12197,7 +11832,7 @@
                           </a:solidFill>
                           <a:latin typeface="Arial"/>
                         </a:rPr>
-                        <a:t>−$247</a:t>
+                        <a:t>−$407 [−$1,324 to +$553]</a:t>
                       </a:r>
                     </a:p>
                   </a:txBody>
@@ -12208,7 +11843,7 @@
                   </a:tcPr>
                 </a:tc>
               </a:tr>
-              <a:tr h="530352">
+              <a:tr h="603504">
                 <a:tc>
                   <a:txBody>
                     <a:bodyPr wrap="square"/>
@@ -12222,7 +11857,7 @@
                           </a:solidFill>
                           <a:latin typeface="Arial"/>
                         </a:rPr>
-                        <a:t>Raw model / no agent</a:t>
+                        <a:t>Raw model</a:t>
                       </a:r>
                     </a:p>
                   </a:txBody>
@@ -12245,7 +11880,7 @@
                           </a:solidFill>
                           <a:latin typeface="Arial"/>
                         </a:rPr>
-                        <a:t>366</a:t>
+                        <a:t>711</a:t>
                       </a:r>
                     </a:p>
                   </a:txBody>
@@ -12268,7 +11903,7 @@
                           </a:solidFill>
                           <a:latin typeface="Arial"/>
                         </a:rPr>
-                        <a:t>−$2,087</a:t>
+                        <a:t>−$2,475 [−$3,995 to −$845]</a:t>
                       </a:r>
                     </a:p>
                   </a:txBody>
@@ -12279,77 +11914,6 @@
                   </a:tcPr>
                 </a:tc>
               </a:tr>
-              <a:tr h="530352">
-                <a:tc>
-                  <a:txBody>
-                    <a:bodyPr wrap="square"/>
-                    <a:lstStyle/>
-                    <a:p>
-                      <a:pPr algn="l"/>
-                      <a:r>
-                        <a:rPr sz="1600" b="0" i="0">
-                          <a:solidFill>
-                            <a:srgbClr val="0F172A"/>
-                          </a:solidFill>
-                          <a:latin typeface="Arial"/>
-                        </a:rPr>
-                        <a:t>Buy every contract (all 2025-26)</a:t>
-                      </a:r>
-                    </a:p>
-                  </a:txBody>
-                  <a:tcPr marL="73152" marR="73152" marT="36576" marB="36576" anchor="ctr">
-                    <a:solidFill>
-                      <a:srgbClr val="F1F5F9"/>
-                    </a:solidFill>
-                  </a:tcPr>
-                </a:tc>
-                <a:tc>
-                  <a:txBody>
-                    <a:bodyPr wrap="square"/>
-                    <a:lstStyle/>
-                    <a:p>
-                      <a:pPr algn="ctr"/>
-                      <a:r>
-                        <a:rPr sz="1600" b="0" i="0">
-                          <a:solidFill>
-                            <a:srgbClr val="0F172A"/>
-                          </a:solidFill>
-                          <a:latin typeface="Arial"/>
-                        </a:rPr>
-                        <a:t>2,632</a:t>
-                      </a:r>
-                    </a:p>
-                  </a:txBody>
-                  <a:tcPr marL="73152" marR="73152" marT="36576" marB="36576" anchor="ctr">
-                    <a:solidFill>
-                      <a:srgbClr val="F1F5F9"/>
-                    </a:solidFill>
-                  </a:tcPr>
-                </a:tc>
-                <a:tc>
-                  <a:txBody>
-                    <a:bodyPr wrap="square"/>
-                    <a:lstStyle/>
-                    <a:p>
-                      <a:pPr algn="ctr"/>
-                      <a:r>
-                        <a:rPr sz="1600" b="0" i="0">
-                          <a:solidFill>
-                            <a:srgbClr val="0F172A"/>
-                          </a:solidFill>
-                          <a:latin typeface="Arial"/>
-                        </a:rPr>
-                        <a:t>−6.0% ROI</a:t>
-                      </a:r>
-                    </a:p>
-                  </a:txBody>
-                  <a:tcPr marL="73152" marR="73152" marT="36576" marB="36576" anchor="ctr">
-                    <a:solidFill>
-                      <a:srgbClr val="F1F5F9"/>
-                    </a:solidFill>
-                  </a:tcPr>
-                </a:tc>
-              </a:tr>
             </a:tbl>
           </a:graphicData>
         </a:graphic>
@@ -12362,8 +11926,8 @@
         </p:nvSpPr>
         <p:spPr>
           <a:xfrm>
-            <a:off x="457200" y="4572000"/>
-            <a:ext cx="11277295" cy="1737360"/>
+            <a:off x="6537960" y="4114800"/>
+            <a:ext cx="5196535" cy="640080"/>
           </a:xfrm>
           <a:prstGeom prst="rect">
             <a:avLst/>
@@ -12376,9 +11940,48 @@
           </a:bodyPr>
           <a:lstStyle/>
           <a:p>
+            <a:pPr algn="l">
+              <a:spcAft>
+                <a:spcPts val="800"/>
+              </a:spcAft>
+            </a:pPr>
+            <a:r>
+              <a:rPr sz="1400" b="0" i="0">
+                <a:solidFill>
+                  <a:srgbClr val="64748B"/>
+                </a:solidFill>
+                <a:latin typeface="Arial"/>
+              </a:rPr>
+              <a:t>Day-clustered bootstrap; M4 retrained monthly. Chart totals include play-offs, the table does not</a:t>
+            </a:r>
+          </a:p>
+        </p:txBody>
+      </p:sp>
+      <p:sp>
+        <p:nvSpPr>
+          <p:cNvPr id="10" name="TextBox 9"/>
+          <p:cNvSpPr txBox="1"/>
+          <p:nvPr/>
+        </p:nvSpPr>
+        <p:spPr>
+          <a:xfrm>
+            <a:off x="457200" y="4663440"/>
+            <a:ext cx="11277295" cy="1691640"/>
+          </a:xfrm>
+          <a:prstGeom prst="rect">
+            <a:avLst/>
+          </a:prstGeom>
+          <a:noFill/>
+        </p:spPr>
+        <p:txBody>
+          <a:bodyPr wrap="square" anchor="t" lIns="73152" rIns="73152" tIns="36576" bIns="36576">
+            <a:spAutoFit/>
+          </a:bodyPr>
+          <a:lstStyle/>
+          <a:p>
             <a:pPr algn="l" marL="292608" indent="-256032">
               <a:spcAft>
-                <a:spcPts val="600"/>
+                <a:spcPts val="400"/>
               </a:spcAft>
               <a:buChar char="•"/>
             </a:pPr>
@@ -12389,7 +11992,7 @@
                 </a:solidFill>
                 <a:latin typeface="Arial"/>
               </a:rPr>
-              <a:t>Agent rows: test period, 1 Feb – 12 Apr 2026; mean closing-line value </a:t>
+              <a:t>Mean CLV &lt; 0 for every setup; </a:t>
             </a:r>
             <a:r>
               <a:rPr sz="1800" b="1" i="0">
@@ -12398,13 +12001,13 @@
                 </a:solidFill>
                 <a:latin typeface="Arial"/>
               </a:rPr>
-              <a:t>negative in every setup</a:t>
+              <a:t>every 95% CI entirely below zero</a:t>
             </a:r>
           </a:p>
           <a:p>
             <a:pPr algn="l" marL="292608" indent="-256032">
               <a:spcAft>
-                <a:spcPts val="600"/>
+                <a:spcPts val="400"/>
               </a:spcAft>
               <a:buChar char="•"/>
             </a:pPr>
@@ -12415,13 +12018,13 @@
                 </a:solidFill>
                 <a:latin typeface="Arial"/>
               </a:rPr>
-              <a:t>Interpretation: trading on a disagreement with the price looks like the raw-model row</a:t>
+              <a:t>Market anchor is real: +$2,450 vs raw model (p = 0.002); learning = trading less (p = 0.13)</a:t>
             </a:r>
           </a:p>
           <a:p>
             <a:pPr algn="l" marL="292608" indent="-256032">
               <a:spcAft>
-                <a:spcPts val="600"/>
+                <a:spcPts val="400"/>
               </a:spcAft>
               <a:buChar char="•"/>
             </a:pPr>
@@ -12432,7 +12035,338 @@
                 </a:solidFill>
                 <a:latin typeface="Arial"/>
               </a:rPr>
-              <a:t>“Buy every contract” covers all 1,316 games of 2025-26 (it includes luck)</a:t>
+              <a:t>Play-off holdout (87 games): full agent 0 trades; no learning 6 trades, −$74; raw model +$450 with negative CLV (luck)</a:t>
+            </a:r>
+          </a:p>
+        </p:txBody>
+      </p:sp>
+    </p:spTree>
+  </p:cSld>
+  <p:clrMapOvr>
+    <a:masterClrMapping/>
+  </p:clrMapOvr>
+</p:sld>
+</file>
+
+<file path=ppt/slides/slide9.xml><?xml version="1.0" encoding="utf-8"?>
+<p:sld xmlns:a="http://schemas.openxmlformats.org/drawingml/2006/main" xmlns:p="http://schemas.openxmlformats.org/presentationml/2006/main" xmlns:r="http://schemas.openxmlformats.org/officeDocument/2006/relationships">
+  <p:cSld>
+    <p:spTree>
+      <p:nvGrpSpPr>
+        <p:cNvPr id="1" name=""/>
+        <p:cNvGrpSpPr/>
+        <p:nvPr/>
+      </p:nvGrpSpPr>
+      <p:grpSpPr/>
+      <p:sp>
+        <p:nvSpPr>
+          <p:cNvPr id="2" name="Rectangle 1"/>
+          <p:cNvSpPr/>
+          <p:nvPr/>
+        </p:nvSpPr>
+        <p:spPr>
+          <a:xfrm>
+            <a:off x="0" y="0"/>
+            <a:ext cx="12191695" cy="868680"/>
+          </a:xfrm>
+          <a:prstGeom prst="rect">
+            <a:avLst/>
+          </a:prstGeom>
+          <a:solidFill>
+            <a:srgbClr val="1E293B"/>
+          </a:solidFill>
+          <a:ln>
+            <a:noFill/>
+          </a:ln>
+          <a:effectLst/>
+        </p:spPr>
+        <p:style>
+          <a:lnRef idx="1">
+            <a:schemeClr val="accent1"/>
+          </a:lnRef>
+          <a:fillRef idx="3">
+            <a:schemeClr val="accent1"/>
+          </a:fillRef>
+          <a:effectRef idx="2">
+            <a:schemeClr val="accent1"/>
+          </a:effectRef>
+          <a:fontRef idx="minor">
+            <a:schemeClr val="lt1"/>
+          </a:fontRef>
+        </p:style>
+        <p:txBody>
+          <a:bodyPr rtlCol="0" anchor="ctr"/>
+          <a:lstStyle/>
+          <a:p>
+            <a:pPr algn="ctr"/>
+          </a:p>
+        </p:txBody>
+      </p:sp>
+      <p:sp>
+        <p:nvSpPr>
+          <p:cNvPr id="3" name="Rectangle 2"/>
+          <p:cNvSpPr/>
+          <p:nvPr/>
+        </p:nvSpPr>
+        <p:spPr>
+          <a:xfrm>
+            <a:off x="0" y="868680"/>
+            <a:ext cx="12191695" cy="54864"/>
+          </a:xfrm>
+          <a:prstGeom prst="rect">
+            <a:avLst/>
+          </a:prstGeom>
+          <a:solidFill>
+            <a:srgbClr val="EA580C"/>
+          </a:solidFill>
+          <a:ln>
+            <a:noFill/>
+          </a:ln>
+          <a:effectLst/>
+        </p:spPr>
+        <p:style>
+          <a:lnRef idx="1">
+            <a:schemeClr val="accent1"/>
+          </a:lnRef>
+          <a:fillRef idx="3">
+            <a:schemeClr val="accent1"/>
+          </a:fillRef>
+          <a:effectRef idx="2">
+            <a:schemeClr val="accent1"/>
+          </a:effectRef>
+          <a:fontRef idx="minor">
+            <a:schemeClr val="lt1"/>
+          </a:fontRef>
+        </p:style>
+        <p:txBody>
+          <a:bodyPr rtlCol="0" anchor="ctr"/>
+          <a:lstStyle/>
+          <a:p>
+            <a:pPr algn="ctr"/>
+          </a:p>
+        </p:txBody>
+      </p:sp>
+      <p:sp>
+        <p:nvSpPr>
+          <p:cNvPr id="4" name="TextBox 3"/>
+          <p:cNvSpPr txBox="1"/>
+          <p:nvPr/>
+        </p:nvSpPr>
+        <p:spPr>
+          <a:xfrm>
+            <a:off x="457200" y="109728"/>
+            <a:ext cx="11277295" cy="685800"/>
+          </a:xfrm>
+          <a:prstGeom prst="rect">
+            <a:avLst/>
+          </a:prstGeom>
+          <a:noFill/>
+        </p:spPr>
+        <p:txBody>
+          <a:bodyPr wrap="square" anchor="ctr" lIns="73152" rIns="73152" tIns="36576" bIns="36576">
+            <a:spAutoFit/>
+          </a:bodyPr>
+          <a:lstStyle/>
+          <a:p>
+            <a:pPr algn="l">
+              <a:spcAft>
+                <a:spcPts val="0"/>
+              </a:spcAft>
+            </a:pPr>
+            <a:r>
+              <a:rPr sz="3000" b="1" i="0">
+                <a:solidFill>
+                  <a:srgbClr val="FFFFFF"/>
+                </a:solidFill>
+                <a:latin typeface="Arial"/>
+              </a:rPr>
+              <a:t>Long shots: where the data is weaker</a:t>
+            </a:r>
+          </a:p>
+        </p:txBody>
+      </p:sp>
+      <p:sp>
+        <p:nvSpPr>
+          <p:cNvPr id="5" name="TextBox 4"/>
+          <p:cNvSpPr txBox="1"/>
+          <p:nvPr/>
+        </p:nvSpPr>
+        <p:spPr>
+          <a:xfrm>
+            <a:off x="457200" y="6446520"/>
+            <a:ext cx="9144000" cy="320040"/>
+          </a:xfrm>
+          <a:prstGeom prst="rect">
+            <a:avLst/>
+          </a:prstGeom>
+          <a:noFill/>
+        </p:spPr>
+        <p:txBody>
+          <a:bodyPr wrap="square" anchor="t" lIns="73152" rIns="73152" tIns="36576" bIns="36576">
+            <a:spAutoFit/>
+          </a:bodyPr>
+          <a:lstStyle/>
+          <a:p>
+            <a:pPr algn="l">
+              <a:spcAft>
+                <a:spcPts val="0"/>
+              </a:spcAft>
+            </a:pPr>
+            <a:r>
+              <a:rPr sz="1100" b="0" i="0">
+                <a:solidFill>
+                  <a:srgbClr val="64748B"/>
+                </a:solidFill>
+                <a:latin typeface="Arial"/>
+              </a:rPr>
+              <a:t>DASC7606C Group 12 · Can a consumer beat a sports prediction market?</a:t>
+            </a:r>
+          </a:p>
+        </p:txBody>
+      </p:sp>
+      <p:sp>
+        <p:nvSpPr>
+          <p:cNvPr id="6" name="TextBox 5"/>
+          <p:cNvSpPr txBox="1"/>
+          <p:nvPr/>
+        </p:nvSpPr>
+        <p:spPr>
+          <a:xfrm>
+            <a:off x="10820095" y="6446520"/>
+            <a:ext cx="914400" cy="320040"/>
+          </a:xfrm>
+          <a:prstGeom prst="rect">
+            <a:avLst/>
+          </a:prstGeom>
+          <a:noFill/>
+        </p:spPr>
+        <p:txBody>
+          <a:bodyPr wrap="square" anchor="t" lIns="73152" rIns="73152" tIns="36576" bIns="36576">
+            <a:spAutoFit/>
+          </a:bodyPr>
+          <a:lstStyle/>
+          <a:p>
+            <a:pPr algn="r">
+              <a:spcAft>
+                <a:spcPts val="0"/>
+              </a:spcAft>
+            </a:pPr>
+            <a:r>
+              <a:rPr sz="1100" b="0" i="0">
+                <a:solidFill>
+                  <a:srgbClr val="64748B"/>
+                </a:solidFill>
+                <a:latin typeface="Arial"/>
+              </a:rPr>
+              <a:t>9</a:t>
+            </a:r>
+          </a:p>
+        </p:txBody>
+      </p:sp>
+      <p:pic>
+        <p:nvPicPr>
+          <p:cNvPr id="7" name="Picture 6" descr="longshot_calibration.png"/>
+          <p:cNvPicPr>
+            <a:picLocks noChangeAspect="1"/>
+          </p:cNvPicPr>
+          <p:nvPr/>
+        </p:nvPicPr>
+        <p:blipFill>
+          <a:blip r:embed="rId3"/>
+          <a:stretch>
+            <a:fillRect/>
+          </a:stretch>
+        </p:blipFill>
+        <p:spPr>
+          <a:xfrm>
+            <a:off x="895197" y="1097280"/>
+            <a:ext cx="10401299" cy="4160520"/>
+          </a:xfrm>
+          <a:prstGeom prst="rect">
+            <a:avLst/>
+          </a:prstGeom>
+        </p:spPr>
+      </p:pic>
+      <p:sp>
+        <p:nvSpPr>
+          <p:cNvPr id="8" name="TextBox 7"/>
+          <p:cNvSpPr txBox="1"/>
+          <p:nvPr/>
+        </p:nvSpPr>
+        <p:spPr>
+          <a:xfrm>
+            <a:off x="457200" y="5349240"/>
+            <a:ext cx="11277295" cy="1005840"/>
+          </a:xfrm>
+          <a:prstGeom prst="rect">
+            <a:avLst/>
+          </a:prstGeom>
+          <a:noFill/>
+        </p:spPr>
+        <p:txBody>
+          <a:bodyPr wrap="square" anchor="t" lIns="73152" rIns="73152" tIns="36576" bIns="36576">
+            <a:spAutoFit/>
+          </a:bodyPr>
+          <a:lstStyle/>
+          <a:p>
+            <a:pPr algn="l" marL="292608" indent="-256032">
+              <a:spcAft>
+                <a:spcPts val="400"/>
+              </a:spcAft>
+              <a:buChar char="•"/>
+            </a:pPr>
+            <a:r>
+              <a:rPr sz="1800" b="1" i="0">
+                <a:solidFill>
+                  <a:srgbClr val="0F172A"/>
+                </a:solidFill>
+                <a:latin typeface="Arial"/>
+              </a:rPr>
+              <a:t>Not clearly supported:</a:t>
+            </a:r>
+            <a:r>
+              <a:rPr sz="1800" b="0" i="0">
+                <a:solidFill>
+                  <a:srgbClr val="0F172A"/>
+                </a:solidFill>
+                <a:latin typeface="Arial"/>
+              </a:rPr>
+              <a:t> prices are calibrated; only 0–10¢ hints (1 win in 66 vs 7.4% implied, z = −1.8)</a:t>
+            </a:r>
+          </a:p>
+          <a:p>
+            <a:pPr algn="l" marL="292608" indent="-256032">
+              <a:spcAft>
+                <a:spcPts val="400"/>
+              </a:spcAft>
+              <a:buChar char="•"/>
+            </a:pPr>
+            <a:r>
+              <a:rPr sz="1800" b="0" i="0">
+                <a:solidFill>
+                  <a:srgbClr val="0F172A"/>
+                </a:solidFill>
+                <a:latin typeface="Arial"/>
+              </a:rPr>
+              <a:t>Buying at ask + fee: long shots ≤ 25¢ </a:t>
+            </a:r>
+            <a:r>
+              <a:rPr sz="1800" b="1" i="0">
+                <a:solidFill>
+                  <a:srgbClr val="0F172A"/>
+                </a:solidFill>
+                <a:latin typeface="Arial"/>
+              </a:rPr>
+              <a:t>−13.4%</a:t>
+            </a:r>
+            <a:r>
+              <a:rPr sz="1800" b="0" i="0">
+                <a:solidFill>
+                  <a:srgbClr val="0F172A"/>
+                </a:solidFill>
+                <a:latin typeface="Arial"/>
+              </a:rPr>
+              <a:t>, heavy favourites ≥ 75¢ −2.2%</a:t>
             </a:r>
           </a:p>
         </p:txBody>

</xml_diff>

<commit_message>
Deck: add the orchestrator diagram to the agentic-upgrades slide
Co-authored-by: Cursor <cursoragent@cursor.com>
</commit_message>
<xml_diff>
--- a/presentation/nba_agent_deck.pptx
+++ b/presentation/nba_agent_deck.pptx
@@ -5684,7 +5684,7 @@
         </p:nvGraphicFramePr>
         <p:xfrm>
           <a:off x="457200" y="1143000"/>
-          <a:ext cx="11277295" cy="4892040"/>
+          <a:ext cx="7818120" cy="4892040"/>
         </p:xfrm>
         <a:graphic>
           <a:graphicData uri="http://schemas.openxmlformats.org/drawingml/2006/table">
@@ -5693,9 +5693,9 @@
                 <a:tableStyleId>{5C22544A-7EE6-4342-B048-85BDC9FD1C3A}</a:tableStyleId>
               </a:tblPr>
               <a:tblGrid>
-                <a:gridCol w="2651760"/>
-                <a:gridCol w="5120640"/>
-                <a:gridCol w="3504895"/>
+                <a:gridCol w="2148840"/>
+                <a:gridCol w="3429000"/>
+                <a:gridCol w="2240280"/>
               </a:tblGrid>
               <a:tr h="365760">
                 <a:tc>
@@ -5705,7 +5705,7 @@
                     <a:p>
                       <a:pPr algn="l"/>
                       <a:r>
-                        <a:rPr sz="1300" b="1" i="0">
+                        <a:rPr sz="1200" b="1" i="0">
                           <a:solidFill>
                             <a:srgbClr val="FFFFFF"/>
                           </a:solidFill>
@@ -5728,7 +5728,7 @@
                     <a:p>
                       <a:pPr algn="l"/>
                       <a:r>
-                        <a:rPr sz="1300" b="1" i="0">
+                        <a:rPr sz="1200" b="1" i="0">
                           <a:solidFill>
                             <a:srgbClr val="FFFFFF"/>
                           </a:solidFill>
@@ -5751,7 +5751,7 @@
                     <a:p>
                       <a:pPr algn="l"/>
                       <a:r>
-                        <a:rPr sz="1300" b="1" i="0">
+                        <a:rPr sz="1200" b="1" i="0">
                           <a:solidFill>
                             <a:srgbClr val="FFFFFF"/>
                           </a:solidFill>
@@ -5776,7 +5776,7 @@
                     <a:p>
                       <a:pPr algn="l"/>
                       <a:r>
-                        <a:rPr sz="1300" b="1" i="0">
+                        <a:rPr sz="1200" b="1" i="0">
                           <a:solidFill>
                             <a:srgbClr val="0F172A"/>
                           </a:solidFill>
@@ -5799,7 +5799,7 @@
                     <a:p>
                       <a:pPr algn="l"/>
                       <a:r>
-                        <a:rPr sz="1300" b="0" i="0">
+                        <a:rPr sz="1200" b="0" i="0">
                           <a:solidFill>
                             <a:srgbClr val="0F172A"/>
                           </a:solidFill>
@@ -5822,7 +5822,7 @@
                     <a:p>
                       <a:pPr algn="l"/>
                       <a:r>
-                        <a:rPr sz="1300" b="0" i="1">
+                        <a:rPr sz="1200" b="0" i="1">
                           <a:solidFill>
                             <a:srgbClr val="64748B"/>
                           </a:solidFill>
@@ -5847,7 +5847,7 @@
                     <a:p>
                       <a:pPr algn="l"/>
                       <a:r>
-                        <a:rPr sz="1300" b="1" i="0">
+                        <a:rPr sz="1200" b="1" i="0">
                           <a:solidFill>
                             <a:srgbClr val="0F172A"/>
                           </a:solidFill>
@@ -5870,7 +5870,7 @@
                     <a:p>
                       <a:pPr algn="l"/>
                       <a:r>
-                        <a:rPr sz="1300" b="0" i="0">
+                        <a:rPr sz="1200" b="0" i="0">
                           <a:solidFill>
                             <a:srgbClr val="0F172A"/>
                           </a:solidFill>
@@ -5893,7 +5893,7 @@
                     <a:p>
                       <a:pPr algn="l"/>
                       <a:r>
-                        <a:rPr sz="1300" b="0" i="1">
+                        <a:rPr sz="1200" b="0" i="1">
                           <a:solidFill>
                             <a:srgbClr val="64748B"/>
                           </a:solidFill>
@@ -5918,7 +5918,7 @@
                     <a:p>
                       <a:pPr algn="l"/>
                       <a:r>
-                        <a:rPr sz="1300" b="1" i="0">
+                        <a:rPr sz="1200" b="1" i="0">
                           <a:solidFill>
                             <a:srgbClr val="0F172A"/>
                           </a:solidFill>
@@ -5941,7 +5941,7 @@
                     <a:p>
                       <a:pPr algn="l"/>
                       <a:r>
-                        <a:rPr sz="1300" b="0" i="0">
+                        <a:rPr sz="1200" b="0" i="0">
                           <a:solidFill>
                             <a:srgbClr val="0F172A"/>
                           </a:solidFill>
@@ -5964,7 +5964,7 @@
                     <a:p>
                       <a:pPr algn="l"/>
                       <a:r>
-                        <a:rPr sz="1300" b="0" i="1">
+                        <a:rPr sz="1200" b="0" i="1">
                           <a:solidFill>
                             <a:srgbClr val="64748B"/>
                           </a:solidFill>
@@ -5989,7 +5989,7 @@
                     <a:p>
                       <a:pPr algn="l"/>
                       <a:r>
-                        <a:rPr sz="1300" b="1" i="0">
+                        <a:rPr sz="1200" b="1" i="0">
                           <a:solidFill>
                             <a:srgbClr val="0F172A"/>
                           </a:solidFill>
@@ -6012,7 +6012,7 @@
                     <a:p>
                       <a:pPr algn="l"/>
                       <a:r>
-                        <a:rPr sz="1300" b="0" i="0">
+                        <a:rPr sz="1200" b="0" i="0">
                           <a:solidFill>
                             <a:srgbClr val="0F172A"/>
                           </a:solidFill>
@@ -6035,7 +6035,7 @@
                     <a:p>
                       <a:pPr algn="l"/>
                       <a:r>
-                        <a:rPr sz="1300" b="0" i="1">
+                        <a:rPr sz="1200" b="0" i="1">
                           <a:solidFill>
                             <a:srgbClr val="64748B"/>
                           </a:solidFill>
@@ -6060,7 +6060,7 @@
                     <a:p>
                       <a:pPr algn="l"/>
                       <a:r>
-                        <a:rPr sz="1300" b="1" i="0">
+                        <a:rPr sz="1200" b="1" i="0">
                           <a:solidFill>
                             <a:srgbClr val="0F172A"/>
                           </a:solidFill>
@@ -6083,7 +6083,7 @@
                     <a:p>
                       <a:pPr algn="l"/>
                       <a:r>
-                        <a:rPr sz="1300" b="0" i="0">
+                        <a:rPr sz="1200" b="0" i="0">
                           <a:solidFill>
                             <a:srgbClr val="0F172A"/>
                           </a:solidFill>
@@ -6106,7 +6106,7 @@
                     <a:p>
                       <a:pPr algn="l"/>
                       <a:r>
-                        <a:rPr sz="1300" b="0" i="1">
+                        <a:rPr sz="1200" b="0" i="1">
                           <a:solidFill>
                             <a:srgbClr val="64748B"/>
                           </a:solidFill>
@@ -6131,7 +6131,7 @@
                     <a:p>
                       <a:pPr algn="l"/>
                       <a:r>
-                        <a:rPr sz="1300" b="1" i="0">
+                        <a:rPr sz="1200" b="1" i="0">
                           <a:solidFill>
                             <a:srgbClr val="0F172A"/>
                           </a:solidFill>
@@ -6154,7 +6154,7 @@
                     <a:p>
                       <a:pPr algn="l"/>
                       <a:r>
-                        <a:rPr sz="1300" b="0" i="0">
+                        <a:rPr sz="1200" b="0" i="0">
                           <a:solidFill>
                             <a:srgbClr val="0F172A"/>
                           </a:solidFill>
@@ -6177,7 +6177,7 @@
                     <a:p>
                       <a:pPr algn="l"/>
                       <a:r>
-                        <a:rPr sz="1300" b="0" i="1">
+                        <a:rPr sz="1200" b="0" i="1">
                           <a:solidFill>
                             <a:srgbClr val="64748B"/>
                           </a:solidFill>
@@ -6202,7 +6202,7 @@
                     <a:p>
                       <a:pPr algn="l"/>
                       <a:r>
-                        <a:rPr sz="1300" b="1" i="0">
+                        <a:rPr sz="1200" b="1" i="0">
                           <a:solidFill>
                             <a:srgbClr val="0F172A"/>
                           </a:solidFill>
@@ -6225,7 +6225,7 @@
                     <a:p>
                       <a:pPr algn="l"/>
                       <a:r>
-                        <a:rPr sz="1300" b="0" i="0">
+                        <a:rPr sz="1200" b="0" i="0">
                           <a:solidFill>
                             <a:srgbClr val="0F172A"/>
                           </a:solidFill>
@@ -6248,7 +6248,7 @@
                     <a:p>
                       <a:pPr algn="l"/>
                       <a:r>
-                        <a:rPr sz="1300" b="0" i="1">
+                        <a:rPr sz="1200" b="0" i="1">
                           <a:solidFill>
                             <a:srgbClr val="64748B"/>
                           </a:solidFill>
@@ -6273,7 +6273,7 @@
                     <a:p>
                       <a:pPr algn="l"/>
                       <a:r>
-                        <a:rPr sz="1300" b="1" i="0">
+                        <a:rPr sz="1200" b="1" i="0">
                           <a:solidFill>
                             <a:srgbClr val="0F172A"/>
                           </a:solidFill>
@@ -6296,7 +6296,7 @@
                     <a:p>
                       <a:pPr algn="l"/>
                       <a:r>
-                        <a:rPr sz="1300" b="0" i="0">
+                        <a:rPr sz="1200" b="0" i="0">
                           <a:solidFill>
                             <a:srgbClr val="0F172A"/>
                           </a:solidFill>
@@ -6319,7 +6319,7 @@
                     <a:p>
                       <a:pPr algn="l"/>
                       <a:r>
-                        <a:rPr sz="1300" b="0" i="1">
+                        <a:rPr sz="1200" b="0" i="1">
                           <a:solidFill>
                             <a:srgbClr val="64748B"/>
                           </a:solidFill>
@@ -6344,7 +6344,7 @@
                     <a:p>
                       <a:pPr algn="l"/>
                       <a:r>
-                        <a:rPr sz="1300" b="1" i="0">
+                        <a:rPr sz="1200" b="1" i="0">
                           <a:solidFill>
                             <a:srgbClr val="0F172A"/>
                           </a:solidFill>
@@ -6367,7 +6367,7 @@
                     <a:p>
                       <a:pPr algn="l"/>
                       <a:r>
-                        <a:rPr sz="1300" b="0" i="0">
+                        <a:rPr sz="1200" b="0" i="0">
                           <a:solidFill>
                             <a:srgbClr val="0F172A"/>
                           </a:solidFill>
@@ -6390,7 +6390,7 @@
                     <a:p>
                       <a:pPr algn="l"/>
                       <a:r>
-                        <a:rPr sz="1300" b="0" i="1">
+                        <a:rPr sz="1200" b="0" i="1">
                           <a:solidFill>
                             <a:srgbClr val="64748B"/>
                           </a:solidFill>
@@ -6411,9 +6411,33 @@
           </a:graphicData>
         </a:graphic>
       </p:graphicFrame>
-      <p:sp>
-        <p:nvSpPr>
-          <p:cNvPr id="8" name="TextBox 7"/>
+      <p:pic>
+        <p:nvPicPr>
+          <p:cNvPr id="8" name="Picture 7" descr="orchestrator.png"/>
+          <p:cNvPicPr>
+            <a:picLocks noChangeAspect="1"/>
+          </p:cNvPicPr>
+          <p:nvPr/>
+        </p:nvPicPr>
+        <p:blipFill>
+          <a:blip r:embed="rId3"/>
+          <a:stretch>
+            <a:fillRect/>
+          </a:stretch>
+        </p:blipFill>
+        <p:spPr>
+          <a:xfrm>
+            <a:off x="8412480" y="2702436"/>
+            <a:ext cx="3322015" cy="1727447"/>
+          </a:xfrm>
+          <a:prstGeom prst="rect">
+            <a:avLst/>
+          </a:prstGeom>
+        </p:spPr>
+      </p:pic>
+      <p:sp>
+        <p:nvSpPr>
+          <p:cNvPr id="9" name="TextBox 8"/>
           <p:cNvSpPr txBox="1"/>
           <p:nvPr/>
         </p:nvSpPr>

</xml_diff>

<commit_message>
Deck: fill the Coach simulated-user result (coach_sim.md, 20 slates x 10 decisions)
Co-authored-by: Cursor <cursoragent@cursor.com>
</commit_message>
<xml_diff>
--- a/presentation/nba_agent_deck.pptx
+++ b/presentation/nba_agent_deck.pptx
@@ -656,7 +656,7 @@
           <a:lstStyle/>
           <a:p>
             <a:r>
-              <a:t>We then made the agent more agentic, and graded each upgrade the same way, pre-registered before scoring. An LLM tool agent chooses its own as-of tools, with code checking every number and a sceptic asking whether the edge is already priced in. We audited the rule gate against placebo rules, enforced a daily kill switch, tried fractional Kelly sizing, tested the Coach on simulated users, joined pregame, trader and coach under one orchestrator, and tried a learned trade-or-pass policy, a rule language for LLM-written rules, and episodic memory. Results so far: none yet. 9 of 9 are still pending at build time.</a:t>
+              <a:t>We then made the agent more agentic, and graded each upgrade the same way, pre-registered before scoring. An LLM tool agent chooses its own as-of tools, with code checking every number and a sceptic asking whether the edge is already priced in. We audited the rule gate against placebo rules, enforced a daily kill switch, tried fractional Kelly sizing, tested the Coach on simulated users, joined pregame, trader and coach under one orchestrator, and tried a learned trade-or-pass policy, a rule language for LLM-written rules, and episodic memory. Results so far: Coach, simulated users: Users trade less, lose less CLV; per-trade CLV no better. 8 of 9 are still pending at build time.</a:t>
             </a:r>
           </a:p>
         </p:txBody>
@@ -6106,13 +6106,13 @@
                     <a:p>
                       <a:pPr algn="l"/>
                       <a:r>
-                        <a:rPr sz="1200" b="0" i="1">
+                        <a:rPr sz="1200" b="0" i="0">
                           <a:solidFill>
-                            <a:srgbClr val="64748B"/>
+                            <a:srgbClr val="0F172A"/>
                           </a:solidFill>
                           <a:latin typeface="Arial"/>
                         </a:rPr>
-                        <a:t>pending</a:t>
+                        <a:t>Users trade less, lose less CLV; per-trade CLV no better</a:t>
                       </a:r>
                     </a:p>
                   </a:txBody>

</xml_diff>

<commit_message>
Deck: fill the gate placebo result (gate_placebo.md)
Co-authored-by: Cursor <cursoragent@cursor.com>
</commit_message>
<xml_diff>
--- a/presentation/nba_agent_deck.pptx
+++ b/presentation/nba_agent_deck.pptx
@@ -656,7 +656,7 @@
           <a:lstStyle/>
           <a:p>
             <a:r>
-              <a:t>We then made the agent more agentic, and graded each upgrade the same way, pre-registered before scoring. An LLM tool agent chooses its own as-of tools, with code checking every number and a sceptic asking whether the edge is already priced in. We audited the rule gate against placebo rules, enforced a daily kill switch, tried fractional Kelly sizing, tested the Coach on simulated users, joined pregame, trader and coach under one orchestrator, and tried a learned trade-or-pass policy, a rule language for LLM-written rules, and episodic memory. Results so far: Coach, simulated users: Users trade less, lose less CLV; per-trade CLV no better. 8 of 9 are still pending at build time.</a:t>
+              <a:t>We then made the agent more agentic, and graded each upgrade the same way, pre-registered before scoring. An LLM tool agent chooses its own as-of tools, with code checking every number and a sceptic asking whether the edge is already priced in. We audited the rule gate against placebo rules, enforced a daily kill switch, tried fractional Kelly sizing, tested the Coach on simulated users, joined pregame, trader and coach under one orchestrator, and tried a learned trade-or-pass policy, a rule language for LLM-written rules, and episodic memory. Results so far: Gate audit + placebo: Random rules pass as often (57% vs 57%); Coach, simulated users: Users trade less, lose less CLV; per-trade CLV no better. 7 of 9 are still pending at build time.</a:t>
             </a:r>
           </a:p>
         </p:txBody>
@@ -5893,13 +5893,13 @@
                     <a:p>
                       <a:pPr algn="l"/>
                       <a:r>
-                        <a:rPr sz="1200" b="0" i="1">
+                        <a:rPr sz="1200" b="0" i="0">
                           <a:solidFill>
-                            <a:srgbClr val="64748B"/>
+                            <a:srgbClr val="0F172A"/>
                           </a:solidFill>
                           <a:latin typeface="Arial"/>
                         </a:rPr>
-                        <a:t>pending</a:t>
+                        <a:t>Random rules pass as often (57% vs 57%)</a:t>
                       </a:r>
                     </a:p>
                   </a:txBody>

</xml_diff>

<commit_message>
Deck: fill kill-switch (gate_audit.md) and LLM tool-agent status (llm_agent.md)
Co-authored-by: Cursor <cursoragent@cursor.com>
</commit_message>
<xml_diff>
--- a/presentation/nba_agent_deck.pptx
+++ b/presentation/nba_agent_deck.pptx
@@ -656,7 +656,7 @@
           <a:lstStyle/>
           <a:p>
             <a:r>
-              <a:t>We then made the agent more agentic, and graded each upgrade the same way, pre-registered before scoring. An LLM tool agent chooses its own as-of tools, with code checking every number and a sceptic asking whether the edge is already priced in. We audited the rule gate against placebo rules, enforced a daily kill switch, tried fractional Kelly sizing, tested the Coach on simulated users, joined pregame, trader and coach under one orchestrator, and tried a learned trade-or-pass policy, a rule language for LLM-written rules, and episodic memory. Results so far: Gate audit + placebo: Random rules pass as often (57% vs 57%); Coach, simulated users: Users trade less, lose less CLV; per-trade CLV no better. 7 of 9 are still pending at build time.</a:t>
+              <a:t>We then made the agent more agentic, and graded each upgrade the same way, pre-registered before scoring. An LLM tool agent chooses its own as-of tools, with code checking every number and a sceptic asking whether the edge is already priced in. We audited the rule gate against placebo rules, enforced a daily kill switch, tried fractional Kelly sizing, tested the Coach on simulated users, joined pregame, trader and coach under one orchestrator, and tried a learned trade-or-pass policy, a rule language for LLM-written rules, and episodic memory. Results so far: LLM tool agent + sceptic: Not scored (API quota); all 32 valid calls passed; Gate audit + placebo: Random rules pass as often (57% vs 57%); Kill switch: Never triggered (worst day −$54); Coach, simulated users: Users trade less, lose less CLV; per-trade CLV no better. 5 of 9 are still pending at build time.</a:t>
             </a:r>
           </a:p>
         </p:txBody>
@@ -5822,13 +5822,13 @@
                     <a:p>
                       <a:pPr algn="l"/>
                       <a:r>
-                        <a:rPr sz="1200" b="0" i="1">
+                        <a:rPr sz="1200" b="0" i="0">
                           <a:solidFill>
-                            <a:srgbClr val="64748B"/>
+                            <a:srgbClr val="0F172A"/>
                           </a:solidFill>
                           <a:latin typeface="Arial"/>
                         </a:rPr>
-                        <a:t>pending</a:t>
+                        <a:t>Not scored (API quota); all 32 valid calls passed</a:t>
                       </a:r>
                     </a:p>
                   </a:txBody>
@@ -5964,13 +5964,13 @@
                     <a:p>
                       <a:pPr algn="l"/>
                       <a:r>
-                        <a:rPr sz="1200" b="0" i="1">
+                        <a:rPr sz="1200" b="0" i="0">
                           <a:solidFill>
-                            <a:srgbClr val="64748B"/>
+                            <a:srgbClr val="0F172A"/>
                           </a:solidFill>
                           <a:latin typeface="Arial"/>
                         </a:rPr>
-                        <a:t>pending</a:t>
+                        <a:t>Never triggered (worst day −$54)</a:t>
                       </a:r>
                     </a:p>
                   </a:txBody>

</xml_diff>

<commit_message>
Deck: fill agentic-upgrades slide with gate audit, placebo, Coach and plain-LLM results; trade-less message; LLM tool row via K['llm_tool']
Co-authored-by: Cursor <cursoragent@cursor.com>
</commit_message>
<xml_diff>
--- a/presentation/nba_agent_deck.pptx
+++ b/presentation/nba_agent_deck.pptx
@@ -656,7 +656,7 @@
           <a:lstStyle/>
           <a:p>
             <a:r>
-              <a:t>We then made the agent more agentic, and graded each upgrade the same way, pre-registered before scoring. An LLM tool agent chooses its own as-of tools, with code checking every number and a sceptic asking whether the edge is already priced in. We audited the rule gate against placebo rules, enforced a daily kill switch, tried fractional Kelly sizing, tested the Coach on simulated users, joined pregame, trader and coach under one orchestrator, and tried a learned trade-or-pass policy, a rule language for LLM-written rules, and episodic memory. Results so far: LLM tool agent + sceptic: Not scored (API quota); all 32 valid calls passed; Gate audit + placebo: Random rules pass as often (57% vs 57%); Kill switch: Never triggered (worst day −$54); Coach, simulated users: Users trade less, lose less CLV; per-trade CLV no better. 5 of 9 are still pending at build time.</a:t>
+              <a:t>We then made the agent more agentic and graded each upgrade the same way, pre-registered before scoring. Gate audit: the split gate, which judges a rule on held-out days by CLV dollars, kept 5 of 11 proposed rules where the legacy gate kept 0 of 24. Trades fell from 129 to 53 and CLV dollars improved by +$18 [+1, +34], but mean CLV per trade did not improve and it still does not beat never trading. The placebo test says why: random rules pass the split gate 57% of the time, the same as the reviewer's picks, so learning works by trading less, not by finding better rules. The kill switch is enforced but never tripped at $20 stakes; property tests show it blocks orders after a trip. Kelly sizing was not run. The Coach on simulated users with full compliance raises CLV dollars for every persona: overtrader +$88 [+65, +111], long-shot lover +$72 [+53, +90], cautious +$24 [+14, +36], price chaser +$17 [−4, +33], whose interval includes zero, and cuts trades by 66–87%. But it flags 99% of trades, so again the gain is trading less. The plain LLM made 5 trades in 304 decisions, CLV −$1, the same as never trading; the deterministic agent made 53 trades, CLV −$19. The tool agent and the sceptic are pending: the Gemini quota ran out and they are being re-run on DeepSeek. The orchestrator is built, shown on the right. The learned policy's selection step chose never trade, and the test was not scored. The rule language and memory are built and tested but not evaluated. The message: Every agentic upgrade, graded by the market, converges on the same answer: trade less. The market is hard to beat after fees, which is exactly why the product is education, not a trading bot.</a:t>
             </a:r>
           </a:p>
         </p:txBody>
@@ -5591,7 +5591,7 @@
                 </a:solidFill>
                 <a:latin typeface="Arial"/>
               </a:rPr>
-              <a:t>Agentic upgrades: the same market grade</a:t>
+              <a:t>Agentic upgrades: the market's answer is “trade less”</a:t>
             </a:r>
           </a:p>
         </p:txBody>
@@ -5684,7 +5684,7 @@
         </p:nvGraphicFramePr>
         <p:xfrm>
           <a:off x="457200" y="1143000"/>
-          <a:ext cx="7818120" cy="4892040"/>
+          <a:ext cx="8138160" cy="4608576"/>
         </p:xfrm>
         <a:graphic>
           <a:graphicData uri="http://schemas.openxmlformats.org/drawingml/2006/table">
@@ -5693,11 +5693,11 @@
                 <a:tableStyleId>{5C22544A-7EE6-4342-B048-85BDC9FD1C3A}</a:tableStyleId>
               </a:tblPr>
               <a:tblGrid>
-                <a:gridCol w="2148840"/>
-                <a:gridCol w="3429000"/>
-                <a:gridCol w="2240280"/>
+                <a:gridCol w="1783080"/>
+                <a:gridCol w="2331720"/>
+                <a:gridCol w="4023360"/>
               </a:tblGrid>
-              <a:tr h="365760">
+              <a:tr h="310896">
                 <a:tc>
                   <a:txBody>
                     <a:bodyPr wrap="square"/>
@@ -5705,7 +5705,7 @@
                     <a:p>
                       <a:pPr algn="l"/>
                       <a:r>
-                        <a:rPr sz="1200" b="1" i="0">
+                        <a:rPr sz="1100" b="1" i="0">
                           <a:solidFill>
                             <a:srgbClr val="FFFFFF"/>
                           </a:solidFill>
@@ -5728,7 +5728,7 @@
                     <a:p>
                       <a:pPr algn="l"/>
                       <a:r>
-                        <a:rPr sz="1200" b="1" i="0">
+                        <a:rPr sz="1100" b="1" i="0">
                           <a:solidFill>
                             <a:srgbClr val="FFFFFF"/>
                           </a:solidFill>
@@ -5751,7 +5751,7 @@
                     <a:p>
                       <a:pPr algn="l"/>
                       <a:r>
-                        <a:rPr sz="1200" b="1" i="0">
+                        <a:rPr sz="1100" b="1" i="0">
                           <a:solidFill>
                             <a:srgbClr val="FFFFFF"/>
                           </a:solidFill>
@@ -5768,7 +5768,7 @@
                   </a:tcPr>
                 </a:tc>
               </a:tr>
-              <a:tr h="502920">
+              <a:tr h="429768">
                 <a:tc>
                   <a:txBody>
                     <a:bodyPr wrap="square"/>
@@ -5776,7 +5776,433 @@
                     <a:p>
                       <a:pPr algn="l"/>
                       <a:r>
-                        <a:rPr sz="1200" b="1" i="0">
+                        <a:rPr sz="1100" b="1" i="0">
+                          <a:solidFill>
+                            <a:srgbClr val="0F172A"/>
+                          </a:solidFill>
+                          <a:latin typeface="Arial"/>
+                        </a:rPr>
+                        <a:t>Gate audit</a:t>
+                      </a:r>
+                    </a:p>
+                  </a:txBody>
+                  <a:tcPr marL="73152" marR="73152" marT="36576" marB="36576" anchor="ctr">
+                    <a:solidFill>
+                      <a:srgbClr val="F1F5F9"/>
+                    </a:solidFill>
+                  </a:tcPr>
+                </a:tc>
+                <a:tc>
+                  <a:txBody>
+                    <a:bodyPr wrap="square"/>
+                    <a:lstStyle/>
+                    <a:p>
+                      <a:pPr algn="l"/>
+                      <a:r>
+                        <a:rPr sz="1100" b="0" i="0">
+                          <a:solidFill>
+                            <a:srgbClr val="0F172A"/>
+                          </a:solidFill>
+                          <a:latin typeface="Arial"/>
+                        </a:rPr>
+                        <a:t>Rule gate judged on held-out days, by CLV $</a:t>
+                      </a:r>
+                    </a:p>
+                  </a:txBody>
+                  <a:tcPr marL="73152" marR="73152" marT="36576" marB="36576" anchor="ctr">
+                    <a:solidFill>
+                      <a:srgbClr val="F1F5F9"/>
+                    </a:solidFill>
+                  </a:tcPr>
+                </a:tc>
+                <a:tc>
+                  <a:txBody>
+                    <a:bodyPr wrap="square"/>
+                    <a:lstStyle/>
+                    <a:p>
+                      <a:pPr algn="l"/>
+                      <a:r>
+                        <a:rPr sz="1100" b="0" i="0">
+                          <a:solidFill>
+                            <a:srgbClr val="0F172A"/>
+                          </a:solidFill>
+                          <a:latin typeface="Arial"/>
+                        </a:rPr>
+                        <a:t>Kept 5 of 11 (legacy 0 of 24); trades 129 → 53; CLV $ +$18 [+1, +34], per trade no better; never trading still wins</a:t>
+                      </a:r>
+                    </a:p>
+                  </a:txBody>
+                  <a:tcPr marL="73152" marR="73152" marT="36576" marB="36576" anchor="ctr">
+                    <a:solidFill>
+                      <a:srgbClr val="F1F5F9"/>
+                    </a:solidFill>
+                  </a:tcPr>
+                </a:tc>
+              </a:tr>
+              <a:tr h="429768">
+                <a:tc>
+                  <a:txBody>
+                    <a:bodyPr wrap="square"/>
+                    <a:lstStyle/>
+                    <a:p>
+                      <a:pPr algn="l"/>
+                      <a:r>
+                        <a:rPr sz="1100" b="1" i="0">
+                          <a:solidFill>
+                            <a:srgbClr val="0F172A"/>
+                          </a:solidFill>
+                          <a:latin typeface="Arial"/>
+                        </a:rPr>
+                        <a:t>Placebo rules</a:t>
+                      </a:r>
+                    </a:p>
+                  </a:txBody>
+                  <a:tcPr marL="73152" marR="73152" marT="36576" marB="36576" anchor="ctr">
+                    <a:solidFill>
+                      <a:srgbClr val="FFFFFF"/>
+                    </a:solidFill>
+                  </a:tcPr>
+                </a:tc>
+                <a:tc>
+                  <a:txBody>
+                    <a:bodyPr wrap="square"/>
+                    <a:lstStyle/>
+                    <a:p>
+                      <a:pPr algn="l"/>
+                      <a:r>
+                        <a:rPr sz="1100" b="0" i="0">
+                          <a:solidFill>
+                            <a:srgbClr val="0F172A"/>
+                          </a:solidFill>
+                          <a:latin typeface="Arial"/>
+                        </a:rPr>
+                        <a:t>Random rules through the same gate</a:t>
+                      </a:r>
+                    </a:p>
+                  </a:txBody>
+                  <a:tcPr marL="73152" marR="73152" marT="36576" marB="36576" anchor="ctr">
+                    <a:solidFill>
+                      <a:srgbClr val="FFFFFF"/>
+                    </a:solidFill>
+                  </a:tcPr>
+                </a:tc>
+                <a:tc>
+                  <a:txBody>
+                    <a:bodyPr wrap="square"/>
+                    <a:lstStyle/>
+                    <a:p>
+                      <a:pPr algn="l"/>
+                      <a:r>
+                        <a:rPr sz="1100" b="0" i="0">
+                          <a:solidFill>
+                            <a:srgbClr val="0F172A"/>
+                          </a:solidFill>
+                          <a:latin typeface="Arial"/>
+                        </a:rPr>
+                        <a:t>Random rules pass 57%, same as the reviewer's: learning works by trading less</a:t>
+                      </a:r>
+                    </a:p>
+                  </a:txBody>
+                  <a:tcPr marL="73152" marR="73152" marT="36576" marB="36576" anchor="ctr">
+                    <a:solidFill>
+                      <a:srgbClr val="FFFFFF"/>
+                    </a:solidFill>
+                  </a:tcPr>
+                </a:tc>
+              </a:tr>
+              <a:tr h="429768">
+                <a:tc>
+                  <a:txBody>
+                    <a:bodyPr wrap="square"/>
+                    <a:lstStyle/>
+                    <a:p>
+                      <a:pPr algn="l"/>
+                      <a:r>
+                        <a:rPr sz="1100" b="1" i="0">
+                          <a:solidFill>
+                            <a:srgbClr val="0F172A"/>
+                          </a:solidFill>
+                          <a:latin typeface="Arial"/>
+                        </a:rPr>
+                        <a:t>Kill switch</a:t>
+                      </a:r>
+                    </a:p>
+                  </a:txBody>
+                  <a:tcPr marL="73152" marR="73152" marT="36576" marB="36576" anchor="ctr">
+                    <a:solidFill>
+                      <a:srgbClr val="F1F5F9"/>
+                    </a:solidFill>
+                  </a:tcPr>
+                </a:tc>
+                <a:tc>
+                  <a:txBody>
+                    <a:bodyPr wrap="square"/>
+                    <a:lstStyle/>
+                    <a:p>
+                      <a:pPr algn="l"/>
+                      <a:r>
+                        <a:rPr sz="1100" b="0" i="0">
+                          <a:solidFill>
+                            <a:srgbClr val="0F172A"/>
+                          </a:solidFill>
+                          <a:latin typeface="Arial"/>
+                        </a:rPr>
+                        <a:t>$100 daily realised-loss stop</a:t>
+                      </a:r>
+                    </a:p>
+                  </a:txBody>
+                  <a:tcPr marL="73152" marR="73152" marT="36576" marB="36576" anchor="ctr">
+                    <a:solidFill>
+                      <a:srgbClr val="F1F5F9"/>
+                    </a:solidFill>
+                  </a:tcPr>
+                </a:tc>
+                <a:tc>
+                  <a:txBody>
+                    <a:bodyPr wrap="square"/>
+                    <a:lstStyle/>
+                    <a:p>
+                      <a:pPr algn="l"/>
+                      <a:r>
+                        <a:rPr sz="1100" b="0" i="0">
+                          <a:solidFill>
+                            <a:srgbClr val="0F172A"/>
+                          </a:solidFill>
+                          <a:latin typeface="Arial"/>
+                        </a:rPr>
+                        <a:t>Enforced, never tripped at $20 stakes (worst day −$54); property-tested</a:t>
+                      </a:r>
+                    </a:p>
+                  </a:txBody>
+                  <a:tcPr marL="73152" marR="73152" marT="36576" marB="36576" anchor="ctr">
+                    <a:solidFill>
+                      <a:srgbClr val="F1F5F9"/>
+                    </a:solidFill>
+                  </a:tcPr>
+                </a:tc>
+              </a:tr>
+              <a:tr h="429768">
+                <a:tc>
+                  <a:txBody>
+                    <a:bodyPr wrap="square"/>
+                    <a:lstStyle/>
+                    <a:p>
+                      <a:pPr algn="l"/>
+                      <a:r>
+                        <a:rPr sz="1100" b="1" i="0">
+                          <a:solidFill>
+                            <a:srgbClr val="0F172A"/>
+                          </a:solidFill>
+                          <a:latin typeface="Arial"/>
+                        </a:rPr>
+                        <a:t>Fractional Kelly</a:t>
+                      </a:r>
+                    </a:p>
+                  </a:txBody>
+                  <a:tcPr marL="73152" marR="73152" marT="36576" marB="36576" anchor="ctr">
+                    <a:solidFill>
+                      <a:srgbClr val="FFFFFF"/>
+                    </a:solidFill>
+                  </a:tcPr>
+                </a:tc>
+                <a:tc>
+                  <a:txBody>
+                    <a:bodyPr wrap="square"/>
+                    <a:lstStyle/>
+                    <a:p>
+                      <a:pPr algn="l"/>
+                      <a:r>
+                        <a:rPr sz="1100" b="0" i="0">
+                          <a:solidFill>
+                            <a:srgbClr val="0F172A"/>
+                          </a:solidFill>
+                          <a:latin typeface="Arial"/>
+                        </a:rPr>
+                        <a:t>¼-Kelly with the fee vs flat $20</a:t>
+                      </a:r>
+                    </a:p>
+                  </a:txBody>
+                  <a:tcPr marL="73152" marR="73152" marT="36576" marB="36576" anchor="ctr">
+                    <a:solidFill>
+                      <a:srgbClr val="FFFFFF"/>
+                    </a:solidFill>
+                  </a:tcPr>
+                </a:tc>
+                <a:tc>
+                  <a:txBody>
+                    <a:bodyPr wrap="square"/>
+                    <a:lstStyle/>
+                    <a:p>
+                      <a:pPr algn="l"/>
+                      <a:r>
+                        <a:rPr sz="1100" b="0" i="1">
+                          <a:solidFill>
+                            <a:srgbClr val="64748B"/>
+                          </a:solidFill>
+                          <a:latin typeface="Arial"/>
+                        </a:rPr>
+                        <a:t>Not run (time)</a:t>
+                      </a:r>
+                    </a:p>
+                  </a:txBody>
+                  <a:tcPr marL="73152" marR="73152" marT="36576" marB="36576" anchor="ctr">
+                    <a:solidFill>
+                      <a:srgbClr val="FFFFFF"/>
+                    </a:solidFill>
+                  </a:tcPr>
+                </a:tc>
+              </a:tr>
+              <a:tr h="429768">
+                <a:tc>
+                  <a:txBody>
+                    <a:bodyPr wrap="square"/>
+                    <a:lstStyle/>
+                    <a:p>
+                      <a:pPr algn="l"/>
+                      <a:r>
+                        <a:rPr sz="1100" b="1" i="0">
+                          <a:solidFill>
+                            <a:srgbClr val="0F172A"/>
+                          </a:solidFill>
+                          <a:latin typeface="Arial"/>
+                        </a:rPr>
+                        <a:t>Coach, simulated users</a:t>
+                      </a:r>
+                    </a:p>
+                  </a:txBody>
+                  <a:tcPr marL="73152" marR="73152" marT="36576" marB="36576" anchor="ctr">
+                    <a:solidFill>
+                      <a:srgbClr val="F1F5F9"/>
+                    </a:solidFill>
+                  </a:tcPr>
+                </a:tc>
+                <a:tc>
+                  <a:txBody>
+                    <a:bodyPr wrap="square"/>
+                    <a:lstStyle/>
+                    <a:p>
+                      <a:pPr algn="l"/>
+                      <a:r>
+                        <a:rPr sz="1100" b="0" i="0">
+                          <a:solidFill>
+                            <a:srgbClr val="0F172A"/>
+                          </a:solidFill>
+                          <a:latin typeface="Arial"/>
+                        </a:rPr>
+                        <a:t>Biased personas follow nudges (compliance 1.0)</a:t>
+                      </a:r>
+                    </a:p>
+                  </a:txBody>
+                  <a:tcPr marL="73152" marR="73152" marT="36576" marB="36576" anchor="ctr">
+                    <a:solidFill>
+                      <a:srgbClr val="F1F5F9"/>
+                    </a:solidFill>
+                  </a:tcPr>
+                </a:tc>
+                <a:tc>
+                  <a:txBody>
+                    <a:bodyPr wrap="square"/>
+                    <a:lstStyle/>
+                    <a:p>
+                      <a:pPr algn="l"/>
+                      <a:r>
+                        <a:rPr sz="1100" b="0" i="0">
+                          <a:solidFill>
+                            <a:srgbClr val="0F172A"/>
+                          </a:solidFill>
+                          <a:latin typeface="Arial"/>
+                        </a:rPr>
+                        <a:t>CLV $ +$17 to +$88 for all 4 personas; trades −66–87%; flags 99%, so the gain is trading less</a:t>
+                      </a:r>
+                    </a:p>
+                  </a:txBody>
+                  <a:tcPr marL="73152" marR="73152" marT="36576" marB="36576" anchor="ctr">
+                    <a:solidFill>
+                      <a:srgbClr val="F1F5F9"/>
+                    </a:solidFill>
+                  </a:tcPr>
+                </a:tc>
+              </a:tr>
+              <a:tr h="429768">
+                <a:tc>
+                  <a:txBody>
+                    <a:bodyPr wrap="square"/>
+                    <a:lstStyle/>
+                    <a:p>
+                      <a:pPr algn="l"/>
+                      <a:r>
+                        <a:rPr sz="1100" b="1" i="0">
+                          <a:solidFill>
+                            <a:srgbClr val="0F172A"/>
+                          </a:solidFill>
+                          <a:latin typeface="Arial"/>
+                        </a:rPr>
+                        <a:t>Plain LLM</a:t>
+                      </a:r>
+                    </a:p>
+                  </a:txBody>
+                  <a:tcPr marL="73152" marR="73152" marT="36576" marB="36576" anchor="ctr">
+                    <a:solidFill>
+                      <a:srgbClr val="FFFFFF"/>
+                    </a:solidFill>
+                  </a:tcPr>
+                </a:tc>
+                <a:tc>
+                  <a:txBody>
+                    <a:bodyPr wrap="square"/>
+                    <a:lstStyle/>
+                    <a:p>
+                      <a:pPr algn="l"/>
+                      <a:r>
+                        <a:rPr sz="1100" b="0" i="0">
+                          <a:solidFill>
+                            <a:srgbClr val="0F172A"/>
+                          </a:solidFill>
+                          <a:latin typeface="Arial"/>
+                        </a:rPr>
+                        <a:t>One LLM call per decision, no tools</a:t>
+                      </a:r>
+                    </a:p>
+                  </a:txBody>
+                  <a:tcPr marL="73152" marR="73152" marT="36576" marB="36576" anchor="ctr">
+                    <a:solidFill>
+                      <a:srgbClr val="FFFFFF"/>
+                    </a:solidFill>
+                  </a:tcPr>
+                </a:tc>
+                <a:tc>
+                  <a:txBody>
+                    <a:bodyPr wrap="square"/>
+                    <a:lstStyle/>
+                    <a:p>
+                      <a:pPr algn="l"/>
+                      <a:r>
+                        <a:rPr sz="1100" b="0" i="0">
+                          <a:solidFill>
+                            <a:srgbClr val="0F172A"/>
+                          </a:solidFill>
+                          <a:latin typeface="Arial"/>
+                        </a:rPr>
+                        <a:t>5 trades in 304 decisions, CLV $ −$1 = never trading (deterministic agent: 53 trades, −$19)</a:t>
+                      </a:r>
+                    </a:p>
+                  </a:txBody>
+                  <a:tcPr marL="73152" marR="73152" marT="36576" marB="36576" anchor="ctr">
+                    <a:solidFill>
+                      <a:srgbClr val="FFFFFF"/>
+                    </a:solidFill>
+                  </a:tcPr>
+                </a:tc>
+              </a:tr>
+              <a:tr h="429768">
+                <a:tc>
+                  <a:txBody>
+                    <a:bodyPr wrap="square"/>
+                    <a:lstStyle/>
+                    <a:p>
+                      <a:pPr algn="l"/>
+                      <a:r>
+                        <a:rPr sz="1100" b="1" i="0">
                           <a:solidFill>
                             <a:srgbClr val="0F172A"/>
                           </a:solidFill>
@@ -5799,13 +6225,13 @@
                     <a:p>
                       <a:pPr algn="l"/>
                       <a:r>
-                        <a:rPr sz="1200" b="0" i="0">
+                        <a:rPr sz="1100" b="0" i="0">
                           <a:solidFill>
                             <a:srgbClr val="0F172A"/>
                           </a:solidFill>
                           <a:latin typeface="Arial"/>
                         </a:rPr>
-                        <a:t>LLM picks as-of tools; code checks every number; a sceptic asks “already priced in?”</a:t>
+                        <a:t>Picks as-of tools; code checks numbers; sceptic can veto</a:t>
                       </a:r>
                     </a:p>
                   </a:txBody>
@@ -5822,220 +6248,7 @@
                     <a:p>
                       <a:pPr algn="l"/>
                       <a:r>
-                        <a:rPr sz="1200" b="0" i="0">
-                          <a:solidFill>
-                            <a:srgbClr val="0F172A"/>
-                          </a:solidFill>
-                          <a:latin typeface="Arial"/>
-                        </a:rPr>
-                        <a:t>Not scored (API quota); all 32 valid calls passed</a:t>
-                      </a:r>
-                    </a:p>
-                  </a:txBody>
-                  <a:tcPr marL="73152" marR="73152" marT="36576" marB="36576" anchor="ctr">
-                    <a:solidFill>
-                      <a:srgbClr val="F1F5F9"/>
-                    </a:solidFill>
-                  </a:tcPr>
-                </a:tc>
-              </a:tr>
-              <a:tr h="502920">
-                <a:tc>
-                  <a:txBody>
-                    <a:bodyPr wrap="square"/>
-                    <a:lstStyle/>
-                    <a:p>
-                      <a:pPr algn="l"/>
-                      <a:r>
-                        <a:rPr sz="1200" b="1" i="0">
-                          <a:solidFill>
-                            <a:srgbClr val="0F172A"/>
-                          </a:solidFill>
-                          <a:latin typeface="Arial"/>
-                        </a:rPr>
-                        <a:t>Gate audit + placebo</a:t>
-                      </a:r>
-                    </a:p>
-                  </a:txBody>
-                  <a:tcPr marL="73152" marR="73152" marT="36576" marB="36576" anchor="ctr">
-                    <a:solidFill>
-                      <a:srgbClr val="FFFFFF"/>
-                    </a:solidFill>
-                  </a:tcPr>
-                </a:tc>
-                <a:tc>
-                  <a:txBody>
-                    <a:bodyPr wrap="square"/>
-                    <a:lstStyle/>
-                    <a:p>
-                      <a:pPr algn="l"/>
-                      <a:r>
-                        <a:rPr sz="1200" b="0" i="0">
-                          <a:solidFill>
-                            <a:srgbClr val="0F172A"/>
-                          </a:solidFill>
-                          <a:latin typeface="Arial"/>
-                        </a:rPr>
-                        <a:t>Rule gate on held-out days; reviewer vs random rules</a:t>
-                      </a:r>
-                    </a:p>
-                  </a:txBody>
-                  <a:tcPr marL="73152" marR="73152" marT="36576" marB="36576" anchor="ctr">
-                    <a:solidFill>
-                      <a:srgbClr val="FFFFFF"/>
-                    </a:solidFill>
-                  </a:tcPr>
-                </a:tc>
-                <a:tc>
-                  <a:txBody>
-                    <a:bodyPr wrap="square"/>
-                    <a:lstStyle/>
-                    <a:p>
-                      <a:pPr algn="l"/>
-                      <a:r>
-                        <a:rPr sz="1200" b="0" i="0">
-                          <a:solidFill>
-                            <a:srgbClr val="0F172A"/>
-                          </a:solidFill>
-                          <a:latin typeface="Arial"/>
-                        </a:rPr>
-                        <a:t>Random rules pass as often (57% vs 57%)</a:t>
-                      </a:r>
-                    </a:p>
-                  </a:txBody>
-                  <a:tcPr marL="73152" marR="73152" marT="36576" marB="36576" anchor="ctr">
-                    <a:solidFill>
-                      <a:srgbClr val="FFFFFF"/>
-                    </a:solidFill>
-                  </a:tcPr>
-                </a:tc>
-              </a:tr>
-              <a:tr h="502920">
-                <a:tc>
-                  <a:txBody>
-                    <a:bodyPr wrap="square"/>
-                    <a:lstStyle/>
-                    <a:p>
-                      <a:pPr algn="l"/>
-                      <a:r>
-                        <a:rPr sz="1200" b="1" i="0">
-                          <a:solidFill>
-                            <a:srgbClr val="0F172A"/>
-                          </a:solidFill>
-                          <a:latin typeface="Arial"/>
-                        </a:rPr>
-                        <a:t>Kill switch</a:t>
-                      </a:r>
-                    </a:p>
-                  </a:txBody>
-                  <a:tcPr marL="73152" marR="73152" marT="36576" marB="36576" anchor="ctr">
-                    <a:solidFill>
-                      <a:srgbClr val="F1F5F9"/>
-                    </a:solidFill>
-                  </a:tcPr>
-                </a:tc>
-                <a:tc>
-                  <a:txBody>
-                    <a:bodyPr wrap="square"/>
-                    <a:lstStyle/>
-                    <a:p>
-                      <a:pPr algn="l"/>
-                      <a:r>
-                        <a:rPr sz="1200" b="0" i="0">
-                          <a:solidFill>
-                            <a:srgbClr val="0F172A"/>
-                          </a:solidFill>
-                          <a:latin typeface="Arial"/>
-                        </a:rPr>
-                        <a:t>$100 daily realised-loss stop, enforced in the replay</a:t>
-                      </a:r>
-                    </a:p>
-                  </a:txBody>
-                  <a:tcPr marL="73152" marR="73152" marT="36576" marB="36576" anchor="ctr">
-                    <a:solidFill>
-                      <a:srgbClr val="F1F5F9"/>
-                    </a:solidFill>
-                  </a:tcPr>
-                </a:tc>
-                <a:tc>
-                  <a:txBody>
-                    <a:bodyPr wrap="square"/>
-                    <a:lstStyle/>
-                    <a:p>
-                      <a:pPr algn="l"/>
-                      <a:r>
-                        <a:rPr sz="1200" b="0" i="0">
-                          <a:solidFill>
-                            <a:srgbClr val="0F172A"/>
-                          </a:solidFill>
-                          <a:latin typeface="Arial"/>
-                        </a:rPr>
-                        <a:t>Never triggered (worst day −$54)</a:t>
-                      </a:r>
-                    </a:p>
-                  </a:txBody>
-                  <a:tcPr marL="73152" marR="73152" marT="36576" marB="36576" anchor="ctr">
-                    <a:solidFill>
-                      <a:srgbClr val="F1F5F9"/>
-                    </a:solidFill>
-                  </a:tcPr>
-                </a:tc>
-              </a:tr>
-              <a:tr h="502920">
-                <a:tc>
-                  <a:txBody>
-                    <a:bodyPr wrap="square"/>
-                    <a:lstStyle/>
-                    <a:p>
-                      <a:pPr algn="l"/>
-                      <a:r>
-                        <a:rPr sz="1200" b="1" i="0">
-                          <a:solidFill>
-                            <a:srgbClr val="0F172A"/>
-                          </a:solidFill>
-                          <a:latin typeface="Arial"/>
-                        </a:rPr>
-                        <a:t>Fractional Kelly</a:t>
-                      </a:r>
-                    </a:p>
-                  </a:txBody>
-                  <a:tcPr marL="73152" marR="73152" marT="36576" marB="36576" anchor="ctr">
-                    <a:solidFill>
-                      <a:srgbClr val="FFFFFF"/>
-                    </a:solidFill>
-                  </a:tcPr>
-                </a:tc>
-                <a:tc>
-                  <a:txBody>
-                    <a:bodyPr wrap="square"/>
-                    <a:lstStyle/>
-                    <a:p>
-                      <a:pPr algn="l"/>
-                      <a:r>
-                        <a:rPr sz="1200" b="0" i="0">
-                          <a:solidFill>
-                            <a:srgbClr val="0F172A"/>
-                          </a:solidFill>
-                          <a:latin typeface="Arial"/>
-                        </a:rPr>
-                        <a:t>¼-Kelly sizing, fee in the formula, vs flat $20</a:t>
-                      </a:r>
-                    </a:p>
-                  </a:txBody>
-                  <a:tcPr marL="73152" marR="73152" marT="36576" marB="36576" anchor="ctr">
-                    <a:solidFill>
-                      <a:srgbClr val="FFFFFF"/>
-                    </a:solidFill>
-                  </a:tcPr>
-                </a:tc>
-                <a:tc>
-                  <a:txBody>
-                    <a:bodyPr wrap="square"/>
-                    <a:lstStyle/>
-                    <a:p>
-                      <a:pPr algn="l"/>
-                      <a:r>
-                        <a:rPr sz="1200" b="0" i="1">
+                        <a:rPr sz="1100" b="0" i="1">
                           <a:solidFill>
                             <a:srgbClr val="64748B"/>
                           </a:solidFill>
@@ -6047,12 +6260,12 @@
                   </a:txBody>
                   <a:tcPr marL="73152" marR="73152" marT="36576" marB="36576" anchor="ctr">
                     <a:solidFill>
-                      <a:srgbClr val="FFFFFF"/>
+                      <a:srgbClr val="F1F5F9"/>
                     </a:solidFill>
                   </a:tcPr>
                 </a:tc>
               </a:tr>
-              <a:tr h="502920">
+              <a:tr h="429768">
                 <a:tc>
                   <a:txBody>
                     <a:bodyPr wrap="square"/>
@@ -6060,78 +6273,7 @@
                     <a:p>
                       <a:pPr algn="l"/>
                       <a:r>
-                        <a:rPr sz="1200" b="1" i="0">
-                          <a:solidFill>
-                            <a:srgbClr val="0F172A"/>
-                          </a:solidFill>
-                          <a:latin typeface="Arial"/>
-                        </a:rPr>
-                        <a:t>Coach, simulated users</a:t>
-                      </a:r>
-                    </a:p>
-                  </a:txBody>
-                  <a:tcPr marL="73152" marR="73152" marT="36576" marB="36576" anchor="ctr">
-                    <a:solidFill>
-                      <a:srgbClr val="F1F5F9"/>
-                    </a:solidFill>
-                  </a:tcPr>
-                </a:tc>
-                <a:tc>
-                  <a:txBody>
-                    <a:bodyPr wrap="square"/>
-                    <a:lstStyle/>
-                    <a:p>
-                      <a:pPr algn="l"/>
-                      <a:r>
-                        <a:rPr sz="1200" b="0" i="0">
-                          <a:solidFill>
-                            <a:srgbClr val="0F172A"/>
-                          </a:solidFill>
-                          <a:latin typeface="Arial"/>
-                        </a:rPr>
-                        <a:t>Biased personas play League slates with and without Coach nudges</a:t>
-                      </a:r>
-                    </a:p>
-                  </a:txBody>
-                  <a:tcPr marL="73152" marR="73152" marT="36576" marB="36576" anchor="ctr">
-                    <a:solidFill>
-                      <a:srgbClr val="F1F5F9"/>
-                    </a:solidFill>
-                  </a:tcPr>
-                </a:tc>
-                <a:tc>
-                  <a:txBody>
-                    <a:bodyPr wrap="square"/>
-                    <a:lstStyle/>
-                    <a:p>
-                      <a:pPr algn="l"/>
-                      <a:r>
-                        <a:rPr sz="1200" b="0" i="0">
-                          <a:solidFill>
-                            <a:srgbClr val="0F172A"/>
-                          </a:solidFill>
-                          <a:latin typeface="Arial"/>
-                        </a:rPr>
-                        <a:t>Users trade less, lose less CLV; per-trade CLV no better</a:t>
-                      </a:r>
-                    </a:p>
-                  </a:txBody>
-                  <a:tcPr marL="73152" marR="73152" marT="36576" marB="36576" anchor="ctr">
-                    <a:solidFill>
-                      <a:srgbClr val="F1F5F9"/>
-                    </a:solidFill>
-                  </a:tcPr>
-                </a:tc>
-              </a:tr>
-              <a:tr h="502920">
-                <a:tc>
-                  <a:txBody>
-                    <a:bodyPr wrap="square"/>
-                    <a:lstStyle/>
-                    <a:p>
-                      <a:pPr algn="l"/>
-                      <a:r>
-                        <a:rPr sz="1200" b="1" i="0">
+                        <a:rPr sz="1100" b="1" i="0">
                           <a:solidFill>
                             <a:srgbClr val="0F172A"/>
                           </a:solidFill>
@@ -6154,13 +6296,13 @@
                     <a:p>
                       <a:pPr algn="l"/>
                       <a:r>
-                        <a:rPr sz="1200" b="0" i="0">
+                        <a:rPr sz="1100" b="0" i="0">
                           <a:solidFill>
                             <a:srgbClr val="0F172A"/>
                           </a:solidFill>
                           <a:latin typeface="Arial"/>
                         </a:rPr>
-                        <a:t>Supervisor graph: pregame → trader → coach → briefs for one night</a:t>
+                        <a:t>Pregame → trader → Coach → briefs, one as-of time</a:t>
                       </a:r>
                     </a:p>
                   </a:txBody>
@@ -6177,13 +6319,13 @@
                     <a:p>
                       <a:pPr algn="l"/>
                       <a:r>
-                        <a:rPr sz="1200" b="0" i="1">
+                        <a:rPr sz="1100" b="0" i="0">
                           <a:solidFill>
-                            <a:srgbClr val="64748B"/>
+                            <a:srgbClr val="0F172A"/>
                           </a:solidFill>
                           <a:latin typeface="Arial"/>
                         </a:rPr>
-                        <a:t>pending</a:t>
+                        <a:t>Built and tested (diagram); no new trading evaluation</a:t>
                       </a:r>
                     </a:p>
                   </a:txBody>
@@ -6194,7 +6336,7 @@
                   </a:tcPr>
                 </a:tc>
               </a:tr>
-              <a:tr h="502920">
+              <a:tr h="429768">
                 <a:tc>
                   <a:txBody>
                     <a:bodyPr wrap="square"/>
@@ -6202,7 +6344,7 @@
                     <a:p>
                       <a:pPr algn="l"/>
                       <a:r>
-                        <a:rPr sz="1200" b="1" i="0">
+                        <a:rPr sz="1100" b="1" i="0">
                           <a:solidFill>
                             <a:srgbClr val="0F172A"/>
                           </a:solidFill>
@@ -6225,13 +6367,13 @@
                     <a:p>
                       <a:pPr algn="l"/>
                       <a:r>
-                        <a:rPr sz="1200" b="0" i="0">
+                        <a:rPr sz="1100" b="0" i="0">
                           <a:solidFill>
                             <a:srgbClr val="0F172A"/>
                           </a:solidFill>
                           <a:latin typeface="Arial"/>
                         </a:rPr>
-                        <a:t>Trade / pass classifier on as-of features, chosen on Nov–Jan only</a:t>
+                        <a:t>Trade / pass model, selected on Nov–Jan</a:t>
                       </a:r>
                     </a:p>
                   </a:txBody>
@@ -6248,13 +6390,13 @@
                     <a:p>
                       <a:pPr algn="l"/>
                       <a:r>
-                        <a:rPr sz="1200" b="0" i="1">
+                        <a:rPr sz="1100" b="0" i="0">
                           <a:solidFill>
-                            <a:srgbClr val="64748B"/>
+                            <a:srgbClr val="0F172A"/>
                           </a:solidFill>
                           <a:latin typeface="Arial"/>
                         </a:rPr>
-                        <a:t>pending</a:t>
+                        <a:t>Selection chose never trade; test not scored</a:t>
                       </a:r>
                     </a:p>
                   </a:txBody>
@@ -6265,7 +6407,7 @@
                   </a:tcPr>
                 </a:tc>
               </a:tr>
-              <a:tr h="502920">
+              <a:tr h="429768">
                 <a:tc>
                   <a:txBody>
                     <a:bodyPr wrap="square"/>
@@ -6273,13 +6415,13 @@
                     <a:p>
                       <a:pPr algn="l"/>
                       <a:r>
-                        <a:rPr sz="1200" b="1" i="0">
+                        <a:rPr sz="1100" b="1" i="0">
                           <a:solidFill>
                             <a:srgbClr val="0F172A"/>
                           </a:solidFill>
                           <a:latin typeface="Arial"/>
                         </a:rPr>
-                        <a:t>Rule DSL</a:t>
+                        <a:t>Rule DSL + memory</a:t>
                       </a:r>
                     </a:p>
                   </a:txBody>
@@ -6296,13 +6438,13 @@
                     <a:p>
                       <a:pPr algn="l"/>
                       <a:r>
-                        <a:rPr sz="1200" b="0" i="0">
+                        <a:rPr sz="1100" b="0" i="0">
                           <a:solidFill>
                             <a:srgbClr val="0F172A"/>
                           </a:solidFill>
                           <a:latin typeface="Arial"/>
                         </a:rPr>
-                        <a:t>LLM writes free-form rules, compiled to a safe DSL, still gated</a:t>
+                        <a:t>LLM rules in a safe DSL; recall of similar past trades</a:t>
                       </a:r>
                     </a:p>
                   </a:txBody>
@@ -6319,90 +6461,19 @@
                     <a:p>
                       <a:pPr algn="l"/>
                       <a:r>
-                        <a:rPr sz="1200" b="0" i="1">
+                        <a:rPr sz="1100" b="0" i="0">
                           <a:solidFill>
-                            <a:srgbClr val="64748B"/>
+                            <a:srgbClr val="0F172A"/>
                           </a:solidFill>
                           <a:latin typeface="Arial"/>
                         </a:rPr>
-                        <a:t>pending</a:t>
+                        <a:t>Built and unit-tested; not evaluated</a:t>
                       </a:r>
                     </a:p>
                   </a:txBody>
                   <a:tcPr marL="73152" marR="73152" marT="36576" marB="36576" anchor="ctr">
                     <a:solidFill>
                       <a:srgbClr val="FFFFFF"/>
-                    </a:solidFill>
-                  </a:tcPr>
-                </a:tc>
-              </a:tr>
-              <a:tr h="502920">
-                <a:tc>
-                  <a:txBody>
-                    <a:bodyPr wrap="square"/>
-                    <a:lstStyle/>
-                    <a:p>
-                      <a:pPr algn="l"/>
-                      <a:r>
-                        <a:rPr sz="1200" b="1" i="0">
-                          <a:solidFill>
-                            <a:srgbClr val="0F172A"/>
-                          </a:solidFill>
-                          <a:latin typeface="Arial"/>
-                        </a:rPr>
-                        <a:t>Episodic memory</a:t>
-                      </a:r>
-                    </a:p>
-                  </a:txBody>
-                  <a:tcPr marL="73152" marR="73152" marT="36576" marB="36576" anchor="ctr">
-                    <a:solidFill>
-                      <a:srgbClr val="F1F5F9"/>
-                    </a:solidFill>
-                  </a:tcPr>
-                </a:tc>
-                <a:tc>
-                  <a:txBody>
-                    <a:bodyPr wrap="square"/>
-                    <a:lstStyle/>
-                    <a:p>
-                      <a:pPr algn="l"/>
-                      <a:r>
-                        <a:rPr sz="1200" b="0" i="0">
-                          <a:solidFill>
-                            <a:srgbClr val="0F172A"/>
-                          </a:solidFill>
-                          <a:latin typeface="Arial"/>
-                        </a:rPr>
-                        <a:t>Retrieve similar past situations and their outcomes</a:t>
-                      </a:r>
-                    </a:p>
-                  </a:txBody>
-                  <a:tcPr marL="73152" marR="73152" marT="36576" marB="36576" anchor="ctr">
-                    <a:solidFill>
-                      <a:srgbClr val="F1F5F9"/>
-                    </a:solidFill>
-                  </a:tcPr>
-                </a:tc>
-                <a:tc>
-                  <a:txBody>
-                    <a:bodyPr wrap="square"/>
-                    <a:lstStyle/>
-                    <a:p>
-                      <a:pPr algn="l"/>
-                      <a:r>
-                        <a:rPr sz="1200" b="0" i="1">
-                          <a:solidFill>
-                            <a:srgbClr val="64748B"/>
-                          </a:solidFill>
-                          <a:latin typeface="Arial"/>
-                        </a:rPr>
-                        <a:t>pending</a:t>
-                      </a:r>
-                    </a:p>
-                  </a:txBody>
-                  <a:tcPr marL="73152" marR="73152" marT="36576" marB="36576" anchor="ctr">
-                    <a:solidFill>
-                      <a:srgbClr val="F1F5F9"/>
                     </a:solidFill>
                   </a:tcPr>
                 </a:tc>
@@ -6427,8 +6498,8 @@
         </p:blipFill>
         <p:spPr>
           <a:xfrm>
-            <a:off x="8412480" y="2702436"/>
-            <a:ext cx="3322015" cy="1727447"/>
+            <a:off x="8732520" y="2282726"/>
+            <a:ext cx="3001975" cy="1561027"/>
           </a:xfrm>
           <a:prstGeom prst="rect">
             <a:avLst/>
@@ -6443,8 +6514,8 @@
         </p:nvSpPr>
         <p:spPr>
           <a:xfrm>
-            <a:off x="457200" y="6080760"/>
-            <a:ext cx="11277295" cy="274320"/>
+            <a:off x="8732520" y="5074920"/>
+            <a:ext cx="3001975" cy="502920"/>
           </a:xfrm>
           <a:prstGeom prst="rect">
             <a:avLst/>
@@ -6463,13 +6534,98 @@
               </a:spcAft>
             </a:pPr>
             <a:r>
-              <a:rPr sz="1200" b="0" i="0">
+              <a:rPr sz="1100" b="0" i="0">
                 <a:solidFill>
                   <a:srgbClr val="64748B"/>
                 </a:solidFill>
                 <a:latin typeface="Arial"/>
               </a:rPr>
-              <a:t>Pre-registered before scoring (docs/preregistration_*.md); same replay, costs and bootstrap as above</a:t>
+              <a:t>Pre-registered before scoring; same replay, costs and day-clustered bootstrap as above</a:t>
+            </a:r>
+          </a:p>
+        </p:txBody>
+      </p:sp>
+      <p:sp>
+        <p:nvSpPr>
+          <p:cNvPr id="10" name="Rounded Rectangle 9"/>
+          <p:cNvSpPr/>
+          <p:nvPr/>
+        </p:nvSpPr>
+        <p:spPr>
+          <a:xfrm>
+            <a:off x="457200" y="5815584"/>
+            <a:ext cx="11277295" cy="512064"/>
+          </a:xfrm>
+          <a:prstGeom prst="roundRect">
+            <a:avLst>
+              <a:gd name="adj" fmla="val 12000"/>
+            </a:avLst>
+          </a:prstGeom>
+          <a:solidFill>
+            <a:srgbClr val="FEF3C7"/>
+          </a:solidFill>
+          <a:ln>
+            <a:noFill/>
+          </a:ln>
+          <a:effectLst/>
+        </p:spPr>
+        <p:style>
+          <a:lnRef idx="1">
+            <a:schemeClr val="accent1"/>
+          </a:lnRef>
+          <a:fillRef idx="3">
+            <a:schemeClr val="accent1"/>
+          </a:fillRef>
+          <a:effectRef idx="2">
+            <a:schemeClr val="accent1"/>
+          </a:effectRef>
+          <a:fontRef idx="minor">
+            <a:schemeClr val="lt1"/>
+          </a:fontRef>
+        </p:style>
+        <p:txBody>
+          <a:bodyPr rtlCol="0" anchor="ctr"/>
+          <a:lstStyle/>
+          <a:p>
+            <a:pPr algn="ctr"/>
+          </a:p>
+        </p:txBody>
+      </p:sp>
+      <p:sp>
+        <p:nvSpPr>
+          <p:cNvPr id="11" name="TextBox 10"/>
+          <p:cNvSpPr txBox="1"/>
+          <p:nvPr/>
+        </p:nvSpPr>
+        <p:spPr>
+          <a:xfrm>
+            <a:off x="548640" y="5815584"/>
+            <a:ext cx="11094415" cy="512064"/>
+          </a:xfrm>
+          <a:prstGeom prst="rect">
+            <a:avLst/>
+          </a:prstGeom>
+          <a:noFill/>
+        </p:spPr>
+        <p:txBody>
+          <a:bodyPr wrap="square" anchor="ctr" lIns="73152" rIns="73152" tIns="36576" bIns="36576">
+            <a:spAutoFit/>
+          </a:bodyPr>
+          <a:lstStyle/>
+          <a:p>
+            <a:pPr algn="l">
+              <a:spcAft>
+                <a:spcPts val="0"/>
+              </a:spcAft>
+            </a:pPr>
+            <a:r>
+              <a:rPr sz="1400" b="0" i="0">
+                <a:solidFill>
+                  <a:srgbClr val="0F172A"/>
+                </a:solidFill>
+                <a:latin typeface="Arial"/>
+              </a:rPr>
+              <a:t>Every agentic upgrade, graded by the market, converges on the same answer: trade less. The market is hard to beat after fees, which is exactly why the product is education, not a trading bot.</a:t>
             </a:r>
           </a:p>
         </p:txBody>
@@ -12041,7 +12197,7 @@
                           </a:solidFill>
                           <a:latin typeface="Arial"/>
                         </a:rPr>
-                        <a:t>LLM agent, Coach, policy …</a:t>
+                        <a:t>LLM agent, Coach, gate audit …</a:t>
                       </a:r>
                     </a:p>
                   </a:txBody>
@@ -12081,13 +12237,13 @@
                     <a:p>
                       <a:pPr algn="l"/>
                       <a:r>
-                        <a:rPr sz="1600" b="0" i="0">
+                        <a:rPr sz="1600" b="1" i="0">
                           <a:solidFill>
                             <a:srgbClr val="0F172A"/>
                           </a:solidFill>
                           <a:latin typeface="Arial"/>
                         </a:rPr>
-                        <a:t>See agentic upgrades</a:t>
+                        <a:t>Help only by trading less</a:t>
                       </a:r>
                     </a:p>
                   </a:txBody>

</xml_diff>

<commit_message>
M4-NN neural win models (MLP, GRU) with day-clustered CIs; docs/deep_learning.md, docs/why_agentic.md; deck: deep-learning map and why-agentic slide; qa.md
Co-authored-by: Cursor <cursoragent@cursor.com>
</commit_message>
<xml_diff>
--- a/presentation/nba_agent_deck.pptx
+++ b/presentation/nba_agent_deck.pptx
@@ -796,7 +796,7 @@
           <a:lstStyle/>
           <a:p>
             <a:r>
-              <a:t>The work is split across the team. The pregame news loop polls several news sources before a game and turns them into fair odds, pull request 7. The player-feature experiment tested isolated player features and probability calibration, pull request 8. In-play news and odds updates are pull request 9. Live, read-only Polymarket prices are pull requests 11 and 12. The replay, the agent, the models M4 and M6, the evaluation, the Coach and the League are on our main branch. Each part had to face the same market grade.</a:t>
+              <a:t>Why an agent and not one classifier? The problem is event-driven: news arrives at random times and 91% of the move comes before the inactive list, about two-thirds before the first official report, so the hard decision is when to act; the agent's trigger, investigate, decide loop makes that decision. It uses tools over as-of data, prices, news, rotations and models, and the tools enforce no look-ahead. Decisions are multi-step with code checks, risk caps and a kill switch, which matters for gambling harm. Learning is graded by the market through the gate, and the placebo shows honestly that it works by trading less. The Coach and League turn the analysis into education, and the orchestrator ties the team's parts together. The counter-argument, a single classifier would do, is answered by our own data: the model alone loses −$2,475 over 711 trades; the decision process around it, anchoring, thresholds and abstention, adds +$2,450, p 0.002. The work is split across the team. The pregame news loop polls several news sources before a game and turns them into fair odds, pull request 7. The player-feature experiment tested isolated player features and probability calibration, pull request 8. In-play news and odds updates are pull request 9. Live, read-only Polymarket prices are pull requests 11 and 12. The replay, the agent, the models M4 and M6, the evaluation, the Coach and the League are on our main branch. Each part had to face the same market grade.</a:t>
             </a:r>
           </a:p>
         </p:txBody>
@@ -1496,7 +1496,7 @@
           <a:lstStyle/>
           <a:p>
             <a:r>
-              <a:t>Our deep-learning component is M6. Its label is the market itself: the move of the home price from the decision time to tip-off, so every decision time is a training row. A 16-unit GRU reads the last six hours of the price in 15-minute steps; it is joined with 18 static features such as the anchor, the clock, M4's news shift and who is out, and an MLP outputs the 10th, 50th and 90th percentiles, trained with pinball loss. It cannot beat “the price won't move”: 0.867 against 0.833 cents. To check that this is not a tuning accident, we ran a pre-declared grid of 9 configurations, GRU sizes, history lengths, an MLP and a CNN, with 3 seeds each: every one is worse than zero move, all 18 of 18 confidence intervals above zero, and none ever predicts the 5.5¢ move needed to pay for a trade. Recalibrating the win model does not help either: Brier 0.183 raw, 0.185 Platt, 0.184 isotonic, against 0.164 for the market, because its miscalibration flips between early and late season.</a:t>
+              <a:t>Deep learning sits in four places. M2 is a GRU over each player's last 20 games giving points and minutes quantiles; it beats gradient boosting, pinball 1.55 against 1.59. M4-NN is a neural win model on M4's features and split: alone it ties logistic regression, Brier 0.184 against 0.183, because 3,400 games is too few for capacity to pay, but plugged into the agent's anchor its news shift gives 0.163, level with the market, not significantly better. The LLM agent is a transformer used as a reasoning policy with tools and code guardrails. M6 is the fourth. Its label is the market itself: the move of the home price from the decision time to tip-off, so every decision time is a training row. A 16-unit GRU reads the last six hours of the price in 15-minute steps; it is joined with 18 static features such as the anchor, the clock, M4's news shift and who is out, and an MLP outputs the 10th, 50th and 90th percentiles, trained with pinball loss. It cannot beat “the price won't move”: 0.867 against 0.833 cents. To check that this is not a tuning accident, we ran a pre-declared grid of 9 configurations, GRU sizes, history lengths, an MLP and a CNN, with 3 seeds each: every one is worse than zero move, all 18 of 18 confidence intervals above zero, and none ever predicts the 5.5¢ move needed to pay for a trade. Recalibrating the win model does not help either: Brier 0.183 raw, 0.185 Platt, 0.184 isotonic, against 0.164 for the market, because its miscalibration flips between early and late season.</a:t>
             </a:r>
           </a:p>
         </p:txBody>
@@ -7804,7 +7804,7 @@
                 </a:solidFill>
                 <a:latin typeface="Arial"/>
               </a:rPr>
-              <a:t>Team contributions</a:t>
+              <a:t>Why an agentic framework, and who built which part</a:t>
             </a:r>
           </a:p>
         </p:txBody>
@@ -7887,17 +7887,186 @@
           </a:p>
         </p:txBody>
       </p:sp>
+      <p:sp>
+        <p:nvSpPr>
+          <p:cNvPr id="7" name="TextBox 6"/>
+          <p:cNvSpPr txBox="1"/>
+          <p:nvPr/>
+        </p:nvSpPr>
+        <p:spPr>
+          <a:xfrm>
+            <a:off x="457200" y="1143000"/>
+            <a:ext cx="5760720" cy="4206240"/>
+          </a:xfrm>
+          <a:prstGeom prst="rect">
+            <a:avLst/>
+          </a:prstGeom>
+          <a:noFill/>
+        </p:spPr>
+        <p:txBody>
+          <a:bodyPr wrap="square" anchor="t" lIns="73152" rIns="73152" tIns="36576" bIns="36576">
+            <a:spAutoFit/>
+          </a:bodyPr>
+          <a:lstStyle/>
+          <a:p>
+            <a:pPr algn="l">
+              <a:spcAft>
+                <a:spcPts val="400"/>
+              </a:spcAft>
+            </a:pPr>
+            <a:r>
+              <a:rPr sz="1500" b="1" i="0">
+                <a:solidFill>
+                  <a:srgbClr val="1E293B"/>
+                </a:solidFill>
+                <a:latin typeface="Arial"/>
+              </a:rPr>
+              <a:t>Why agentic: the problem's structure</a:t>
+            </a:r>
+          </a:p>
+          <a:p>
+            <a:pPr algn="l" marL="292608" indent="-256032">
+              <a:spcAft>
+                <a:spcPts val="400"/>
+              </a:spcAft>
+              <a:buChar char="•"/>
+            </a:pPr>
+            <a:r>
+              <a:rPr sz="1500" b="1" i="0">
+                <a:solidFill>
+                  <a:srgbClr val="0F172A"/>
+                </a:solidFill>
+                <a:latin typeface="Arial"/>
+              </a:rPr>
+              <a:t>When to act:</a:t>
+            </a:r>
+            <a:r>
+              <a:rPr sz="1500" b="0" i="0">
+                <a:solidFill>
+                  <a:srgbClr val="0F172A"/>
+                </a:solidFill>
+                <a:latin typeface="Arial"/>
+              </a:rPr>
+              <a:t> news is asynchronous; 91% of the move before the inactive list, ~⅔ before the first report → trigger → investigate → decide</a:t>
+            </a:r>
+          </a:p>
+          <a:p>
+            <a:pPr algn="l" marL="292608" indent="-256032">
+              <a:spcAft>
+                <a:spcPts val="400"/>
+              </a:spcAft>
+              <a:buChar char="•"/>
+            </a:pPr>
+            <a:r>
+              <a:rPr sz="1500" b="1" i="0">
+                <a:solidFill>
+                  <a:srgbClr val="0F172A"/>
+                </a:solidFill>
+                <a:latin typeface="Arial"/>
+              </a:rPr>
+              <a:t>Tools over as-of data:</a:t>
+            </a:r>
+            <a:r>
+              <a:rPr sz="1500" b="0" i="0">
+                <a:solidFill>
+                  <a:srgbClr val="0F172A"/>
+                </a:solidFill>
+                <a:latin typeface="Arial"/>
+              </a:rPr>
+              <a:t> prices, news, rotations, models; no look-ahead</a:t>
+            </a:r>
+          </a:p>
+          <a:p>
+            <a:pPr algn="l" marL="292608" indent="-256032">
+              <a:spcAft>
+                <a:spcPts val="400"/>
+              </a:spcAft>
+              <a:buChar char="•"/>
+            </a:pPr>
+            <a:r>
+              <a:rPr sz="1500" b="1" i="0">
+                <a:solidFill>
+                  <a:srgbClr val="0F172A"/>
+                </a:solidFill>
+                <a:latin typeface="Arial"/>
+              </a:rPr>
+              <a:t>Multi-step + safety:</a:t>
+            </a:r>
+            <a:r>
+              <a:rPr sz="1500" b="0" i="0">
+                <a:solidFill>
+                  <a:srgbClr val="0F172A"/>
+                </a:solidFill>
+                <a:latin typeface="Arial"/>
+              </a:rPr>
+              <a:t> checks, risk caps, kill switch, blocked orders</a:t>
+            </a:r>
+          </a:p>
+          <a:p>
+            <a:pPr algn="l" marL="292608" indent="-256032">
+              <a:spcAft>
+                <a:spcPts val="400"/>
+              </a:spcAft>
+              <a:buChar char="•"/>
+            </a:pPr>
+            <a:r>
+              <a:rPr sz="1500" b="1" i="0">
+                <a:solidFill>
+                  <a:srgbClr val="0F172A"/>
+                </a:solidFill>
+                <a:latin typeface="Arial"/>
+              </a:rPr>
+              <a:t>Market-graded learning:</a:t>
+            </a:r>
+            <a:r>
+              <a:rPr sz="1500" b="0" i="0">
+                <a:solidFill>
+                  <a:srgbClr val="0F172A"/>
+                </a:solidFill>
+                <a:latin typeface="Arial"/>
+              </a:rPr>
+              <a:t> review → gate → rules; placebo-audited</a:t>
+            </a:r>
+          </a:p>
+          <a:p>
+            <a:pPr algn="l" marL="292608" indent="-256032">
+              <a:spcAft>
+                <a:spcPts val="400"/>
+              </a:spcAft>
+              <a:buChar char="•"/>
+            </a:pPr>
+            <a:r>
+              <a:rPr sz="1500" b="1" i="0">
+                <a:solidFill>
+                  <a:srgbClr val="0F172A"/>
+                </a:solidFill>
+                <a:latin typeface="Arial"/>
+              </a:rPr>
+              <a:t>Human in the loop:</a:t>
+            </a:r>
+            <a:r>
+              <a:rPr sz="1500" b="0" i="0">
+                <a:solidFill>
+                  <a:srgbClr val="0F172A"/>
+                </a:solidFill>
+                <a:latin typeface="Arial"/>
+              </a:rPr>
+              <a:t> Coach and League teach; orchestrator joins the team's parts</a:t>
+            </a:r>
+          </a:p>
+        </p:txBody>
+      </p:sp>
       <p:graphicFrame>
         <p:nvGraphicFramePr>
-          <p:cNvPr id="7" name="Table 6"/>
+          <p:cNvPr id="8" name="Table 7"/>
           <p:cNvGraphicFramePr>
             <a:graphicFrameLocks noGrp="1"/>
           </p:cNvGraphicFramePr>
           <p:nvPr/>
         </p:nvGraphicFramePr>
         <p:xfrm>
-          <a:off x="457200" y="1234439"/>
-          <a:ext cx="11277295" cy="3730752"/>
+          <a:off x="6400800" y="1143000"/>
+          <a:ext cx="5333695" cy="3200400"/>
         </p:xfrm>
         <a:graphic>
           <a:graphicData uri="http://schemas.openxmlformats.org/drawingml/2006/table">
@@ -7906,12 +8075,11 @@
                 <a:tableStyleId>{5C22544A-7EE6-4342-B048-85BDC9FD1C3A}</a:tableStyleId>
               </a:tblPr>
               <a:tblGrid>
-                <a:gridCol w="3017520"/>
-                <a:gridCol w="1097280"/>
-                <a:gridCol w="2560320"/>
-                <a:gridCol w="4602175"/>
+                <a:gridCol w="2743200"/>
+                <a:gridCol w="868680"/>
+                <a:gridCol w="1721815"/>
               </a:tblGrid>
-              <a:tr h="438912">
+              <a:tr h="365760">
                 <a:tc>
                   <a:txBody>
                     <a:bodyPr wrap="square"/>
@@ -7919,7 +8087,7 @@
                     <a:p>
                       <a:pPr algn="l"/>
                       <a:r>
-                        <a:rPr sz="1600" b="1" i="0">
+                        <a:rPr sz="1200" b="1" i="0">
                           <a:solidFill>
                             <a:srgbClr val="FFFFFF"/>
                           </a:solidFill>
@@ -7942,7 +8110,7 @@
                     <a:p>
                       <a:pPr algn="ctr"/>
                       <a:r>
-                        <a:rPr sz="1600" b="1" i="0">
+                        <a:rPr sz="1200" b="1" i="0">
                           <a:solidFill>
                             <a:srgbClr val="FFFFFF"/>
                           </a:solidFill>
@@ -7965,7 +8133,7 @@
                     <a:p>
                       <a:pPr algn="l"/>
                       <a:r>
-                        <a:rPr sz="1600" b="1" i="0">
+                        <a:rPr sz="1200" b="1" i="0">
                           <a:solidFill>
                             <a:srgbClr val="FFFFFF"/>
                           </a:solidFill>
@@ -7981,6 +8149,8 @@
                     </a:solidFill>
                   </a:tcPr>
                 </a:tc>
+              </a:tr>
+              <a:tr h="566928">
                 <a:tc>
                   <a:txBody>
                     <a:bodyPr wrap="square"/>
@@ -7988,32 +8158,7 @@
                     <a:p>
                       <a:pPr algn="l"/>
                       <a:r>
-                        <a:rPr sz="1600" b="1" i="0">
-                          <a:solidFill>
-                            <a:srgbClr val="FFFFFF"/>
-                          </a:solidFill>
-                          <a:latin typeface="Arial"/>
-                        </a:rPr>
-                        <a:t>What it adds</a:t>
-                      </a:r>
-                    </a:p>
-                  </a:txBody>
-                  <a:tcPr marL="73152" marR="73152" marT="36576" marB="36576" anchor="ctr">
-                    <a:solidFill>
-                      <a:srgbClr val="1E293B"/>
-                    </a:solidFill>
-                  </a:tcPr>
-                </a:tc>
-              </a:tr>
-              <a:tr h="658368">
-                <a:tc>
-                  <a:txBody>
-                    <a:bodyPr wrap="square"/>
-                    <a:lstStyle/>
-                    <a:p>
-                      <a:pPr algn="l"/>
-                      <a:r>
-                        <a:rPr sz="1600" b="0" i="0">
+                        <a:rPr sz="1200" b="0" i="0">
                           <a:solidFill>
                             <a:srgbClr val="0F172A"/>
                           </a:solidFill>
@@ -8036,7 +8181,7 @@
                     <a:p>
                       <a:pPr algn="ctr"/>
                       <a:r>
-                        <a:rPr sz="1600" b="0" i="0">
+                        <a:rPr sz="1200" b="0" i="0">
                           <a:solidFill>
                             <a:srgbClr val="0F172A"/>
                           </a:solidFill>
@@ -8059,7 +8204,7 @@
                     <a:p>
                       <a:pPr algn="l"/>
                       <a:r>
-                        <a:rPr sz="1600" b="0" i="0">
+                        <a:rPr sz="1200" b="0" i="0">
                           <a:solidFill>
                             <a:srgbClr val="0F172A"/>
                           </a:solidFill>
@@ -8075,6 +8220,8 @@
                     </a:solidFill>
                   </a:tcPr>
                 </a:tc>
+              </a:tr>
+              <a:tr h="566928">
                 <a:tc>
                   <a:txBody>
                     <a:bodyPr wrap="square"/>
@@ -8082,32 +8229,7 @@
                     <a:p>
                       <a:pPr algn="l"/>
                       <a:r>
-                        <a:rPr sz="1600" b="0" i="0">
-                          <a:solidFill>
-                            <a:srgbClr val="0F172A"/>
-                          </a:solidFill>
-                          <a:latin typeface="Arial"/>
-                        </a:rPr>
-                        <a:t>Multi-source news polling → fair odds</a:t>
-                      </a:r>
-                    </a:p>
-                  </a:txBody>
-                  <a:tcPr marL="73152" marR="73152" marT="36576" marB="36576" anchor="ctr">
-                    <a:solidFill>
-                      <a:srgbClr val="F1F5F9"/>
-                    </a:solidFill>
-                  </a:tcPr>
-                </a:tc>
-              </a:tr>
-              <a:tr h="658368">
-                <a:tc>
-                  <a:txBody>
-                    <a:bodyPr wrap="square"/>
-                    <a:lstStyle/>
-                    <a:p>
-                      <a:pPr algn="l"/>
-                      <a:r>
-                        <a:rPr sz="1600" b="0" i="0">
+                        <a:rPr sz="1200" b="0" i="0">
                           <a:solidFill>
                             <a:srgbClr val="0F172A"/>
                           </a:solidFill>
@@ -8130,7 +8252,7 @@
                     <a:p>
                       <a:pPr algn="ctr"/>
                       <a:r>
-                        <a:rPr sz="1600" b="0" i="0">
+                        <a:rPr sz="1200" b="0" i="0">
                           <a:solidFill>
                             <a:srgbClr val="0F172A"/>
                           </a:solidFill>
@@ -8153,7 +8275,7 @@
                     <a:p>
                       <a:pPr algn="l"/>
                       <a:r>
-                        <a:rPr sz="1600" b="0" i="0">
+                        <a:rPr sz="1200" b="0" i="0">
                           <a:solidFill>
                             <a:srgbClr val="0F172A"/>
                           </a:solidFill>
@@ -8169,6 +8291,8 @@
                     </a:solidFill>
                   </a:tcPr>
                 </a:tc>
+              </a:tr>
+              <a:tr h="566928">
                 <a:tc>
                   <a:txBody>
                     <a:bodyPr wrap="square"/>
@@ -8176,32 +8300,7 @@
                     <a:p>
                       <a:pPr algn="l"/>
                       <a:r>
-                        <a:rPr sz="1600" b="0" i="0">
-                          <a:solidFill>
-                            <a:srgbClr val="0F172A"/>
-                          </a:solidFill>
-                          <a:latin typeface="Arial"/>
-                        </a:rPr>
-                        <a:t>Isolated player features + probability calibration</a:t>
-                      </a:r>
-                    </a:p>
-                  </a:txBody>
-                  <a:tcPr marL="73152" marR="73152" marT="36576" marB="36576" anchor="ctr">
-                    <a:solidFill>
-                      <a:srgbClr val="FFFFFF"/>
-                    </a:solidFill>
-                  </a:tcPr>
-                </a:tc>
-              </a:tr>
-              <a:tr h="658368">
-                <a:tc>
-                  <a:txBody>
-                    <a:bodyPr wrap="square"/>
-                    <a:lstStyle/>
-                    <a:p>
-                      <a:pPr algn="l"/>
-                      <a:r>
-                        <a:rPr sz="1600" b="0" i="0">
+                        <a:rPr sz="1200" b="0" i="0">
                           <a:solidFill>
                             <a:srgbClr val="0F172A"/>
                           </a:solidFill>
@@ -8224,7 +8323,7 @@
                     <a:p>
                       <a:pPr algn="ctr"/>
                       <a:r>
-                        <a:rPr sz="1600" b="0" i="0">
+                        <a:rPr sz="1200" b="0" i="0">
                           <a:solidFill>
                             <a:srgbClr val="0F172A"/>
                           </a:solidFill>
@@ -8247,7 +8346,7 @@
                     <a:p>
                       <a:pPr algn="l"/>
                       <a:r>
-                        <a:rPr sz="1600" b="0" i="0">
+                        <a:rPr sz="1200" b="0" i="0">
                           <a:solidFill>
                             <a:srgbClr val="0F172A"/>
                           </a:solidFill>
@@ -8263,6 +8362,8 @@
                     </a:solidFill>
                   </a:tcPr>
                 </a:tc>
+              </a:tr>
+              <a:tr h="566928">
                 <a:tc>
                   <a:txBody>
                     <a:bodyPr wrap="square"/>
@@ -8270,32 +8371,7 @@
                     <a:p>
                       <a:pPr algn="l"/>
                       <a:r>
-                        <a:rPr sz="1600" b="0" i="0">
-                          <a:solidFill>
-                            <a:srgbClr val="0F172A"/>
-                          </a:solidFill>
-                          <a:latin typeface="Arial"/>
-                        </a:rPr>
-                        <a:t>Independent in-play updates (synthetic scenarios)</a:t>
-                      </a:r>
-                    </a:p>
-                  </a:txBody>
-                  <a:tcPr marL="73152" marR="73152" marT="36576" marB="36576" anchor="ctr">
-                    <a:solidFill>
-                      <a:srgbClr val="F1F5F9"/>
-                    </a:solidFill>
-                  </a:tcPr>
-                </a:tc>
-              </a:tr>
-              <a:tr h="658368">
-                <a:tc>
-                  <a:txBody>
-                    <a:bodyPr wrap="square"/>
-                    <a:lstStyle/>
-                    <a:p>
-                      <a:pPr algn="l"/>
-                      <a:r>
-                        <a:rPr sz="1600" b="0" i="0">
+                        <a:rPr sz="1200" b="0" i="0">
                           <a:solidFill>
                             <a:srgbClr val="0F172A"/>
                           </a:solidFill>
@@ -8318,7 +8394,7 @@
                     <a:p>
                       <a:pPr algn="ctr"/>
                       <a:r>
-                        <a:rPr sz="1600" b="0" i="0">
+                        <a:rPr sz="1200" b="0" i="0">
                           <a:solidFill>
                             <a:srgbClr val="0F172A"/>
                           </a:solidFill>
@@ -8341,7 +8417,7 @@
                     <a:p>
                       <a:pPr algn="l"/>
                       <a:r>
-                        <a:rPr sz="1600" b="0" i="0">
+                        <a:rPr sz="1200" b="0" i="0">
                           <a:solidFill>
                             <a:srgbClr val="0F172A"/>
                           </a:solidFill>
@@ -8357,6 +8433,8 @@
                     </a:solidFill>
                   </a:tcPr>
                 </a:tc>
+              </a:tr>
+              <a:tr h="566928">
                 <a:tc>
                   <a:txBody>
                     <a:bodyPr wrap="square"/>
@@ -8364,32 +8442,7 @@
                     <a:p>
                       <a:pPr algn="l"/>
                       <a:r>
-                        <a:rPr sz="1600" b="0" i="0">
-                          <a:solidFill>
-                            <a:srgbClr val="0F172A"/>
-                          </a:solidFill>
-                          <a:latin typeface="Arial"/>
-                        </a:rPr>
-                        <a:t>Read-only live prices and page</a:t>
-                      </a:r>
-                    </a:p>
-                  </a:txBody>
-                  <a:tcPr marL="73152" marR="73152" marT="36576" marB="36576" anchor="ctr">
-                    <a:solidFill>
-                      <a:srgbClr val="FFFFFF"/>
-                    </a:solidFill>
-                  </a:tcPr>
-                </a:tc>
-              </a:tr>
-              <a:tr h="658368">
-                <a:tc>
-                  <a:txBody>
-                    <a:bodyPr wrap="square"/>
-                    <a:lstStyle/>
-                    <a:p>
-                      <a:pPr algn="l"/>
-                      <a:r>
-                        <a:rPr sz="1600" b="0" i="0">
+                        <a:rPr sz="1200" b="0" i="0">
                           <a:solidFill>
                             <a:srgbClr val="0F172A"/>
                           </a:solidFill>
@@ -8412,7 +8465,7 @@
                     <a:p>
                       <a:pPr algn="ctr"/>
                       <a:r>
-                        <a:rPr sz="1600" b="0" i="0">
+                        <a:rPr sz="1200" b="0" i="0">
                           <a:solidFill>
                             <a:srgbClr val="0F172A"/>
                           </a:solidFill>
@@ -8435,7 +8488,7 @@
                     <a:p>
                       <a:pPr algn="l"/>
                       <a:r>
-                        <a:rPr sz="1600" b="0" i="0">
+                        <a:rPr sz="1200" b="0" i="0">
                           <a:solidFill>
                             <a:srgbClr val="0F172A"/>
                           </a:solidFill>
@@ -8451,29 +8504,6 @@
                     </a:solidFill>
                   </a:tcPr>
                 </a:tc>
-                <a:tc>
-                  <a:txBody>
-                    <a:bodyPr wrap="square"/>
-                    <a:lstStyle/>
-                    <a:p>
-                      <a:pPr algn="l"/>
-                      <a:r>
-                        <a:rPr sz="1600" b="0" i="0">
-                          <a:solidFill>
-                            <a:srgbClr val="0F172A"/>
-                          </a:solidFill>
-                          <a:latin typeface="Arial"/>
-                        </a:rPr>
-                        <a:t>As-of replay, M4 / M6, LangGraph agent, gate, walk-forward, Coach, League</a:t>
-                      </a:r>
-                    </a:p>
-                  </a:txBody>
-                  <a:tcPr marL="73152" marR="73152" marT="36576" marB="36576" anchor="ctr">
-                    <a:solidFill>
-                      <a:srgbClr val="F1F5F9"/>
-                    </a:solidFill>
-                  </a:tcPr>
-                </a:tc>
               </a:tr>
             </a:tbl>
           </a:graphicData>
@@ -8481,14 +8511,14 @@
       </p:graphicFrame>
       <p:sp>
         <p:nvSpPr>
-          <p:cNvPr id="8" name="Rounded Rectangle 7"/>
+          <p:cNvPr id="9" name="Rounded Rectangle 8"/>
           <p:cNvSpPr/>
           <p:nvPr/>
         </p:nvSpPr>
         <p:spPr>
           <a:xfrm>
-            <a:off x="457200" y="5440680"/>
-            <a:ext cx="11277295" cy="685800"/>
+            <a:off x="457200" y="5257800"/>
+            <a:ext cx="11277295" cy="960120"/>
           </a:xfrm>
           <a:prstGeom prst="roundRect">
             <a:avLst>
@@ -8527,14 +8557,14 @@
       </p:sp>
       <p:sp>
         <p:nvSpPr>
-          <p:cNvPr id="9" name="TextBox 8"/>
+          <p:cNvPr id="10" name="TextBox 9"/>
           <p:cNvSpPr txBox="1"/>
           <p:nvPr/>
         </p:nvSpPr>
         <p:spPr>
           <a:xfrm>
-            <a:off x="548640" y="5440680"/>
-            <a:ext cx="11094415" cy="685800"/>
+            <a:off x="548640" y="5257800"/>
+            <a:ext cx="11094415" cy="960120"/>
           </a:xfrm>
           <a:prstGeom prst="rect">
             <a:avLst/>
@@ -8553,13 +8583,13 @@
               </a:spcAft>
             </a:pPr>
             <a:r>
-              <a:rPr sz="1900" b="0" i="0">
+              <a:rPr sz="1700" b="0" i="0">
                 <a:solidFill>
                   <a:srgbClr val="0F172A"/>
                 </a:solidFill>
                 <a:latin typeface="Arial"/>
               </a:rPr>
-              <a:t>Every part is graded the same way: by the market's closing price</a:t>
+              <a:t>“A single classifier would do”? The model alone loses −$2,475 over 711 trades; the decision process around it adds +$2,450 [+$854, +$3,984], p = 0.002</a:t>
             </a:r>
           </a:p>
         </p:txBody>
@@ -14727,7 +14757,7 @@
                 </a:solidFill>
                 <a:latin typeface="Arial"/>
               </a:rPr>
-              <a:t>Deep learning: a GRU trained on the market's own moves</a:t>
+              <a:t>Deep learning: four neural parts, graded by the market</a:t>
             </a:r>
           </a:p>
         </p:txBody>
@@ -14810,182 +14840,495 @@
           </a:p>
         </p:txBody>
       </p:sp>
-      <p:sp>
-        <p:nvSpPr>
-          <p:cNvPr id="7" name="TextBox 6"/>
-          <p:cNvSpPr txBox="1"/>
+      <p:graphicFrame>
+        <p:nvGraphicFramePr>
+          <p:cNvPr id="7" name="Table 6"/>
+          <p:cNvGraphicFramePr>
+            <a:graphicFrameLocks noGrp="1"/>
+          </p:cNvGraphicFramePr>
           <p:nvPr/>
-        </p:nvSpPr>
-        <p:spPr>
-          <a:xfrm>
-            <a:off x="457200" y="1143000"/>
-            <a:ext cx="4572000" cy="4114800"/>
-          </a:xfrm>
-          <a:prstGeom prst="rect">
-            <a:avLst/>
-          </a:prstGeom>
-          <a:noFill/>
-        </p:spPr>
-        <p:txBody>
-          <a:bodyPr wrap="square" anchor="t" lIns="73152" rIns="73152" tIns="36576" bIns="36576">
-            <a:spAutoFit/>
-          </a:bodyPr>
-          <a:lstStyle/>
-          <a:p>
-            <a:pPr algn="l">
-              <a:spcAft>
-                <a:spcPts val="400"/>
-              </a:spcAft>
-            </a:pPr>
-            <a:r>
-              <a:rPr sz="1600" b="1" i="0">
-                <a:solidFill>
-                  <a:srgbClr val="1E293B"/>
-                </a:solidFill>
-                <a:latin typeface="Arial"/>
-              </a:rPr>
-              <a:t>M6 design</a:t>
-            </a:r>
-          </a:p>
-          <a:p>
-            <a:pPr algn="l" marL="292608" indent="-256032">
-              <a:spcAft>
-                <a:spcPts val="400"/>
-              </a:spcAft>
-              <a:buChar char="•"/>
-            </a:pPr>
-            <a:r>
-              <a:rPr sz="1600" b="0" i="0">
-                <a:solidFill>
-                  <a:srgbClr val="0F172A"/>
-                </a:solidFill>
-                <a:latin typeface="Arial"/>
-              </a:rPr>
-              <a:t>Label = price move to tip (the market grades it)</a:t>
-            </a:r>
-          </a:p>
-          <a:p>
-            <a:pPr algn="l" marL="292608" indent="-256032">
-              <a:spcAft>
-                <a:spcPts val="400"/>
-              </a:spcAft>
-              <a:buChar char="•"/>
-            </a:pPr>
-            <a:r>
-              <a:rPr sz="1600" b="0" i="0">
-                <a:solidFill>
-                  <a:srgbClr val="0F172A"/>
-                </a:solidFill>
-                <a:latin typeface="Arial"/>
-              </a:rPr>
-              <a:t>GRU-16 over 6 h of prices, 15-min steps</a:t>
-            </a:r>
-          </a:p>
-          <a:p>
-            <a:pPr algn="l" marL="292608" indent="-256032">
-              <a:spcAft>
-                <a:spcPts val="400"/>
-              </a:spcAft>
-              <a:buChar char="•"/>
-            </a:pPr>
-            <a:r>
-              <a:rPr sz="1600" b="0" i="0">
-                <a:solidFill>
-                  <a:srgbClr val="0F172A"/>
-                </a:solidFill>
-                <a:latin typeface="Arial"/>
-              </a:rPr>
-              <a:t>+ 18 static features → MLP → 10 / 50 / 90th percentiles</a:t>
-            </a:r>
-          </a:p>
-          <a:p>
-            <a:pPr algn="l" marL="292608" indent="-256032">
-              <a:spcAft>
-                <a:spcPts val="400"/>
-              </a:spcAft>
-              <a:buChar char="•"/>
-            </a:pPr>
-            <a:r>
-              <a:rPr sz="1600" b="0" i="0">
-                <a:solidFill>
-                  <a:srgbClr val="0F172A"/>
-                </a:solidFill>
-                <a:latin typeface="Arial"/>
-              </a:rPr>
-              <a:t>Pinball loss, early stopping; leak-tested</a:t>
-            </a:r>
-          </a:p>
-          <a:p>
-            <a:pPr algn="l">
-              <a:spcAft>
-                <a:spcPts val="400"/>
-              </a:spcAft>
-            </a:pPr>
-            <a:r>
-              <a:rPr sz="1600" b="1" i="0">
-                <a:solidFill>
-                  <a:srgbClr val="DC2626"/>
-                </a:solidFill>
-                <a:latin typeface="Arial"/>
-              </a:rPr>
-              <a:t>Result</a:t>
-            </a:r>
-          </a:p>
-          <a:p>
-            <a:pPr algn="l" marL="292608" indent="-256032">
-              <a:spcAft>
-                <a:spcPts val="400"/>
-              </a:spcAft>
-              <a:buChar char="•"/>
-            </a:pPr>
-            <a:r>
-              <a:rPr sz="1600" b="0" i="0">
-                <a:solidFill>
-                  <a:srgbClr val="0F172A"/>
-                </a:solidFill>
-                <a:latin typeface="Arial"/>
-              </a:rPr>
-              <a:t>MAE </a:t>
-            </a:r>
-            <a:r>
-              <a:rPr sz="1600" b="1" i="0">
-                <a:solidFill>
-                  <a:srgbClr val="0F172A"/>
-                </a:solidFill>
-                <a:latin typeface="Arial"/>
-              </a:rPr>
-              <a:t>0.867¢</a:t>
-            </a:r>
-            <a:r>
-              <a:rPr sz="1600" b="0" i="0">
-                <a:solidFill>
-                  <a:srgbClr val="0F172A"/>
-                </a:solidFill>
-                <a:latin typeface="Arial"/>
-              </a:rPr>
-              <a:t> vs zero move </a:t>
-            </a:r>
-            <a:r>
-              <a:rPr sz="1600" b="1" i="0">
-                <a:solidFill>
-                  <a:srgbClr val="0F172A"/>
-                </a:solidFill>
-                <a:latin typeface="Arial"/>
-              </a:rPr>
-              <a:t>0.833¢</a:t>
-            </a:r>
-            <a:r>
-              <a:rPr sz="1600" b="0" i="0">
-                <a:solidFill>
-                  <a:srgbClr val="0F172A"/>
-                </a:solidFill>
-                <a:latin typeface="Arial"/>
-              </a:rPr>
-              <a:t>; agent makes 0 trades</a:t>
-            </a:r>
-          </a:p>
-        </p:txBody>
-      </p:sp>
+        </p:nvGraphicFramePr>
+        <p:xfrm>
+          <a:off x="457200" y="1143000"/>
+          <a:ext cx="7223760" cy="3200400"/>
+        </p:xfrm>
+        <a:graphic>
+          <a:graphicData uri="http://schemas.openxmlformats.org/drawingml/2006/table">
+            <a:tbl>
+              <a:tblPr firstRow="1" bandRow="1">
+                <a:tableStyleId>{5C22544A-7EE6-4342-B048-85BDC9FD1C3A}</a:tableStyleId>
+              </a:tblPr>
+              <a:tblGrid>
+                <a:gridCol w="1828800"/>
+                <a:gridCol w="2743200"/>
+                <a:gridCol w="2651760"/>
+              </a:tblGrid>
+              <a:tr h="365760">
+                <a:tc>
+                  <a:txBody>
+                    <a:bodyPr wrap="square"/>
+                    <a:lstStyle/>
+                    <a:p>
+                      <a:pPr algn="l"/>
+                      <a:r>
+                        <a:rPr sz="1300" b="1" i="0">
+                          <a:solidFill>
+                            <a:srgbClr val="FFFFFF"/>
+                          </a:solidFill>
+                          <a:latin typeface="Arial"/>
+                        </a:rPr>
+                        <a:t>Neural part</a:t>
+                      </a:r>
+                    </a:p>
+                  </a:txBody>
+                  <a:tcPr marL="73152" marR="73152" marT="36576" marB="36576" anchor="ctr">
+                    <a:solidFill>
+                      <a:srgbClr val="1E293B"/>
+                    </a:solidFill>
+                  </a:tcPr>
+                </a:tc>
+                <a:tc>
+                  <a:txBody>
+                    <a:bodyPr wrap="square"/>
+                    <a:lstStyle/>
+                    <a:p>
+                      <a:pPr algn="l"/>
+                      <a:r>
+                        <a:rPr sz="1300" b="1" i="0">
+                          <a:solidFill>
+                            <a:srgbClr val="FFFFFF"/>
+                          </a:solidFill>
+                          <a:latin typeface="Arial"/>
+                        </a:rPr>
+                        <a:t>Design</a:t>
+                      </a:r>
+                    </a:p>
+                  </a:txBody>
+                  <a:tcPr marL="73152" marR="73152" marT="36576" marB="36576" anchor="ctr">
+                    <a:solidFill>
+                      <a:srgbClr val="1E293B"/>
+                    </a:solidFill>
+                  </a:tcPr>
+                </a:tc>
+                <a:tc>
+                  <a:txBody>
+                    <a:bodyPr wrap="square"/>
+                    <a:lstStyle/>
+                    <a:p>
+                      <a:pPr algn="l"/>
+                      <a:r>
+                        <a:rPr sz="1300" b="1" i="0">
+                          <a:solidFill>
+                            <a:srgbClr val="FFFFFF"/>
+                          </a:solidFill>
+                          <a:latin typeface="Arial"/>
+                        </a:rPr>
+                        <a:t>Market-graded result</a:t>
+                      </a:r>
+                    </a:p>
+                  </a:txBody>
+                  <a:tcPr marL="73152" marR="73152" marT="36576" marB="36576" anchor="ctr">
+                    <a:solidFill>
+                      <a:srgbClr val="1E293B"/>
+                    </a:solidFill>
+                  </a:tcPr>
+                </a:tc>
+              </a:tr>
+              <a:tr h="566928">
+                <a:tc>
+                  <a:txBody>
+                    <a:bodyPr wrap="square"/>
+                    <a:lstStyle/>
+                    <a:p>
+                      <a:pPr algn="l"/>
+                      <a:r>
+                        <a:rPr sz="1300" b="0" i="0">
+                          <a:solidFill>
+                            <a:srgbClr val="0F172A"/>
+                          </a:solidFill>
+                          <a:latin typeface="Arial"/>
+                        </a:rPr>
+                        <a:t>M2 player GRU</a:t>
+                      </a:r>
+                    </a:p>
+                  </a:txBody>
+                  <a:tcPr marL="73152" marR="73152" marT="36576" marB="36576" anchor="ctr">
+                    <a:solidFill>
+                      <a:srgbClr val="F1F5F9"/>
+                    </a:solidFill>
+                  </a:tcPr>
+                </a:tc>
+                <a:tc>
+                  <a:txBody>
+                    <a:bodyPr wrap="square"/>
+                    <a:lstStyle/>
+                    <a:p>
+                      <a:pPr algn="l"/>
+                      <a:r>
+                        <a:rPr sz="1300" b="0" i="0">
+                          <a:solidFill>
+                            <a:srgbClr val="0F172A"/>
+                          </a:solidFill>
+                          <a:latin typeface="Arial"/>
+                        </a:rPr>
+                        <a:t>GRU over last 20 games → pts / min quantiles</a:t>
+                      </a:r>
+                    </a:p>
+                  </a:txBody>
+                  <a:tcPr marL="73152" marR="73152" marT="36576" marB="36576" anchor="ctr">
+                    <a:solidFill>
+                      <a:srgbClr val="F1F5F9"/>
+                    </a:solidFill>
+                  </a:tcPr>
+                </a:tc>
+                <a:tc>
+                  <a:txBody>
+                    <a:bodyPr wrap="square"/>
+                    <a:lstStyle/>
+                    <a:p>
+                      <a:pPr algn="l"/>
+                      <a:r>
+                        <a:rPr sz="1300" b="1" i="0">
+                          <a:solidFill>
+                            <a:srgbClr val="0F172A"/>
+                          </a:solidFill>
+                          <a:latin typeface="Arial"/>
+                        </a:rPr>
+                        <a:t>Beats GBM:</a:t>
+                      </a:r>
+                      <a:r>
+                        <a:rPr sz="1300" b="0" i="0">
+                          <a:solidFill>
+                            <a:srgbClr val="0F172A"/>
+                          </a:solidFill>
+                          <a:latin typeface="Arial"/>
+                        </a:rPr>
+                        <a:t> pinball 1.55 vs 1.59</a:t>
+                      </a:r>
+                    </a:p>
+                  </a:txBody>
+                  <a:tcPr marL="73152" marR="73152" marT="36576" marB="36576" anchor="ctr">
+                    <a:solidFill>
+                      <a:srgbClr val="F1F5F9"/>
+                    </a:solidFill>
+                  </a:tcPr>
+                </a:tc>
+              </a:tr>
+              <a:tr h="566928">
+                <a:tc>
+                  <a:txBody>
+                    <a:bodyPr wrap="square"/>
+                    <a:lstStyle/>
+                    <a:p>
+                      <a:pPr algn="l"/>
+                      <a:r>
+                        <a:rPr sz="1300" b="0" i="0">
+                          <a:solidFill>
+                            <a:srgbClr val="0F172A"/>
+                          </a:solidFill>
+                          <a:latin typeface="Arial"/>
+                        </a:rPr>
+                        <a:t>M4-NN win MLP</a:t>
+                      </a:r>
+                    </a:p>
+                  </a:txBody>
+                  <a:tcPr marL="73152" marR="73152" marT="36576" marB="36576" anchor="ctr">
+                    <a:solidFill>
+                      <a:srgbClr val="FFFFFF"/>
+                    </a:solidFill>
+                  </a:tcPr>
+                </a:tc>
+                <a:tc>
+                  <a:txBody>
+                    <a:bodyPr wrap="square"/>
+                    <a:lstStyle/>
+                    <a:p>
+                      <a:pPr algn="l"/>
+                      <a:r>
+                        <a:rPr sz="1300" b="0" i="0">
+                          <a:solidFill>
+                            <a:srgbClr val="0F172A"/>
+                          </a:solidFill>
+                          <a:latin typeface="Arial"/>
+                        </a:rPr>
+                        <a:t>M4's 6 features, BCE, early stop, 3 seeds</a:t>
+                      </a:r>
+                    </a:p>
+                  </a:txBody>
+                  <a:tcPr marL="73152" marR="73152" marT="36576" marB="36576" anchor="ctr">
+                    <a:solidFill>
+                      <a:srgbClr val="FFFFFF"/>
+                    </a:solidFill>
+                  </a:tcPr>
+                </a:tc>
+                <a:tc>
+                  <a:txBody>
+                    <a:bodyPr wrap="square"/>
+                    <a:lstStyle/>
+                    <a:p>
+                      <a:pPr algn="l"/>
+                      <a:r>
+                        <a:rPr sz="1300" b="0" i="0">
+                          <a:solidFill>
+                            <a:srgbClr val="0F172A"/>
+                          </a:solidFill>
+                          <a:latin typeface="Arial"/>
+                        </a:rPr>
+                        <a:t>Brier 0.184 vs M4 0.183: tie</a:t>
+                      </a:r>
+                    </a:p>
+                  </a:txBody>
+                  <a:tcPr marL="73152" marR="73152" marT="36576" marB="36576" anchor="ctr">
+                    <a:solidFill>
+                      <a:srgbClr val="FFFFFF"/>
+                    </a:solidFill>
+                  </a:tcPr>
+                </a:tc>
+              </a:tr>
+              <a:tr h="566928">
+                <a:tc>
+                  <a:txBody>
+                    <a:bodyPr wrap="square"/>
+                    <a:lstStyle/>
+                    <a:p>
+                      <a:pPr algn="l"/>
+                      <a:r>
+                        <a:rPr sz="1300" b="0" i="0">
+                          <a:solidFill>
+                            <a:srgbClr val="0F172A"/>
+                          </a:solidFill>
+                          <a:latin typeface="Arial"/>
+                        </a:rPr>
+                        <a:t>Anchor + NN shift</a:t>
+                      </a:r>
+                    </a:p>
+                  </a:txBody>
+                  <a:tcPr marL="73152" marR="73152" marT="36576" marB="36576" anchor="ctr">
+                    <a:solidFill>
+                      <a:srgbClr val="F1F5F9"/>
+                    </a:solidFill>
+                  </a:tcPr>
+                </a:tc>
+                <a:tc>
+                  <a:txBody>
+                    <a:bodyPr wrap="square"/>
+                    <a:lstStyle/>
+                    <a:p>
+                      <a:pPr algn="l"/>
+                      <a:r>
+                        <a:rPr sz="1300" b="0" i="0">
+                          <a:solidFill>
+                            <a:srgbClr val="0F172A"/>
+                          </a:solidFill>
+                          <a:latin typeface="Arial"/>
+                        </a:rPr>
+                        <a:t>24 h mid + MLP news shift</a:t>
+                      </a:r>
+                    </a:p>
+                  </a:txBody>
+                  <a:tcPr marL="73152" marR="73152" marT="36576" marB="36576" anchor="ctr">
+                    <a:solidFill>
+                      <a:srgbClr val="F1F5F9"/>
+                    </a:solidFill>
+                  </a:tcPr>
+                </a:tc>
+                <a:tc>
+                  <a:txBody>
+                    <a:bodyPr wrap="square"/>
+                    <a:lstStyle/>
+                    <a:p>
+                      <a:pPr algn="l"/>
+                      <a:r>
+                        <a:rPr sz="1300" b="0" i="0">
+                          <a:solidFill>
+                            <a:srgbClr val="0F172A"/>
+                          </a:solidFill>
+                          <a:latin typeface="Arial"/>
+                        </a:rPr>
+                        <a:t>Brier </a:t>
+                      </a:r>
+                      <a:r>
+                        <a:rPr sz="1300" b="1" i="0">
+                          <a:solidFill>
+                            <a:srgbClr val="0F172A"/>
+                          </a:solidFill>
+                          <a:latin typeface="Arial"/>
+                        </a:rPr>
+                        <a:t>0.163</a:t>
+                      </a:r>
+                      <a:r>
+                        <a:rPr sz="1300" b="0" i="0">
+                          <a:solidFill>
+                            <a:srgbClr val="0F172A"/>
+                          </a:solidFill>
+                          <a:latin typeface="Arial"/>
+                        </a:rPr>
+                        <a:t> vs market 0.164: level</a:t>
+                      </a:r>
+                    </a:p>
+                  </a:txBody>
+                  <a:tcPr marL="73152" marR="73152" marT="36576" marB="36576" anchor="ctr">
+                    <a:solidFill>
+                      <a:srgbClr val="F1F5F9"/>
+                    </a:solidFill>
+                  </a:tcPr>
+                </a:tc>
+              </a:tr>
+              <a:tr h="566928">
+                <a:tc>
+                  <a:txBody>
+                    <a:bodyPr wrap="square"/>
+                    <a:lstStyle/>
+                    <a:p>
+                      <a:pPr algn="l"/>
+                      <a:r>
+                        <a:rPr sz="1300" b="0" i="0">
+                          <a:solidFill>
+                            <a:srgbClr val="0F172A"/>
+                          </a:solidFill>
+                          <a:latin typeface="Arial"/>
+                        </a:rPr>
+                        <a:t>M6 impact GRU</a:t>
+                      </a:r>
+                    </a:p>
+                  </a:txBody>
+                  <a:tcPr marL="73152" marR="73152" marT="36576" marB="36576" anchor="ctr">
+                    <a:solidFill>
+                      <a:srgbClr val="FFFFFF"/>
+                    </a:solidFill>
+                  </a:tcPr>
+                </a:tc>
+                <a:tc>
+                  <a:txBody>
+                    <a:bodyPr wrap="square"/>
+                    <a:lstStyle/>
+                    <a:p>
+                      <a:pPr algn="l"/>
+                      <a:r>
+                        <a:rPr sz="1300" b="0" i="0">
+                          <a:solidFill>
+                            <a:srgbClr val="0F172A"/>
+                          </a:solidFill>
+                          <a:latin typeface="Arial"/>
+                        </a:rPr>
+                        <a:t>6 h prices + 18 features → quantiles</a:t>
+                      </a:r>
+                    </a:p>
+                  </a:txBody>
+                  <a:tcPr marL="73152" marR="73152" marT="36576" marB="36576" anchor="ctr">
+                    <a:solidFill>
+                      <a:srgbClr val="FFFFFF"/>
+                    </a:solidFill>
+                  </a:tcPr>
+                </a:tc>
+                <a:tc>
+                  <a:txBody>
+                    <a:bodyPr wrap="square"/>
+                    <a:lstStyle/>
+                    <a:p>
+                      <a:pPr algn="l"/>
+                      <a:r>
+                        <a:rPr sz="1300" b="1" i="0">
+                          <a:solidFill>
+                            <a:srgbClr val="0F172A"/>
+                          </a:solidFill>
+                          <a:latin typeface="Arial"/>
+                        </a:rPr>
+                        <a:t>Fails:</a:t>
+                      </a:r>
+                      <a:r>
+                        <a:rPr sz="1300" b="0" i="0">
+                          <a:solidFill>
+                            <a:srgbClr val="0F172A"/>
+                          </a:solidFill>
+                          <a:latin typeface="Arial"/>
+                        </a:rPr>
+                        <a:t> 9 of 9 configs worse than zero move</a:t>
+                      </a:r>
+                    </a:p>
+                  </a:txBody>
+                  <a:tcPr marL="73152" marR="73152" marT="36576" marB="36576" anchor="ctr">
+                    <a:solidFill>
+                      <a:srgbClr val="FFFFFF"/>
+                    </a:solidFill>
+                  </a:tcPr>
+                </a:tc>
+              </a:tr>
+              <a:tr h="566928">
+                <a:tc>
+                  <a:txBody>
+                    <a:bodyPr wrap="square"/>
+                    <a:lstStyle/>
+                    <a:p>
+                      <a:pPr algn="l"/>
+                      <a:r>
+                        <a:rPr sz="1300" b="0" i="0">
+                          <a:solidFill>
+                            <a:srgbClr val="0F172A"/>
+                          </a:solidFill>
+                          <a:latin typeface="Arial"/>
+                        </a:rPr>
+                        <a:t>LLM tool agent</a:t>
+                      </a:r>
+                    </a:p>
+                  </a:txBody>
+                  <a:tcPr marL="73152" marR="73152" marT="36576" marB="36576" anchor="ctr">
+                    <a:solidFill>
+                      <a:srgbClr val="F1F5F9"/>
+                    </a:solidFill>
+                  </a:tcPr>
+                </a:tc>
+                <a:tc>
+                  <a:txBody>
+                    <a:bodyPr wrap="square"/>
+                    <a:lstStyle/>
+                    <a:p>
+                      <a:pPr algn="l"/>
+                      <a:r>
+                        <a:rPr sz="1300" b="0" i="0">
+                          <a:solidFill>
+                            <a:srgbClr val="0F172A"/>
+                          </a:solidFill>
+                          <a:latin typeface="Arial"/>
+                        </a:rPr>
+                        <a:t>Transformer as policy; code guardrails</a:t>
+                      </a:r>
+                    </a:p>
+                  </a:txBody>
+                  <a:tcPr marL="73152" marR="73152" marT="36576" marB="36576" anchor="ctr">
+                    <a:solidFill>
+                      <a:srgbClr val="F1F5F9"/>
+                    </a:solidFill>
+                  </a:tcPr>
+                </a:tc>
+                <a:tc>
+                  <a:txBody>
+                    <a:bodyPr wrap="square"/>
+                    <a:lstStyle/>
+                    <a:p>
+                      <a:pPr algn="l"/>
+                      <a:r>
+                        <a:rPr sz="1300" b="0" i="0">
+                          <a:solidFill>
+                            <a:srgbClr val="0F172A"/>
+                          </a:solidFill>
+                          <a:latin typeface="Arial"/>
+                        </a:rPr>
+                        <a:t>Slide 11: helps only by trading less</a:t>
+                      </a:r>
+                    </a:p>
+                  </a:txBody>
+                  <a:tcPr marL="73152" marR="73152" marT="36576" marB="36576" anchor="ctr">
+                    <a:solidFill>
+                      <a:srgbClr val="F1F5F9"/>
+                    </a:solidFill>
+                  </a:tcPr>
+                </a:tc>
+              </a:tr>
+            </a:tbl>
+          </a:graphicData>
+        </a:graphic>
+      </p:graphicFrame>
       <p:pic>
         <p:nvPicPr>
           <p:cNvPr id="8" name="Picture 7" descr="m6_robustness.png"/>
@@ -15002,48 +15345,24 @@
         </p:blipFill>
         <p:spPr>
           <a:xfrm>
-            <a:off x="5120640" y="1206550"/>
-            <a:ext cx="6613855" cy="2204618"/>
+            <a:off x="7863840" y="2143810"/>
+            <a:ext cx="3870655" cy="1290218"/>
           </a:xfrm>
           <a:prstGeom prst="rect">
             <a:avLst/>
           </a:prstGeom>
         </p:spPr>
       </p:pic>
-      <p:pic>
-        <p:nvPicPr>
-          <p:cNvPr id="9" name="Picture 8" descr="m6_vs_baselines.png"/>
-          <p:cNvPicPr>
-            <a:picLocks noChangeAspect="1"/>
-          </p:cNvPicPr>
-          <p:nvPr/>
-        </p:nvPicPr>
-        <p:blipFill>
-          <a:blip r:embed="rId4"/>
-          <a:stretch>
-            <a:fillRect/>
-          </a:stretch>
-        </p:blipFill>
-        <p:spPr>
-          <a:xfrm>
-            <a:off x="5445828" y="3520439"/>
-            <a:ext cx="5963478" cy="1828800"/>
-          </a:xfrm>
-          <a:prstGeom prst="rect">
-            <a:avLst/>
-          </a:prstGeom>
-        </p:spPr>
-      </p:pic>
-      <p:sp>
-        <p:nvSpPr>
-          <p:cNvPr id="10" name="TextBox 9"/>
+      <p:sp>
+        <p:nvSpPr>
+          <p:cNvPr id="9" name="TextBox 8"/>
           <p:cNvSpPr txBox="1"/>
           <p:nvPr/>
         </p:nvSpPr>
         <p:spPr>
           <a:xfrm>
-            <a:off x="457200" y="5212080"/>
-            <a:ext cx="11277295" cy="566928"/>
+            <a:off x="457200" y="5074920"/>
+            <a:ext cx="11277295" cy="640080"/>
           </a:xfrm>
           <a:prstGeom prst="rect">
             <a:avLst/>
@@ -15062,36 +15381,36 @@
               </a:spcAft>
             </a:pPr>
             <a:r>
-              <a:rPr sz="1600" b="1" i="0">
+              <a:rPr sz="1500" b="1" i="0">
                 <a:solidFill>
                   <a:srgbClr val="0F172A"/>
                 </a:solidFill>
                 <a:latin typeface="Arial"/>
               </a:rPr>
-              <a:t>Robustness:</a:t>
-            </a:r>
-            <a:r>
-              <a:rPr sz="1600" b="0" i="0">
+              <a:t>Why small and quantile:</a:t>
+            </a:r>
+            <a:r>
+              <a:rPr sz="1500" b="0" i="0">
                 <a:solidFill>
                   <a:srgbClr val="0F172A"/>
                 </a:solidFill>
                 <a:latin typeface="Arial"/>
               </a:rPr>
-              <a:t> 9 configurations × 3 seeds, all worse than zero move (best +0.017¢); none predicts the 5.5¢ needed to trade</a:t>
-            </a:r>
-          </a:p>
-        </p:txBody>
-      </p:sp>
-      <p:sp>
-        <p:nvSpPr>
-          <p:cNvPr id="11" name="TextBox 10"/>
+              <a:t> ~3.4k training games, 3.9M price rows but only ~600 training games of them; GRU-8/16 with early stopping; pinball loss gives a 10–90% band, not a point bet</a:t>
+            </a:r>
+          </a:p>
+        </p:txBody>
+      </p:sp>
+      <p:sp>
+        <p:nvSpPr>
+          <p:cNvPr id="10" name="TextBox 9"/>
           <p:cNvSpPr txBox="1"/>
           <p:nvPr/>
         </p:nvSpPr>
         <p:spPr>
           <a:xfrm>
-            <a:off x="457200" y="5788152"/>
-            <a:ext cx="11277295" cy="566928"/>
+            <a:off x="457200" y="5742432"/>
+            <a:ext cx="11277295" cy="594360"/>
           </a:xfrm>
           <a:prstGeom prst="rect">
             <a:avLst/>
@@ -15110,22 +15429,22 @@
               </a:spcAft>
             </a:pPr>
             <a:r>
-              <a:rPr sz="1600" b="1" i="0">
+              <a:rPr sz="1500" b="1" i="0">
                 <a:solidFill>
                   <a:srgbClr val="0F172A"/>
                 </a:solidFill>
                 <a:latin typeface="Arial"/>
               </a:rPr>
-              <a:t>M4 recalibration:</a:t>
-            </a:r>
-            <a:r>
-              <a:rPr sz="1600" b="0" i="0">
+              <a:t>Null results are the finding:</a:t>
+            </a:r>
+            <a:r>
+              <a:rPr sz="1500" b="0" i="0">
                 <a:solidFill>
                   <a:srgbClr val="0F172A"/>
                 </a:solidFill>
                 <a:latin typeface="Arial"/>
               </a:rPr>
-              <a:t> Brier 0.183 raw, 0.185 Platt, 0.184 isotonic vs market 0.164; miscalibration changes with season phase</a:t>
+              <a:t> in an efficient market, “no move” and the market's own price are hard baselines; deep learning helps only next to the anchor</a:t>
             </a:r>
           </a:p>
         </p:txBody>

</xml_diff>

<commit_message>
Deck: 'How the agent works' slide with architecture figure (decide/learn loops, guardrails, market as grader, CLE@POR walk-through); merge costs and speed evidence; why-agentic refers to the architecture
Co-authored-by: Cursor <cursoragent@cursor.com>
</commit_message>
<xml_diff>
--- a/presentation/nba_agent_deck.pptx
+++ b/presentation/nba_agent_deck.pptx
@@ -796,7 +796,7 @@
           <a:lstStyle/>
           <a:p>
             <a:r>
-              <a:t>Why an agent and not one classifier? The problem is event-driven: news arrives at random times and 91% of the move comes before the inactive list, about two-thirds before the first official report, so the hard decision is when to act; the agent's trigger, investigate, decide loop makes that decision. It uses tools over as-of data, prices, news, rotations and models, and the tools enforce no look-ahead. Decisions are multi-step with code checks, risk caps and a kill switch, which matters for gambling harm. Learning is graded by the market through the gate, and the placebo shows honestly that it works by trading less. The Coach and League turn the analysis into education, and the orchestrator ties the team's parts together. The counter-argument, a single classifier would do, is answered by our own data: the model alone loses −$2,475 over 711 trades; the decision process around it, anchoring, thresholds and abstention, adds +$2,450, p 0.002. The work is split across the team. The pregame news loop polls several news sources before a game and turns them into fair odds, pull request 7. The player-feature experiment tested isolated player features and probability calibration, pull request 8. In-play news and odds updates are pull request 9. Live, read-only Polymarket prices are pull requests 11 and 12. The replay, the agent, the models M4 and M6, the evaluation, the Coach and the League are on our main branch. Each part had to face the same market grade.</a:t>
+              <a:t>Why an agent and not one classifier? Each box of the slide 4 diagram answers a feature of the problem. The problem is event-driven: news arrives at random times and 91% of the move comes before the inactive list, about two-thirds before the first official report, so the hard decision is when to act; that is the trigger. What to look at is the as-of tools, which enforce no look-ahead. Whether to trade is the edge test and the LLM sceptic, and the code checks, risk caps and kill switch make sure the LLM can never override a limit, which matters for gambling harm. The learn loop is graded by the market through the gate, and the placebo shows honestly that it works by trading less. The Coach and League are the people in the loop. The counter-argument, a single classifier would do, is answered by our own data: the model alone loses −$2,475 over 711 trades; the decision process around it, the diagram's anchor, edge threshold and pass, adds +$2,450, p 0.002. The work is split across the team. The pregame news loop polls several news sources before a game and turns them into fair odds, pull request 7. The player-feature experiment tested isolated player features and probability calibration, pull request 8. In-play news and odds updates are pull request 9. Live, read-only Polymarket prices are pull requests 11 and 12. The replay, the agent, the models M4 and M6, the evaluation, the Coach and the League are on our main branch. Each part had to face the same market grade.</a:t>
             </a:r>
           </a:p>
         </p:txBody>
@@ -1146,7 +1146,7 @@
           <a:lstStyle/>
           <a:p>
             <a:r>
-              <a:t>This is what the title means. Every component is a hypothesis that must pass an evidence gate on recorded prices, and the grader is the market's closing price. The raw win model fails: −$2,475 over the season, and recalibrating it does not help. The neural impact model fails: all 9 configurations are worse than predicting no move. What passes defers to the market: the market anchor, +$2,450 with p 0.002, and gated learning, which passes only by trading less. The newer agentic parts face the same gate; slide 11. So the finding is the product: if a disciplined agent cannot beat the close, a consumer cannot either. We say “we pass” as often as “we trade”.</a:t>
+              <a:t>This is the agent. The top row is the decide loop, a LangGraph graph. A trigger, news or the clock an hour before tip, wakes it; it then chooses which as-of tools to call, prices, news, rotations, and our models M4 and M6, which only see what was public. It estimates a probability, the market anchor plus the model's news shift, or an LLM analyst; trades only if the gap after spread and fee is at least 4 cents; an LLM sceptic asks whether the news is already priced in and can veto; code re-checks every number; risk caps and a kill switch the LLM cannot override; then a confirm step, and an order or, about 90% of the time, a pass with the reason. One example: CLE at POR. Deni Avdija is out, 32.8 minutes and 26 points a game. M4's shift is −8.7 points, so the anchor of 42.5% becomes 33.8%. The agent bought POR “no” at 55¢, fee 1.73¢, a gap of 9.5¢ after costs, 36 contracts. The close was 62.5¢: closing-line value +7.5¢, profit +$15.57. The bottom row is the learn loop: at the close every trade is settled and graded by CLV, a reviewer proposes one rule, and the gate keeps it only if it helps on held-out days; kept rules feed back into the decision. The Coach and League turn the same analysis into education. The closing price grades every box.</a:t>
             </a:r>
           </a:p>
         </p:txBody>
@@ -1216,7 +1216,7 @@
           <a:lstStyle/>
           <a:p>
             <a:r>
-              <a:t>The data is all public. From Kalshi: every NBA game-winner market for 2025-26, 2,632 markets on 1,316 games, 3,938,368 one-minute rows of bid, ask and volume, and settlements. From ESPN: three seasons of games, 85,422 box-score rows and 3,371 inactive-list entries, which are our news. Models train on games before 1 February; the agent develops on November to January; the test period is 1 February to 12 April, 501 games; the walk-forward retrains monthly; and the 87 play-off games are a holdout scored once. The replay shows the agent only what was public, counts each inactive list as news 30 minutes before tip, and fills at the recorded ask plus the Kalshi fee.</a:t>
+              <a:t>This is what the title means. Every component is a hypothesis that must pass an evidence gate on recorded prices, and the grader is the market's closing price. The raw win model fails: −$2,475 over the season, and recalibrating it does not help. The neural impact model fails: all 9 configurations are worse than predicting no move. What passes defers to the market: the market anchor, +$2,450 with p 0.002, and gated learning, which passes only by trading less. The newer agentic parts face the same gate; slide 11. So the finding is the product: if a disciplined agent cannot beat the close, a consumer cannot either. We say “we pass” as often as “we trade”.</a:t>
             </a:r>
           </a:p>
         </p:txBody>
@@ -1286,7 +1286,7 @@
           <a:lstStyle/>
           <a:p>
             <a:r>
-              <a:t>First, costs. One hour before tip a $20 order pays half the bid-ask spread plus the Kalshi fee: 1.92 cents per contract on average, 5.0% of the price, and 9–14% on cheap contracts. Our best agent would have made +$36 at the mid but lost −$32 after costs. Even very selective, 74 trades out of 771 decision points, only 27 (36%) beat or matched the closing price.</a:t>
+              <a:t>The data is all public. From Kalshi: every NBA game-winner market for 2025-26, 2,632 markets on 1,316 games, 3,938,368 one-minute rows of bid, ask and volume, and settlements. From ESPN: three seasons of games, 85,422 box-score rows and 3,371 inactive-list entries, which are our news. Models train on games before 1 February; the agent develops on November to January; the test period is 1 February to 12 April, 501 games; the walk-forward retrains monthly; and the 87 play-off games are a holdout scored once. The replay shows the agent only what was public, counts each inactive list as news 30 minutes before tip, and fills at the recorded ask plus the Kalshi fee.</a:t>
             </a:r>
           </a:p>
         </p:txBody>
@@ -1356,7 +1356,7 @@
           <a:lstStyle/>
           <a:p>
             <a:r>
-              <a:t>Second, speed. On the 193 test games where the inactive list moved our win model by at least a point, 91% of the price move in the news direction happened before the inactive list, which is when a retail user reading it could act. We then matched the official NBA injury reports: about two-thirds of the move, 67% with a confidence interval of 47–85%, came before the first official report listing the player out, which itself comes a median of about 6 hours before the inactive list. Assuming no publication lag the share is 49%. Official reports only; beat reporters and social media can be earlier still.</a:t>
+              <a:t>First, costs. One hour before tip a $20 order pays half the bid-ask spread plus the Kalshi fee: 1.92 cents per contract on average, 5.0% of the price, and 9–14% on cheap contracts. Our best agent would have made +$36 at the mid but lost −$32 after costs; only 27 (36%) of its 74 trades beat or matched the close. Second, speed. On the 193 test games where the inactive list moved our win model by at least a point, 91% of the price move in the news direction happened before the inactive list, when a retail user could act. Against the official NBA injury reports, about two-thirds, 67% with a confidence interval of 47–85%, came before the first report listing the player out, which comes about 6 hours before the inactive list; 49% assuming no publication lag. These two facts are why the agent passes by default and why its trigger matters.</a:t>
             </a:r>
           </a:p>
         </p:txBody>
@@ -4879,7 +4879,7 @@
                 </a:solidFill>
                 <a:latin typeface="Arial"/>
               </a:rPr>
-              <a:t>Evidence 4: every line drifts down; never trading wins</a:t>
+              <a:t>Evidence 3: every line drifts down; never trading wins</a:t>
             </a:r>
           </a:p>
         </p:txBody>
@@ -7921,7 +7921,7 @@
                 </a:solidFill>
                 <a:latin typeface="Arial"/>
               </a:rPr>
-              <a:t>Why agentic: the problem's structure</a:t>
+              <a:t>Why agentic: each box of slide 4 answers the problem</a:t>
             </a:r>
           </a:p>
           <a:p>
@@ -7938,7 +7938,7 @@
                 </a:solidFill>
                 <a:latin typeface="Arial"/>
               </a:rPr>
-              <a:t>When to act:</a:t>
+              <a:t>When to act = trigger:</a:t>
             </a:r>
             <a:r>
               <a:rPr sz="1500" b="0" i="0">
@@ -7947,7 +7947,7 @@
                 </a:solidFill>
                 <a:latin typeface="Arial"/>
               </a:rPr>
-              <a:t> news is asynchronous; 91% of the move before the inactive list, ~⅔ before the first report → trigger → investigate → decide</a:t>
+              <a:t> news is asynchronous; 91% of the move before the inactive list, ~⅔ before the first report</a:t>
             </a:r>
           </a:p>
           <a:p>
@@ -7964,7 +7964,7 @@
                 </a:solidFill>
                 <a:latin typeface="Arial"/>
               </a:rPr>
-              <a:t>Tools over as-of data:</a:t>
+              <a:t>What to look at = as-of tools:</a:t>
             </a:r>
             <a:r>
               <a:rPr sz="1500" b="0" i="0">
@@ -7973,7 +7973,7 @@
                 </a:solidFill>
                 <a:latin typeface="Arial"/>
               </a:rPr>
-              <a:t> prices, news, rotations, models; no look-ahead</a:t>
+              <a:t> prices, news, rotations, M4 / M6; no look-ahead</a:t>
             </a:r>
           </a:p>
           <a:p>
@@ -7990,7 +7990,7 @@
                 </a:solidFill>
                 <a:latin typeface="Arial"/>
               </a:rPr>
-              <a:t>Multi-step + safety:</a:t>
+              <a:t>Whether to trade = edge + sceptic:</a:t>
             </a:r>
             <a:r>
               <a:rPr sz="1500" b="0" i="0">
@@ -7999,7 +7999,7 @@
                 </a:solidFill>
                 <a:latin typeface="Arial"/>
               </a:rPr>
-              <a:t> checks, risk caps, kill switch, blocked orders</a:t>
+              <a:t> code checks, risk caps, kill switch; LLM can't override</a:t>
             </a:r>
           </a:p>
           <a:p>
@@ -8016,7 +8016,7 @@
                 </a:solidFill>
                 <a:latin typeface="Arial"/>
               </a:rPr>
-              <a:t>Market-graded learning:</a:t>
+              <a:t>Learn loop:</a:t>
             </a:r>
             <a:r>
               <a:rPr sz="1500" b="0" i="0">
@@ -8025,7 +8025,7 @@
                 </a:solidFill>
                 <a:latin typeface="Arial"/>
               </a:rPr>
-              <a:t> review → gate → rules; placebo-audited</a:t>
+              <a:t> CLV → reviewer → held-out gate → rules; placebo-audited</a:t>
             </a:r>
           </a:p>
           <a:p>
@@ -8042,7 +8042,7 @@
                 </a:solidFill>
                 <a:latin typeface="Arial"/>
               </a:rPr>
-              <a:t>Human in the loop:</a:t>
+              <a:t>People:</a:t>
             </a:r>
             <a:r>
               <a:rPr sz="1500" b="0" i="0">
@@ -8051,7 +8051,7 @@
                 </a:solidFill>
                 <a:latin typeface="Arial"/>
               </a:rPr>
-              <a:t> Coach and League teach; orchestrator joins the team's parts</a:t>
+              <a:t> Coach and League teach with the same analysis</a:t>
             </a:r>
           </a:p>
         </p:txBody>
@@ -11636,7 +11636,7 @@
                 </a:solidFill>
                 <a:latin typeface="Arial"/>
               </a:rPr>
-              <a:t>Market-Graded Learning: the closing price is the grader</a:t>
+              <a:t>How the agent works: decide, learn, graded by the close</a:t>
             </a:r>
           </a:p>
         </p:txBody>
@@ -11715,6 +11715,647 @@
                 <a:latin typeface="Arial"/>
               </a:rPr>
               <a:t>4</a:t>
+            </a:r>
+          </a:p>
+        </p:txBody>
+      </p:sp>
+      <p:pic>
+        <p:nvPicPr>
+          <p:cNvPr id="7" name="Picture 6" descr="agent_architecture.png"/>
+          <p:cNvPicPr>
+            <a:picLocks noChangeAspect="1"/>
+          </p:cNvPicPr>
+          <p:nvPr/>
+        </p:nvPicPr>
+        <p:blipFill>
+          <a:blip r:embed="rId3"/>
+          <a:stretch>
+            <a:fillRect/>
+          </a:stretch>
+        </p:blipFill>
+        <p:spPr>
+          <a:xfrm>
+            <a:off x="874978" y="1051560"/>
+            <a:ext cx="10441738" cy="4206240"/>
+          </a:xfrm>
+          <a:prstGeom prst="rect">
+            <a:avLst/>
+          </a:prstGeom>
+        </p:spPr>
+      </p:pic>
+      <p:sp>
+        <p:nvSpPr>
+          <p:cNvPr id="8" name="Rounded Rectangle 7"/>
+          <p:cNvSpPr/>
+          <p:nvPr/>
+        </p:nvSpPr>
+        <p:spPr>
+          <a:xfrm>
+            <a:off x="457200" y="5212080"/>
+            <a:ext cx="2716453" cy="1051560"/>
+          </a:xfrm>
+          <a:prstGeom prst="roundRect">
+            <a:avLst>
+              <a:gd name="adj" fmla="val 12000"/>
+            </a:avLst>
+          </a:prstGeom>
+          <a:solidFill>
+            <a:srgbClr val="FEF3C7"/>
+          </a:solidFill>
+          <a:ln>
+            <a:noFill/>
+          </a:ln>
+          <a:effectLst/>
+        </p:spPr>
+        <p:style>
+          <a:lnRef idx="1">
+            <a:schemeClr val="accent1"/>
+          </a:lnRef>
+          <a:fillRef idx="3">
+            <a:schemeClr val="accent1"/>
+          </a:fillRef>
+          <a:effectRef idx="2">
+            <a:schemeClr val="accent1"/>
+          </a:effectRef>
+          <a:fontRef idx="minor">
+            <a:schemeClr val="lt1"/>
+          </a:fontRef>
+        </p:style>
+        <p:txBody>
+          <a:bodyPr rtlCol="0" anchor="ctr"/>
+          <a:lstStyle/>
+          <a:p>
+            <a:pPr algn="ctr"/>
+          </a:p>
+        </p:txBody>
+      </p:sp>
+      <p:sp>
+        <p:nvSpPr>
+          <p:cNvPr id="9" name="TextBox 8"/>
+          <p:cNvSpPr txBox="1"/>
+          <p:nvPr/>
+        </p:nvSpPr>
+        <p:spPr>
+          <a:xfrm>
+            <a:off x="548640" y="5212080"/>
+            <a:ext cx="2533573" cy="1051560"/>
+          </a:xfrm>
+          <a:prstGeom prst="rect">
+            <a:avLst/>
+          </a:prstGeom>
+          <a:noFill/>
+        </p:spPr>
+        <p:txBody>
+          <a:bodyPr wrap="square" anchor="ctr" lIns="73152" rIns="73152" tIns="36576" bIns="36576">
+            <a:spAutoFit/>
+          </a:bodyPr>
+          <a:lstStyle/>
+          <a:p>
+            <a:pPr algn="l">
+              <a:spcAft>
+                <a:spcPts val="0"/>
+              </a:spcAft>
+            </a:pPr>
+            <a:r>
+              <a:rPr sz="1400" b="1" i="0">
+                <a:solidFill>
+                  <a:srgbClr val="0F172A"/>
+                </a:solidFill>
+                <a:latin typeface="Arial"/>
+              </a:rPr>
+              <a:t>Autonomy:</a:t>
+            </a:r>
+            <a:r>
+              <a:rPr sz="1400" b="0" i="0">
+                <a:solidFill>
+                  <a:srgbClr val="0F172A"/>
+                </a:solidFill>
+                <a:latin typeface="Arial"/>
+              </a:rPr>
+              <a:t> it decides when to act, what to look at, and whether to trade</a:t>
+            </a:r>
+          </a:p>
+        </p:txBody>
+      </p:sp>
+      <p:sp>
+        <p:nvSpPr>
+          <p:cNvPr id="10" name="Rounded Rectangle 9"/>
+          <p:cNvSpPr/>
+          <p:nvPr/>
+        </p:nvSpPr>
+        <p:spPr>
+          <a:xfrm>
+            <a:off x="3310813" y="5212080"/>
+            <a:ext cx="2716453" cy="1051560"/>
+          </a:xfrm>
+          <a:prstGeom prst="roundRect">
+            <a:avLst>
+              <a:gd name="adj" fmla="val 12000"/>
+            </a:avLst>
+          </a:prstGeom>
+          <a:solidFill>
+            <a:srgbClr val="FEF3C7"/>
+          </a:solidFill>
+          <a:ln>
+            <a:noFill/>
+          </a:ln>
+          <a:effectLst/>
+        </p:spPr>
+        <p:style>
+          <a:lnRef idx="1">
+            <a:schemeClr val="accent1"/>
+          </a:lnRef>
+          <a:fillRef idx="3">
+            <a:schemeClr val="accent1"/>
+          </a:fillRef>
+          <a:effectRef idx="2">
+            <a:schemeClr val="accent1"/>
+          </a:effectRef>
+          <a:fontRef idx="minor">
+            <a:schemeClr val="lt1"/>
+          </a:fontRef>
+        </p:style>
+        <p:txBody>
+          <a:bodyPr rtlCol="0" anchor="ctr"/>
+          <a:lstStyle/>
+          <a:p>
+            <a:pPr algn="ctr"/>
+          </a:p>
+        </p:txBody>
+      </p:sp>
+      <p:sp>
+        <p:nvSpPr>
+          <p:cNvPr id="11" name="TextBox 10"/>
+          <p:cNvSpPr txBox="1"/>
+          <p:nvPr/>
+        </p:nvSpPr>
+        <p:spPr>
+          <a:xfrm>
+            <a:off x="3402253" y="5212080"/>
+            <a:ext cx="2533573" cy="1051560"/>
+          </a:xfrm>
+          <a:prstGeom prst="rect">
+            <a:avLst/>
+          </a:prstGeom>
+          <a:noFill/>
+        </p:spPr>
+        <p:txBody>
+          <a:bodyPr wrap="square" anchor="ctr" lIns="73152" rIns="73152" tIns="36576" bIns="36576">
+            <a:spAutoFit/>
+          </a:bodyPr>
+          <a:lstStyle/>
+          <a:p>
+            <a:pPr algn="l">
+              <a:spcAft>
+                <a:spcPts val="0"/>
+              </a:spcAft>
+            </a:pPr>
+            <a:r>
+              <a:rPr sz="1400" b="1" i="0">
+                <a:solidFill>
+                  <a:srgbClr val="0F172A"/>
+                </a:solidFill>
+                <a:latin typeface="Arial"/>
+              </a:rPr>
+              <a:t>Safety:</a:t>
+            </a:r>
+            <a:r>
+              <a:rPr sz="1400" b="0" i="0">
+                <a:solidFill>
+                  <a:srgbClr val="0F172A"/>
+                </a:solidFill>
+                <a:latin typeface="Arial"/>
+              </a:rPr>
+              <a:t> code limits and a kill switch; </a:t>
+            </a:r>
+            <a:r>
+              <a:rPr sz="1400" b="1" i="0">
+                <a:solidFill>
+                  <a:srgbClr val="0F172A"/>
+                </a:solidFill>
+                <a:latin typeface="Arial"/>
+              </a:rPr>
+              <a:t>9 / 9</a:t>
+            </a:r>
+            <a:r>
+              <a:rPr sz="1400" b="0" i="0">
+                <a:solidFill>
+                  <a:srgbClr val="0F172A"/>
+                </a:solidFill>
+                <a:latin typeface="Arial"/>
+              </a:rPr>
+              <a:t> planted violations blocked</a:t>
+            </a:r>
+          </a:p>
+        </p:txBody>
+      </p:sp>
+      <p:sp>
+        <p:nvSpPr>
+          <p:cNvPr id="12" name="Rounded Rectangle 11"/>
+          <p:cNvSpPr/>
+          <p:nvPr/>
+        </p:nvSpPr>
+        <p:spPr>
+          <a:xfrm>
+            <a:off x="6164427" y="5212080"/>
+            <a:ext cx="2716453" cy="1051560"/>
+          </a:xfrm>
+          <a:prstGeom prst="roundRect">
+            <a:avLst>
+              <a:gd name="adj" fmla="val 12000"/>
+            </a:avLst>
+          </a:prstGeom>
+          <a:solidFill>
+            <a:srgbClr val="FEF3C7"/>
+          </a:solidFill>
+          <a:ln>
+            <a:noFill/>
+          </a:ln>
+          <a:effectLst/>
+        </p:spPr>
+        <p:style>
+          <a:lnRef idx="1">
+            <a:schemeClr val="accent1"/>
+          </a:lnRef>
+          <a:fillRef idx="3">
+            <a:schemeClr val="accent1"/>
+          </a:fillRef>
+          <a:effectRef idx="2">
+            <a:schemeClr val="accent1"/>
+          </a:effectRef>
+          <a:fontRef idx="minor">
+            <a:schemeClr val="lt1"/>
+          </a:fontRef>
+        </p:style>
+        <p:txBody>
+          <a:bodyPr rtlCol="0" anchor="ctr"/>
+          <a:lstStyle/>
+          <a:p>
+            <a:pPr algn="ctr"/>
+          </a:p>
+        </p:txBody>
+      </p:sp>
+      <p:sp>
+        <p:nvSpPr>
+          <p:cNvPr id="13" name="TextBox 12"/>
+          <p:cNvSpPr txBox="1"/>
+          <p:nvPr/>
+        </p:nvSpPr>
+        <p:spPr>
+          <a:xfrm>
+            <a:off x="6255867" y="5212080"/>
+            <a:ext cx="2533573" cy="1051560"/>
+          </a:xfrm>
+          <a:prstGeom prst="rect">
+            <a:avLst/>
+          </a:prstGeom>
+          <a:noFill/>
+        </p:spPr>
+        <p:txBody>
+          <a:bodyPr wrap="square" anchor="ctr" lIns="73152" rIns="73152" tIns="36576" bIns="36576">
+            <a:spAutoFit/>
+          </a:bodyPr>
+          <a:lstStyle/>
+          <a:p>
+            <a:pPr algn="l">
+              <a:spcAft>
+                <a:spcPts val="0"/>
+              </a:spcAft>
+            </a:pPr>
+            <a:r>
+              <a:rPr sz="1400" b="1" i="0">
+                <a:solidFill>
+                  <a:srgbClr val="0F172A"/>
+                </a:solidFill>
+                <a:latin typeface="Arial"/>
+              </a:rPr>
+              <a:t>Learning:</a:t>
+            </a:r>
+            <a:r>
+              <a:rPr sz="1400" b="0" i="0">
+                <a:solidFill>
+                  <a:srgbClr val="0F172A"/>
+                </a:solidFill>
+                <a:latin typeface="Arial"/>
+              </a:rPr>
+              <a:t> rules graded by the market on held-out days, placebo-audited</a:t>
+            </a:r>
+          </a:p>
+        </p:txBody>
+      </p:sp>
+      <p:sp>
+        <p:nvSpPr>
+          <p:cNvPr id="14" name="Rounded Rectangle 13"/>
+          <p:cNvSpPr/>
+          <p:nvPr/>
+        </p:nvSpPr>
+        <p:spPr>
+          <a:xfrm>
+            <a:off x="9018041" y="5212080"/>
+            <a:ext cx="2716453" cy="1051560"/>
+          </a:xfrm>
+          <a:prstGeom prst="roundRect">
+            <a:avLst>
+              <a:gd name="adj" fmla="val 12000"/>
+            </a:avLst>
+          </a:prstGeom>
+          <a:solidFill>
+            <a:srgbClr val="FEF3C7"/>
+          </a:solidFill>
+          <a:ln>
+            <a:noFill/>
+          </a:ln>
+          <a:effectLst/>
+        </p:spPr>
+        <p:style>
+          <a:lnRef idx="1">
+            <a:schemeClr val="accent1"/>
+          </a:lnRef>
+          <a:fillRef idx="3">
+            <a:schemeClr val="accent1"/>
+          </a:fillRef>
+          <a:effectRef idx="2">
+            <a:schemeClr val="accent1"/>
+          </a:effectRef>
+          <a:fontRef idx="minor">
+            <a:schemeClr val="lt1"/>
+          </a:fontRef>
+        </p:style>
+        <p:txBody>
+          <a:bodyPr rtlCol="0" anchor="ctr"/>
+          <a:lstStyle/>
+          <a:p>
+            <a:pPr algn="ctr"/>
+          </a:p>
+        </p:txBody>
+      </p:sp>
+      <p:sp>
+        <p:nvSpPr>
+          <p:cNvPr id="15" name="TextBox 14"/>
+          <p:cNvSpPr txBox="1"/>
+          <p:nvPr/>
+        </p:nvSpPr>
+        <p:spPr>
+          <a:xfrm>
+            <a:off x="9109481" y="5212080"/>
+            <a:ext cx="2533573" cy="1051560"/>
+          </a:xfrm>
+          <a:prstGeom prst="rect">
+            <a:avLst/>
+          </a:prstGeom>
+          <a:noFill/>
+        </p:spPr>
+        <p:txBody>
+          <a:bodyPr wrap="square" anchor="ctr" lIns="73152" rIns="73152" tIns="36576" bIns="36576">
+            <a:spAutoFit/>
+          </a:bodyPr>
+          <a:lstStyle/>
+          <a:p>
+            <a:pPr algn="l">
+              <a:spcAft>
+                <a:spcPts val="0"/>
+              </a:spcAft>
+            </a:pPr>
+            <a:r>
+              <a:rPr sz="1400" b="1" i="0">
+                <a:solidFill>
+                  <a:srgbClr val="0F172A"/>
+                </a:solidFill>
+                <a:latin typeface="Arial"/>
+              </a:rPr>
+              <a:t>People in the loop:</a:t>
+            </a:r>
+            <a:r>
+              <a:rPr sz="1400" b="0" i="0">
+                <a:solidFill>
+                  <a:srgbClr val="0F172A"/>
+                </a:solidFill>
+                <a:latin typeface="Arial"/>
+              </a:rPr>
+              <a:t> humans confirm; Coach and League teach with its analysis</a:t>
+            </a:r>
+          </a:p>
+        </p:txBody>
+      </p:sp>
+    </p:spTree>
+  </p:cSld>
+  <p:clrMapOvr>
+    <a:masterClrMapping/>
+  </p:clrMapOvr>
+</p:sld>
+</file>
+
+<file path=ppt/slides/slide5.xml><?xml version="1.0" encoding="utf-8"?>
+<p:sld xmlns:a="http://schemas.openxmlformats.org/drawingml/2006/main" xmlns:p="http://schemas.openxmlformats.org/presentationml/2006/main" xmlns:r="http://schemas.openxmlformats.org/officeDocument/2006/relationships">
+  <p:cSld>
+    <p:spTree>
+      <p:nvGrpSpPr>
+        <p:cNvPr id="1" name=""/>
+        <p:cNvGrpSpPr/>
+        <p:nvPr/>
+      </p:nvGrpSpPr>
+      <p:grpSpPr/>
+      <p:sp>
+        <p:nvSpPr>
+          <p:cNvPr id="2" name="Rectangle 1"/>
+          <p:cNvSpPr/>
+          <p:nvPr/>
+        </p:nvSpPr>
+        <p:spPr>
+          <a:xfrm>
+            <a:off x="0" y="0"/>
+            <a:ext cx="12191695" cy="868680"/>
+          </a:xfrm>
+          <a:prstGeom prst="rect">
+            <a:avLst/>
+          </a:prstGeom>
+          <a:solidFill>
+            <a:srgbClr val="1E293B"/>
+          </a:solidFill>
+          <a:ln>
+            <a:noFill/>
+          </a:ln>
+          <a:effectLst/>
+        </p:spPr>
+        <p:style>
+          <a:lnRef idx="1">
+            <a:schemeClr val="accent1"/>
+          </a:lnRef>
+          <a:fillRef idx="3">
+            <a:schemeClr val="accent1"/>
+          </a:fillRef>
+          <a:effectRef idx="2">
+            <a:schemeClr val="accent1"/>
+          </a:effectRef>
+          <a:fontRef idx="minor">
+            <a:schemeClr val="lt1"/>
+          </a:fontRef>
+        </p:style>
+        <p:txBody>
+          <a:bodyPr rtlCol="0" anchor="ctr"/>
+          <a:lstStyle/>
+          <a:p>
+            <a:pPr algn="ctr"/>
+          </a:p>
+        </p:txBody>
+      </p:sp>
+      <p:sp>
+        <p:nvSpPr>
+          <p:cNvPr id="3" name="Rectangle 2"/>
+          <p:cNvSpPr/>
+          <p:nvPr/>
+        </p:nvSpPr>
+        <p:spPr>
+          <a:xfrm>
+            <a:off x="0" y="868680"/>
+            <a:ext cx="12191695" cy="54864"/>
+          </a:xfrm>
+          <a:prstGeom prst="rect">
+            <a:avLst/>
+          </a:prstGeom>
+          <a:solidFill>
+            <a:srgbClr val="EA580C"/>
+          </a:solidFill>
+          <a:ln>
+            <a:noFill/>
+          </a:ln>
+          <a:effectLst/>
+        </p:spPr>
+        <p:style>
+          <a:lnRef idx="1">
+            <a:schemeClr val="accent1"/>
+          </a:lnRef>
+          <a:fillRef idx="3">
+            <a:schemeClr val="accent1"/>
+          </a:fillRef>
+          <a:effectRef idx="2">
+            <a:schemeClr val="accent1"/>
+          </a:effectRef>
+          <a:fontRef idx="minor">
+            <a:schemeClr val="lt1"/>
+          </a:fontRef>
+        </p:style>
+        <p:txBody>
+          <a:bodyPr rtlCol="0" anchor="ctr"/>
+          <a:lstStyle/>
+          <a:p>
+            <a:pPr algn="ctr"/>
+          </a:p>
+        </p:txBody>
+      </p:sp>
+      <p:sp>
+        <p:nvSpPr>
+          <p:cNvPr id="4" name="TextBox 3"/>
+          <p:cNvSpPr txBox="1"/>
+          <p:nvPr/>
+        </p:nvSpPr>
+        <p:spPr>
+          <a:xfrm>
+            <a:off x="457200" y="109728"/>
+            <a:ext cx="11277295" cy="685800"/>
+          </a:xfrm>
+          <a:prstGeom prst="rect">
+            <a:avLst/>
+          </a:prstGeom>
+          <a:noFill/>
+        </p:spPr>
+        <p:txBody>
+          <a:bodyPr wrap="square" anchor="ctr" lIns="73152" rIns="73152" tIns="36576" bIns="36576">
+            <a:spAutoFit/>
+          </a:bodyPr>
+          <a:lstStyle/>
+          <a:p>
+            <a:pPr algn="l">
+              <a:spcAft>
+                <a:spcPts val="0"/>
+              </a:spcAft>
+            </a:pPr>
+            <a:r>
+              <a:rPr sz="3000" b="1" i="0">
+                <a:solidFill>
+                  <a:srgbClr val="FFFFFF"/>
+                </a:solidFill>
+                <a:latin typeface="Arial"/>
+              </a:rPr>
+              <a:t>Market-Graded Learning: the closing price is the grader</a:t>
+            </a:r>
+          </a:p>
+        </p:txBody>
+      </p:sp>
+      <p:sp>
+        <p:nvSpPr>
+          <p:cNvPr id="5" name="TextBox 4"/>
+          <p:cNvSpPr txBox="1"/>
+          <p:nvPr/>
+        </p:nvSpPr>
+        <p:spPr>
+          <a:xfrm>
+            <a:off x="457200" y="6446520"/>
+            <a:ext cx="9144000" cy="320040"/>
+          </a:xfrm>
+          <a:prstGeom prst="rect">
+            <a:avLst/>
+          </a:prstGeom>
+          <a:noFill/>
+        </p:spPr>
+        <p:txBody>
+          <a:bodyPr wrap="square" anchor="t" lIns="73152" rIns="73152" tIns="36576" bIns="36576">
+            <a:spAutoFit/>
+          </a:bodyPr>
+          <a:lstStyle/>
+          <a:p>
+            <a:pPr algn="l">
+              <a:spcAft>
+                <a:spcPts val="0"/>
+              </a:spcAft>
+            </a:pPr>
+            <a:r>
+              <a:rPr sz="1100" b="0" i="0">
+                <a:solidFill>
+                  <a:srgbClr val="64748B"/>
+                </a:solidFill>
+                <a:latin typeface="Arial"/>
+              </a:rPr>
+              <a:t>DASC7606C Group 12 · Market-Graded Learning: the closing price grades every component</a:t>
+            </a:r>
+          </a:p>
+        </p:txBody>
+      </p:sp>
+      <p:sp>
+        <p:nvSpPr>
+          <p:cNvPr id="6" name="TextBox 5"/>
+          <p:cNvSpPr txBox="1"/>
+          <p:nvPr/>
+        </p:nvSpPr>
+        <p:spPr>
+          <a:xfrm>
+            <a:off x="10820095" y="6446520"/>
+            <a:ext cx="914400" cy="320040"/>
+          </a:xfrm>
+          <a:prstGeom prst="rect">
+            <a:avLst/>
+          </a:prstGeom>
+          <a:noFill/>
+        </p:spPr>
+        <p:txBody>
+          <a:bodyPr wrap="square" anchor="t" lIns="73152" rIns="73152" tIns="36576" bIns="36576">
+            <a:spAutoFit/>
+          </a:bodyPr>
+          <a:lstStyle/>
+          <a:p>
+            <a:pPr algn="r">
+              <a:spcAft>
+                <a:spcPts val="0"/>
+              </a:spcAft>
+            </a:pPr>
+            <a:r>
+              <a:rPr sz="1100" b="0" i="0">
+                <a:solidFill>
+                  <a:srgbClr val="64748B"/>
+                </a:solidFill>
+                <a:latin typeface="Arial"/>
+              </a:rPr>
+              <a:t>5</a:t>
             </a:r>
           </a:p>
         </p:txBody>
@@ -12452,7 +13093,7 @@
 </p:sld>
 </file>
 
-<file path=ppt/slides/slide5.xml><?xml version="1.0" encoding="utf-8"?>
+<file path=ppt/slides/slide6.xml><?xml version="1.0" encoding="utf-8"?>
 <p:sld xmlns:a="http://schemas.openxmlformats.org/drawingml/2006/main" xmlns:p="http://schemas.openxmlformats.org/presentationml/2006/main" xmlns:r="http://schemas.openxmlformats.org/officeDocument/2006/relationships">
   <p:cSld>
     <p:spTree>
@@ -12662,7 +13303,7 @@
                 </a:solidFill>
                 <a:latin typeface="Arial"/>
               </a:rPr>
-              <a:t>5</a:t>
+              <a:t>6</a:t>
             </a:r>
           </a:p>
         </p:txBody>
@@ -13447,7 +14088,7 @@
 </p:sld>
 </file>
 
-<file path=ppt/slides/slide6.xml><?xml version="1.0" encoding="utf-8"?>
+<file path=ppt/slides/slide7.xml><?xml version="1.0" encoding="utf-8"?>
 <p:sld xmlns:a="http://schemas.openxmlformats.org/drawingml/2006/main" xmlns:p="http://schemas.openxmlformats.org/presentationml/2006/main" xmlns:r="http://schemas.openxmlformats.org/officeDocument/2006/relationships">
   <p:cSld>
     <p:spTree>
@@ -13579,7 +14220,7 @@
                 </a:solidFill>
                 <a:latin typeface="Arial"/>
               </a:rPr>
-              <a:t>Evidence 1: costs set a hurdle before you start</a:t>
+              <a:t>Evidence 1: costs, and a price that moves before the news</a:t>
             </a:r>
           </a:p>
         </p:txBody>
@@ -13657,7 +14298,7 @@
                 </a:solidFill>
                 <a:latin typeface="Arial"/>
               </a:rPr>
-              <a:t>6</a:t>
+              <a:t>7</a:t>
             </a:r>
           </a:p>
         </p:txBody>
@@ -13678,441 +14319,8 @@
         </p:blipFill>
         <p:spPr>
           <a:xfrm>
-            <a:off x="1352397" y="1097280"/>
-            <a:ext cx="9486900" cy="3794760"/>
-          </a:xfrm>
-          <a:prstGeom prst="rect">
-            <a:avLst/>
-          </a:prstGeom>
-        </p:spPr>
-      </p:pic>
-      <p:sp>
-        <p:nvSpPr>
-          <p:cNvPr id="8" name="TextBox 7"/>
-          <p:cNvSpPr txBox="1"/>
-          <p:nvPr/>
-        </p:nvSpPr>
-        <p:spPr>
-          <a:xfrm>
-            <a:off x="457200" y="4983480"/>
-            <a:ext cx="5547207" cy="1371600"/>
-          </a:xfrm>
-          <a:prstGeom prst="rect">
-            <a:avLst/>
-          </a:prstGeom>
-          <a:noFill/>
-        </p:spPr>
-        <p:txBody>
-          <a:bodyPr wrap="square" anchor="t" lIns="73152" rIns="73152" tIns="36576" bIns="36576">
-            <a:spAutoFit/>
-          </a:bodyPr>
-          <a:lstStyle/>
-          <a:p>
-            <a:pPr algn="l" marL="292608" indent="-256032">
-              <a:spcAft>
-                <a:spcPts val="400"/>
-              </a:spcAft>
-              <a:buChar char="•"/>
-            </a:pPr>
-            <a:r>
-              <a:rPr sz="1800" b="1" i="0">
-                <a:solidFill>
-                  <a:srgbClr val="0F172A"/>
-                </a:solidFill>
-                <a:latin typeface="Arial"/>
-              </a:rPr>
-              <a:t>1.92¢ per contract</a:t>
-            </a:r>
-            <a:r>
-              <a:rPr sz="1800" b="0" i="0">
-                <a:solidFill>
-                  <a:srgbClr val="0F172A"/>
-                </a:solidFill>
-                <a:latin typeface="Arial"/>
-              </a:rPr>
-              <a:t> = 5.0% of price; </a:t>
-            </a:r>
-            <a:r>
-              <a:rPr sz="1800" b="1" i="0">
-                <a:solidFill>
-                  <a:srgbClr val="0F172A"/>
-                </a:solidFill>
-                <a:latin typeface="Arial"/>
-              </a:rPr>
-              <a:t>9–14%</a:t>
-            </a:r>
-            <a:r>
-              <a:rPr sz="1800" b="0" i="0">
-                <a:solidFill>
-                  <a:srgbClr val="0F172A"/>
-                </a:solidFill>
-                <a:latin typeface="Arial"/>
-              </a:rPr>
-              <a:t> under 20¢</a:t>
-            </a:r>
-          </a:p>
-          <a:p>
-            <a:pPr algn="l" marL="292608" indent="-256032">
-              <a:spcAft>
-                <a:spcPts val="400"/>
-              </a:spcAft>
-              <a:buChar char="•"/>
-            </a:pPr>
-            <a:r>
-              <a:rPr sz="1800" b="0" i="0">
-                <a:solidFill>
-                  <a:srgbClr val="0F172A"/>
-                </a:solidFill>
-                <a:latin typeface="Arial"/>
-              </a:rPr>
-              <a:t>Best agent, Feb–Apr: +$36 at mid → </a:t>
-            </a:r>
-            <a:r>
-              <a:rPr sz="1800" b="1" i="0">
-                <a:solidFill>
-                  <a:srgbClr val="0F172A"/>
-                </a:solidFill>
-                <a:latin typeface="Arial"/>
-              </a:rPr>
-              <a:t>−$32</a:t>
-            </a:r>
-            <a:r>
-              <a:rPr sz="1800" b="0" i="0">
-                <a:solidFill>
-                  <a:srgbClr val="0F172A"/>
-                </a:solidFill>
-                <a:latin typeface="Arial"/>
-              </a:rPr>
-              <a:t> after costs</a:t>
-            </a:r>
-          </a:p>
-        </p:txBody>
-      </p:sp>
-      <p:sp>
-        <p:nvSpPr>
-          <p:cNvPr id="9" name="TextBox 8"/>
-          <p:cNvSpPr txBox="1"/>
-          <p:nvPr/>
-        </p:nvSpPr>
-        <p:spPr>
-          <a:xfrm>
-            <a:off x="6187287" y="4983480"/>
-            <a:ext cx="5547207" cy="1371600"/>
-          </a:xfrm>
-          <a:prstGeom prst="rect">
-            <a:avLst/>
-          </a:prstGeom>
-          <a:noFill/>
-        </p:spPr>
-        <p:txBody>
-          <a:bodyPr wrap="square" anchor="t" lIns="73152" rIns="73152" tIns="36576" bIns="36576">
-            <a:spAutoFit/>
-          </a:bodyPr>
-          <a:lstStyle/>
-          <a:p>
-            <a:pPr algn="l" marL="292608" indent="-256032">
-              <a:spcAft>
-                <a:spcPts val="400"/>
-              </a:spcAft>
-              <a:buChar char="•"/>
-            </a:pPr>
-            <a:r>
-              <a:rPr sz="1800" b="0" i="0">
-                <a:solidFill>
-                  <a:srgbClr val="0F172A"/>
-                </a:solidFill>
-                <a:latin typeface="Arial"/>
-              </a:rPr>
-              <a:t>771 decision points → 153 with gap &gt; 4 pts → </a:t>
-            </a:r>
-            <a:r>
-              <a:rPr sz="1800" b="1" i="0">
-                <a:solidFill>
-                  <a:srgbClr val="0F172A"/>
-                </a:solidFill>
-                <a:latin typeface="Arial"/>
-              </a:rPr>
-              <a:t>74 trades</a:t>
-            </a:r>
-          </a:p>
-          <a:p>
-            <a:pPr algn="l" marL="292608" indent="-256032">
-              <a:spcAft>
-                <a:spcPts val="400"/>
-              </a:spcAft>
-              <a:buChar char="•"/>
-            </a:pPr>
-            <a:r>
-              <a:rPr sz="1800" b="0" i="0">
-                <a:solidFill>
-                  <a:srgbClr val="0F172A"/>
-                </a:solidFill>
-                <a:latin typeface="Arial"/>
-              </a:rPr>
-              <a:t>Only </a:t>
-            </a:r>
-            <a:r>
-              <a:rPr sz="1800" b="1" i="0">
-                <a:solidFill>
-                  <a:srgbClr val="0F172A"/>
-                </a:solidFill>
-                <a:latin typeface="Arial"/>
-              </a:rPr>
-              <a:t>27 (36%)</a:t>
-            </a:r>
-            <a:r>
-              <a:rPr sz="1800" b="0" i="0">
-                <a:solidFill>
-                  <a:srgbClr val="0F172A"/>
-                </a:solidFill>
-                <a:latin typeface="Arial"/>
-              </a:rPr>
-              <a:t> beat or matched the close</a:t>
-            </a:r>
-          </a:p>
-        </p:txBody>
-      </p:sp>
-    </p:spTree>
-  </p:cSld>
-  <p:clrMapOvr>
-    <a:masterClrMapping/>
-  </p:clrMapOvr>
-</p:sld>
-</file>
-
-<file path=ppt/slides/slide7.xml><?xml version="1.0" encoding="utf-8"?>
-<p:sld xmlns:a="http://schemas.openxmlformats.org/drawingml/2006/main" xmlns:p="http://schemas.openxmlformats.org/presentationml/2006/main" xmlns:r="http://schemas.openxmlformats.org/officeDocument/2006/relationships">
-  <p:cSld>
-    <p:spTree>
-      <p:nvGrpSpPr>
-        <p:cNvPr id="1" name=""/>
-        <p:cNvGrpSpPr/>
-        <p:nvPr/>
-      </p:nvGrpSpPr>
-      <p:grpSpPr/>
-      <p:sp>
-        <p:nvSpPr>
-          <p:cNvPr id="2" name="Rectangle 1"/>
-          <p:cNvSpPr/>
-          <p:nvPr/>
-        </p:nvSpPr>
-        <p:spPr>
-          <a:xfrm>
-            <a:off x="0" y="0"/>
-            <a:ext cx="12191695" cy="868680"/>
-          </a:xfrm>
-          <a:prstGeom prst="rect">
-            <a:avLst/>
-          </a:prstGeom>
-          <a:solidFill>
-            <a:srgbClr val="1E293B"/>
-          </a:solidFill>
-          <a:ln>
-            <a:noFill/>
-          </a:ln>
-          <a:effectLst/>
-        </p:spPr>
-        <p:style>
-          <a:lnRef idx="1">
-            <a:schemeClr val="accent1"/>
-          </a:lnRef>
-          <a:fillRef idx="3">
-            <a:schemeClr val="accent1"/>
-          </a:fillRef>
-          <a:effectRef idx="2">
-            <a:schemeClr val="accent1"/>
-          </a:effectRef>
-          <a:fontRef idx="minor">
-            <a:schemeClr val="lt1"/>
-          </a:fontRef>
-        </p:style>
-        <p:txBody>
-          <a:bodyPr rtlCol="0" anchor="ctr"/>
-          <a:lstStyle/>
-          <a:p>
-            <a:pPr algn="ctr"/>
-          </a:p>
-        </p:txBody>
-      </p:sp>
-      <p:sp>
-        <p:nvSpPr>
-          <p:cNvPr id="3" name="Rectangle 2"/>
-          <p:cNvSpPr/>
-          <p:nvPr/>
-        </p:nvSpPr>
-        <p:spPr>
-          <a:xfrm>
-            <a:off x="0" y="868680"/>
-            <a:ext cx="12191695" cy="54864"/>
-          </a:xfrm>
-          <a:prstGeom prst="rect">
-            <a:avLst/>
-          </a:prstGeom>
-          <a:solidFill>
-            <a:srgbClr val="EA580C"/>
-          </a:solidFill>
-          <a:ln>
-            <a:noFill/>
-          </a:ln>
-          <a:effectLst/>
-        </p:spPr>
-        <p:style>
-          <a:lnRef idx="1">
-            <a:schemeClr val="accent1"/>
-          </a:lnRef>
-          <a:fillRef idx="3">
-            <a:schemeClr val="accent1"/>
-          </a:fillRef>
-          <a:effectRef idx="2">
-            <a:schemeClr val="accent1"/>
-          </a:effectRef>
-          <a:fontRef idx="minor">
-            <a:schemeClr val="lt1"/>
-          </a:fontRef>
-        </p:style>
-        <p:txBody>
-          <a:bodyPr rtlCol="0" anchor="ctr"/>
-          <a:lstStyle/>
-          <a:p>
-            <a:pPr algn="ctr"/>
-          </a:p>
-        </p:txBody>
-      </p:sp>
-      <p:sp>
-        <p:nvSpPr>
-          <p:cNvPr id="4" name="TextBox 3"/>
-          <p:cNvSpPr txBox="1"/>
-          <p:nvPr/>
-        </p:nvSpPr>
-        <p:spPr>
-          <a:xfrm>
-            <a:off x="457200" y="109728"/>
-            <a:ext cx="11277295" cy="685800"/>
-          </a:xfrm>
-          <a:prstGeom prst="rect">
-            <a:avLst/>
-          </a:prstGeom>
-          <a:noFill/>
-        </p:spPr>
-        <p:txBody>
-          <a:bodyPr wrap="square" anchor="ctr" lIns="73152" rIns="73152" tIns="36576" bIns="36576">
-            <a:spAutoFit/>
-          </a:bodyPr>
-          <a:lstStyle/>
-          <a:p>
-            <a:pPr algn="l">
-              <a:spcAft>
-                <a:spcPts val="0"/>
-              </a:spcAft>
-            </a:pPr>
-            <a:r>
-              <a:rPr sz="3000" b="1" i="0">
-                <a:solidFill>
-                  <a:srgbClr val="FFFFFF"/>
-                </a:solidFill>
-                <a:latin typeface="Arial"/>
-              </a:rPr>
-              <a:t>Evidence 2: the price moves before the news reaches you</a:t>
-            </a:r>
-          </a:p>
-        </p:txBody>
-      </p:sp>
-      <p:sp>
-        <p:nvSpPr>
-          <p:cNvPr id="5" name="TextBox 4"/>
-          <p:cNvSpPr txBox="1"/>
-          <p:nvPr/>
-        </p:nvSpPr>
-        <p:spPr>
-          <a:xfrm>
-            <a:off x="457200" y="6446520"/>
-            <a:ext cx="9144000" cy="320040"/>
-          </a:xfrm>
-          <a:prstGeom prst="rect">
-            <a:avLst/>
-          </a:prstGeom>
-          <a:noFill/>
-        </p:spPr>
-        <p:txBody>
-          <a:bodyPr wrap="square" anchor="t" lIns="73152" rIns="73152" tIns="36576" bIns="36576">
-            <a:spAutoFit/>
-          </a:bodyPr>
-          <a:lstStyle/>
-          <a:p>
-            <a:pPr algn="l">
-              <a:spcAft>
-                <a:spcPts val="0"/>
-              </a:spcAft>
-            </a:pPr>
-            <a:r>
-              <a:rPr sz="1100" b="0" i="0">
-                <a:solidFill>
-                  <a:srgbClr val="64748B"/>
-                </a:solidFill>
-                <a:latin typeface="Arial"/>
-              </a:rPr>
-              <a:t>DASC7606C Group 12 · Market-Graded Learning: the closing price grades every component</a:t>
-            </a:r>
-          </a:p>
-        </p:txBody>
-      </p:sp>
-      <p:sp>
-        <p:nvSpPr>
-          <p:cNvPr id="6" name="TextBox 5"/>
-          <p:cNvSpPr txBox="1"/>
-          <p:nvPr/>
-        </p:nvSpPr>
-        <p:spPr>
-          <a:xfrm>
-            <a:off x="10820095" y="6446520"/>
-            <a:ext cx="914400" cy="320040"/>
-          </a:xfrm>
-          <a:prstGeom prst="rect">
-            <a:avLst/>
-          </a:prstGeom>
-          <a:noFill/>
-        </p:spPr>
-        <p:txBody>
-          <a:bodyPr wrap="square" anchor="t" lIns="73152" rIns="73152" tIns="36576" bIns="36576">
-            <a:spAutoFit/>
-          </a:bodyPr>
-          <a:lstStyle/>
-          <a:p>
-            <a:pPr algn="r">
-              <a:spcAft>
-                <a:spcPts val="0"/>
-              </a:spcAft>
-            </a:pPr>
-            <a:r>
-              <a:rPr sz="1100" b="0" i="0">
-                <a:solidFill>
-                  <a:srgbClr val="64748B"/>
-                </a:solidFill>
-                <a:latin typeface="Arial"/>
-              </a:rPr>
-              <a:t>7</a:t>
-            </a:r>
-          </a:p>
-        </p:txBody>
-      </p:sp>
-      <p:pic>
-        <p:nvPicPr>
-          <p:cNvPr id="7" name="Picture 6" descr="price_discovery.png"/>
-          <p:cNvPicPr>
-            <a:picLocks noChangeAspect="1"/>
-          </p:cNvPicPr>
-          <p:nvPr/>
-        </p:nvPicPr>
-        <p:blipFill>
-          <a:blip r:embed="rId3"/>
-          <a:stretch>
-            <a:fillRect/>
-          </a:stretch>
-        </p:blipFill>
-        <p:spPr>
-          <a:xfrm>
-            <a:off x="457200" y="1856232"/>
-            <a:ext cx="5120640" cy="2048255"/>
+            <a:off x="457200" y="1139982"/>
+            <a:ext cx="5501487" cy="2200595"/>
           </a:xfrm>
           <a:prstGeom prst="rect">
             <a:avLst/>
@@ -14121,7 +14329,7 @@
       </p:pic>
       <p:pic>
         <p:nvPicPr>
-          <p:cNvPr id="8" name="Picture 7" descr="injury_timing.png"/>
+          <p:cNvPr id="8" name="Picture 7" descr="price_discovery.png"/>
           <p:cNvPicPr>
             <a:picLocks noChangeAspect="1"/>
           </p:cNvPicPr>
@@ -14135,8 +14343,8 @@
         </p:blipFill>
         <p:spPr>
           <a:xfrm>
-            <a:off x="5715000" y="1676460"/>
-            <a:ext cx="6019495" cy="2407798"/>
+            <a:off x="6233007" y="1139982"/>
+            <a:ext cx="5501487" cy="2200595"/>
           </a:xfrm>
           <a:prstGeom prst="rect">
             <a:avLst/>
@@ -14151,8 +14359,8 @@
         </p:nvSpPr>
         <p:spPr>
           <a:xfrm>
-            <a:off x="457200" y="4754880"/>
-            <a:ext cx="11277295" cy="1600200"/>
+            <a:off x="457200" y="3520439"/>
+            <a:ext cx="5501487" cy="457200"/>
           </a:xfrm>
           <a:prstGeom prst="rect">
             <a:avLst/>
@@ -14165,81 +14373,305 @@
           </a:bodyPr>
           <a:lstStyle/>
           <a:p>
+            <a:pPr algn="l">
+              <a:spcAft>
+                <a:spcPts val="0"/>
+              </a:spcAft>
+            </a:pPr>
+            <a:r>
+              <a:rPr sz="2000" b="1" i="0">
+                <a:solidFill>
+                  <a:srgbClr val="EA580C"/>
+                </a:solidFill>
+                <a:latin typeface="Arial"/>
+              </a:rPr>
+              <a:t>Costs</a:t>
+            </a:r>
+          </a:p>
+        </p:txBody>
+      </p:sp>
+      <p:sp>
+        <p:nvSpPr>
+          <p:cNvPr id="10" name="TextBox 9"/>
+          <p:cNvSpPr txBox="1"/>
+          <p:nvPr/>
+        </p:nvSpPr>
+        <p:spPr>
+          <a:xfrm>
+            <a:off x="457200" y="3931920"/>
+            <a:ext cx="5501487" cy="2377440"/>
+          </a:xfrm>
+          <a:prstGeom prst="rect">
+            <a:avLst/>
+          </a:prstGeom>
+          <a:noFill/>
+        </p:spPr>
+        <p:txBody>
+          <a:bodyPr wrap="square" anchor="t" lIns="73152" rIns="73152" tIns="36576" bIns="36576">
+            <a:spAutoFit/>
+          </a:bodyPr>
+          <a:lstStyle/>
+          <a:p>
             <a:pPr algn="l" marL="292608" indent="-256032">
               <a:spcAft>
-                <a:spcPts val="400"/>
+                <a:spcPts val="600"/>
               </a:spcAft>
               <a:buChar char="•"/>
             </a:pPr>
             <a:r>
-              <a:rPr sz="1800" b="1" i="0">
+              <a:rPr sz="1700" b="1" i="0">
                 <a:solidFill>
                   <a:srgbClr val="0F172A"/>
                 </a:solidFill>
                 <a:latin typeface="Arial"/>
               </a:rPr>
-              <a:t>91%</a:t>
-            </a:r>
-            <a:r>
-              <a:rPr sz="1800" b="0" i="0">
+              <a:t>1.92¢ per contract</a:t>
+            </a:r>
+            <a:r>
+              <a:rPr sz="1700" b="0" i="0">
                 <a:solidFill>
                   <a:srgbClr val="0F172A"/>
                 </a:solidFill>
                 <a:latin typeface="Arial"/>
               </a:rPr>
-              <a:t> of the move happens before the inactive list (+1.80 vs +0.18 pts, 193 test games)</a:t>
+              <a:t> = 5.0% of price; </a:t>
+            </a:r>
+            <a:r>
+              <a:rPr sz="1700" b="1" i="0">
+                <a:solidFill>
+                  <a:srgbClr val="0F172A"/>
+                </a:solidFill>
+                <a:latin typeface="Arial"/>
+              </a:rPr>
+              <a:t>9–14%</a:t>
+            </a:r>
+            <a:r>
+              <a:rPr sz="1700" b="0" i="0">
+                <a:solidFill>
+                  <a:srgbClr val="0F172A"/>
+                </a:solidFill>
+                <a:latin typeface="Arial"/>
+              </a:rPr>
+              <a:t> under 20¢</a:t>
             </a:r>
           </a:p>
           <a:p>
             <a:pPr algn="l" marL="292608" indent="-256032">
               <a:spcAft>
-                <a:spcPts val="400"/>
+                <a:spcPts val="600"/>
               </a:spcAft>
               <a:buChar char="•"/>
             </a:pPr>
             <a:r>
-              <a:rPr sz="1800" b="0" i="0">
+              <a:rPr sz="1700" b="0" i="0">
                 <a:solidFill>
                   <a:srgbClr val="0F172A"/>
                 </a:solidFill>
                 <a:latin typeface="Arial"/>
               </a:rPr>
-              <a:t>About </a:t>
-            </a:r>
-            <a:r>
-              <a:rPr sz="1800" b="1" i="0">
+              <a:t>Best agent, Feb–Apr: +$36 at mid → </a:t>
+            </a:r>
+            <a:r>
+              <a:rPr sz="1700" b="1" i="0">
                 <a:solidFill>
                   <a:srgbClr val="0F172A"/>
                 </a:solidFill>
                 <a:latin typeface="Arial"/>
               </a:rPr>
-              <a:t>two-thirds</a:t>
-            </a:r>
-            <a:r>
-              <a:rPr sz="1800" b="0" i="0">
+              <a:t>−$32</a:t>
+            </a:r>
+            <a:r>
+              <a:rPr sz="1700" b="0" i="0">
                 <a:solidFill>
                   <a:srgbClr val="0F172A"/>
                 </a:solidFill>
                 <a:latin typeface="Arial"/>
               </a:rPr>
-              <a:t> (67%, CI 47–85%) comes before the first official injury report, ~6 h earlier</a:t>
+              <a:t> after costs</a:t>
             </a:r>
           </a:p>
           <a:p>
             <a:pPr algn="l" marL="292608" indent="-256032">
               <a:spcAft>
-                <a:spcPts val="400"/>
+                <a:spcPts val="600"/>
               </a:spcAft>
               <a:buChar char="•"/>
             </a:pPr>
             <a:r>
-              <a:rPr sz="1500" b="0" i="0">
+              <a:rPr sz="1700" b="0" i="0">
+                <a:solidFill>
+                  <a:srgbClr val="0F172A"/>
+                </a:solidFill>
+                <a:latin typeface="Arial"/>
+              </a:rPr>
+              <a:t>771 decision points → </a:t>
+            </a:r>
+            <a:r>
+              <a:rPr sz="1700" b="1" i="0">
+                <a:solidFill>
+                  <a:srgbClr val="0F172A"/>
+                </a:solidFill>
+                <a:latin typeface="Arial"/>
+              </a:rPr>
+              <a:t>74 trades</a:t>
+            </a:r>
+            <a:r>
+              <a:rPr sz="1700" b="0" i="0">
+                <a:solidFill>
+                  <a:srgbClr val="0F172A"/>
+                </a:solidFill>
+                <a:latin typeface="Arial"/>
+              </a:rPr>
+              <a:t>; only </a:t>
+            </a:r>
+            <a:r>
+              <a:rPr sz="1700" b="1" i="0">
+                <a:solidFill>
+                  <a:srgbClr val="0F172A"/>
+                </a:solidFill>
+                <a:latin typeface="Arial"/>
+              </a:rPr>
+              <a:t>27 (36%)</a:t>
+            </a:r>
+            <a:r>
+              <a:rPr sz="1700" b="0" i="0">
+                <a:solidFill>
+                  <a:srgbClr val="0F172A"/>
+                </a:solidFill>
+                <a:latin typeface="Arial"/>
+              </a:rPr>
+              <a:t> beat the close</a:t>
+            </a:r>
+          </a:p>
+        </p:txBody>
+      </p:sp>
+      <p:sp>
+        <p:nvSpPr>
+          <p:cNvPr id="11" name="TextBox 10"/>
+          <p:cNvSpPr txBox="1"/>
+          <p:nvPr/>
+        </p:nvSpPr>
+        <p:spPr>
+          <a:xfrm>
+            <a:off x="6233007" y="3520439"/>
+            <a:ext cx="5501487" cy="457200"/>
+          </a:xfrm>
+          <a:prstGeom prst="rect">
+            <a:avLst/>
+          </a:prstGeom>
+          <a:noFill/>
+        </p:spPr>
+        <p:txBody>
+          <a:bodyPr wrap="square" anchor="t" lIns="73152" rIns="73152" tIns="36576" bIns="36576">
+            <a:spAutoFit/>
+          </a:bodyPr>
+          <a:lstStyle/>
+          <a:p>
+            <a:pPr algn="l">
+              <a:spcAft>
+                <a:spcPts val="0"/>
+              </a:spcAft>
+            </a:pPr>
+            <a:r>
+              <a:rPr sz="2000" b="1" i="0">
+                <a:solidFill>
+                  <a:srgbClr val="2563EB"/>
+                </a:solidFill>
+                <a:latin typeface="Arial"/>
+              </a:rPr>
+              <a:t>Speed</a:t>
+            </a:r>
+          </a:p>
+        </p:txBody>
+      </p:sp>
+      <p:sp>
+        <p:nvSpPr>
+          <p:cNvPr id="12" name="TextBox 11"/>
+          <p:cNvSpPr txBox="1"/>
+          <p:nvPr/>
+        </p:nvSpPr>
+        <p:spPr>
+          <a:xfrm>
+            <a:off x="6233007" y="3931920"/>
+            <a:ext cx="5501487" cy="2377440"/>
+          </a:xfrm>
+          <a:prstGeom prst="rect">
+            <a:avLst/>
+          </a:prstGeom>
+          <a:noFill/>
+        </p:spPr>
+        <p:txBody>
+          <a:bodyPr wrap="square" anchor="t" lIns="73152" rIns="73152" tIns="36576" bIns="36576">
+            <a:spAutoFit/>
+          </a:bodyPr>
+          <a:lstStyle/>
+          <a:p>
+            <a:pPr algn="l" marL="292608" indent="-256032">
+              <a:spcAft>
+                <a:spcPts val="600"/>
+              </a:spcAft>
+              <a:buChar char="•"/>
+            </a:pPr>
+            <a:r>
+              <a:rPr sz="1700" b="1" i="0">
+                <a:solidFill>
+                  <a:srgbClr val="0F172A"/>
+                </a:solidFill>
+                <a:latin typeface="Arial"/>
+              </a:rPr>
+              <a:t>91%</a:t>
+            </a:r>
+            <a:r>
+              <a:rPr sz="1700" b="0" i="0">
+                <a:solidFill>
+                  <a:srgbClr val="0F172A"/>
+                </a:solidFill>
+                <a:latin typeface="Arial"/>
+              </a:rPr>
+              <a:t> of the move before the inactive list (+1.80 vs +0.18 pts, 193 games)</a:t>
+            </a:r>
+          </a:p>
+          <a:p>
+            <a:pPr algn="l" marL="292608" indent="-256032">
+              <a:spcAft>
+                <a:spcPts val="600"/>
+              </a:spcAft>
+              <a:buChar char="•"/>
+            </a:pPr>
+            <a:r>
+              <a:rPr sz="1700" b="1" i="0">
+                <a:solidFill>
+                  <a:srgbClr val="0F172A"/>
+                </a:solidFill>
+                <a:latin typeface="Arial"/>
+              </a:rPr>
+              <a:t>~⅔</a:t>
+            </a:r>
+            <a:r>
+              <a:rPr sz="1700" b="0" i="0">
+                <a:solidFill>
+                  <a:srgbClr val="0F172A"/>
+                </a:solidFill>
+                <a:latin typeface="Arial"/>
+              </a:rPr>
+              <a:t> (67%, CI 47–85%) before the first official injury report, ~6 h earlier</a:t>
+            </a:r>
+          </a:p>
+          <a:p>
+            <a:pPr algn="l" marL="292608" indent="-256032">
+              <a:spcAft>
+                <a:spcPts val="600"/>
+              </a:spcAft>
+              <a:buChar char="•"/>
+            </a:pPr>
+            <a:r>
+              <a:rPr sz="1400" b="0" i="0">
                 <a:solidFill>
                   <a:srgbClr val="64748B"/>
                 </a:solidFill>
                 <a:latin typeface="Arial"/>
               </a:rPr>
-              <a:t>49% if reports are public at their slot; official reports only, so news can be earlier</a:t>
+              <a:t>49% with no publication lag; official reports only</a:t>
             </a:r>
           </a:p>
         </p:txBody>
@@ -14384,7 +14816,7 @@
                 </a:solidFill>
                 <a:latin typeface="Arial"/>
               </a:rPr>
-              <a:t>Evidence 3: the market beats our model</a:t>
+              <a:t>Evidence 2: the market beats our model</a:t>
             </a:r>
           </a:p>
         </p:txBody>

</xml_diff>

<commit_message>
Problem slide: surging Kalshi/Polymarket volume and thin consumer price protection (dated, cited); docs/market_regulation.md; script timing; Q&A on CFTC fairness and sportsbooks
Co-authored-by: Cursor <cursoragent@cursor.com>
</commit_message>
<xml_diff>
--- a/presentation/nba_agent_deck.pptx
+++ b/presentation/nba_agent_deck.pptx
@@ -1006,7 +1006,7 @@
           <a:lstStyle/>
           <a:p>
             <a:r>
-              <a:t>Three parts. First, consumers want to learn: since 2018, 38 US states have legalised sports betting, and the Lancet Public Health Commission estimates 46% of adults worldwide gambled last year. Second, the markets are structurally tilted, which is what we measured: about 5.0% cost per trade, 91% of the price move before the public news, and the market beats our model. Third, published research shows harm: about 80M adults with gambling disorder; online betting lowers credit scores by 2.75 points and raises bankruptcies by about 10%; each dollar of online betting cuts investment by about $0.99. References: Wardle et al., Lancet Public Health 2024; Hollenbeck, Larsen and Proserpio, SSRN 4903302; Baker et al., NBER WP 33108.</a:t>
+              <a:t>Three parts. First, volume is surging. Pew Research, using The Block's data, found that monthly volume on Kalshi and Polymarket more than doubled from $26B in May to $53B in July 2026, mostly sports. Kalshi alone traded a record $61B notional in September 2026, about 46× its daily average a year earlier (TickerTracker, via NEXTPredict). Notional counts each contract at one dollar, so cash paid is lower, but in July Kalshi's sports notional of $31B compared with $11.6B of handle at all US sportsbooks (AGA). It reaches retail users through brokers: Robinhood reported 13.6B event contracts in Q2 2026 and nearly 2 million prediction-market customers; Coinbase routes to Kalshi since January 2026. Investors value Kalshi at $22B (May 2026, talks at about $40 billion reported by Reuters on 29 September) and Polymarket at $21B (Bloomberg, 31 August). Second, price protection is thin. An exchange has no house edge, but every taker pays a fee, 0.07 times p times one minus p per contract on Kalshi, plus the spread, and trades against professional market makers, including Kalshi's own affiliate, Kalshi Trading, which the CFTC has proposed to restrict. Kalshi has been CFTC-regulated since 2020 and self-certified sports contracts in January 2025; the CFTC did not block them. CFTC core principles protect market integrity, surveillance and manipulation, but nobody checks that the price a retail user pays is fair, and there is no federal responsible-gambling duty; sports contracts are open at 18, not 21. States are fighting back: the Third Circuit said New Jersey cannot regulate Kalshi, the Ninth Circuit in August said Nevada can. Our own measurement shows what this gap costs: about 5.0% per trade, and 91% of the price move before the public news. Third, published research shows harm: about 80M adults with gambling disorder (Lancet Public Health 2024); online betting lowers credit scores by 2.75 points and raises bankruptcies by about 10% (Hollenbeck, Larsen and Proserpio, SSRN 4903302). Full sources and dates: docs/market_regulation.md.</a:t>
             </a:r>
           </a:p>
         </p:txBody>
@@ -10063,7 +10063,7 @@
                 </a:solidFill>
                 <a:latin typeface="Arial"/>
               </a:rPr>
-              <a:t>The problem: three things consumers face</a:t>
+              <a:t>The problem: surging, under-protected betting markets</a:t>
             </a:r>
           </a:p>
         </p:txBody>
@@ -10154,8 +10154,8 @@
         </p:nvSpPr>
         <p:spPr>
           <a:xfrm>
-            <a:off x="457200" y="1234439"/>
-            <a:ext cx="3606698" cy="3246120"/>
+            <a:off x="457200" y="1170432"/>
+            <a:ext cx="3606698" cy="3721608"/>
           </a:xfrm>
           <a:prstGeom prst="roundRect">
             <a:avLst>
@@ -10202,8 +10202,8 @@
         </p:nvSpPr>
         <p:spPr>
           <a:xfrm>
-            <a:off x="457200" y="1234439"/>
-            <a:ext cx="109728" cy="3246120"/>
+            <a:off x="457200" y="1170432"/>
+            <a:ext cx="109728" cy="3721608"/>
           </a:xfrm>
           <a:prstGeom prst="rect">
             <a:avLst/>
@@ -10246,7 +10246,7 @@
         </p:nvSpPr>
         <p:spPr>
           <a:xfrm>
-            <a:off x="640080" y="1307592"/>
+            <a:off x="640080" y="1243584"/>
             <a:ext cx="3332378" cy="457200"/>
           </a:xfrm>
           <a:prstGeom prst="rect">
@@ -10266,13 +10266,13 @@
               </a:spcAft>
             </a:pPr>
             <a:r>
-              <a:rPr sz="2000" b="1" i="0">
+              <a:rPr sz="1800" b="1" i="0">
                 <a:solidFill>
                   <a:srgbClr val="2563EB"/>
                 </a:solidFill>
                 <a:latin typeface="Arial"/>
               </a:rPr>
-              <a:t>1  People want to learn</a:t>
+              <a:t>1  Surging volume</a:t>
             </a:r>
           </a:p>
         </p:txBody>
@@ -10285,8 +10285,8 @@
         </p:nvSpPr>
         <p:spPr>
           <a:xfrm>
-            <a:off x="640080" y="1764791"/>
-            <a:ext cx="3332378" cy="2642615"/>
+            <a:off x="640080" y="1700784"/>
+            <a:ext cx="3332378" cy="3118104"/>
           </a:xfrm>
           <a:prstGeom prst="rect">
             <a:avLst/>
@@ -10306,13 +10306,31 @@
               <a:buChar char="•"/>
             </a:pPr>
             <a:r>
-              <a:rPr sz="1800" b="0" i="0">
+              <a:rPr sz="1600" b="0" i="0">
                 <a:solidFill>
                   <a:srgbClr val="0F172A"/>
                 </a:solidFill>
                 <a:latin typeface="Arial"/>
               </a:rPr>
-              <a:t>Mainstream: legal in 38 US states since 2018 ¹</a:t>
+              <a:t>Kalshi + Polymarket: </a:t>
+            </a:r>
+            <a:r>
+              <a:rPr sz="1600" b="1" i="0">
+                <a:solidFill>
+                  <a:srgbClr val="0F172A"/>
+                </a:solidFill>
+                <a:latin typeface="Arial"/>
+              </a:rPr>
+              <a:t>$26B → $53B</a:t>
+            </a:r>
+            <a:r>
+              <a:rPr sz="1600" b="0" i="0">
+                <a:solidFill>
+                  <a:srgbClr val="0F172A"/>
+                </a:solidFill>
+                <a:latin typeface="Arial"/>
+              </a:rPr>
+              <a:t> a month, May → Jul 2026 ¹</a:t>
             </a:r>
           </a:p>
           <a:p>
@@ -10323,13 +10341,31 @@
               <a:buChar char="•"/>
             </a:pPr>
             <a:r>
-              <a:rPr sz="1800" b="0" i="0">
+              <a:rPr sz="1600" b="0" i="0">
                 <a:solidFill>
                   <a:srgbClr val="0F172A"/>
                 </a:solidFill>
                 <a:latin typeface="Arial"/>
               </a:rPr>
-              <a:t>46% of adults worldwide gambled last year ²</a:t>
+              <a:t>Kalshi Sep 2026: </a:t>
+            </a:r>
+            <a:r>
+              <a:rPr sz="1600" b="1" i="0">
+                <a:solidFill>
+                  <a:srgbClr val="0F172A"/>
+                </a:solidFill>
+                <a:latin typeface="Arial"/>
+              </a:rPr>
+              <a:t>$61B</a:t>
+            </a:r>
+            <a:r>
+              <a:rPr sz="1600" b="0" i="0">
+                <a:solidFill>
+                  <a:srgbClr val="0F172A"/>
+                </a:solidFill>
+                <a:latin typeface="Arial"/>
+              </a:rPr>
+              <a:t> notional, ~46× a year earlier ²</a:t>
             </a:r>
           </a:p>
           <a:p>
@@ -10340,13 +10376,30 @@
               <a:buChar char="•"/>
             </a:pPr>
             <a:r>
-              <a:rPr sz="1800" b="0" i="0">
+              <a:rPr sz="1600" b="0" i="0">
                 <a:solidFill>
                   <a:srgbClr val="0F172A"/>
                 </a:solidFill>
                 <a:latin typeface="Arial"/>
               </a:rPr>
-              <a:t>Few understand prices, fees and spreads</a:t>
+              <a:t>Sold in Robinhood (~2M users) and Coinbase apps ³</a:t>
+            </a:r>
+          </a:p>
+          <a:p>
+            <a:pPr algn="l" marL="292608" indent="-256032">
+              <a:spcAft>
+                <a:spcPts val="600"/>
+              </a:spcAft>
+              <a:buChar char="•"/>
+            </a:pPr>
+            <a:r>
+              <a:rPr sz="1600" b="0" i="0">
+                <a:solidFill>
+                  <a:srgbClr val="0F172A"/>
+                </a:solidFill>
+                <a:latin typeface="Arial"/>
+              </a:rPr>
+              <a:t>Valued at $22B (Kalshi), $21B (Polymarket) ⁴</a:t>
             </a:r>
           </a:p>
         </p:txBody>
@@ -10359,8 +10412,8 @@
         </p:nvSpPr>
         <p:spPr>
           <a:xfrm>
-            <a:off x="4292498" y="1234439"/>
-            <a:ext cx="3606698" cy="3246120"/>
+            <a:off x="4292498" y="1170432"/>
+            <a:ext cx="3606698" cy="3721608"/>
           </a:xfrm>
           <a:prstGeom prst="roundRect">
             <a:avLst>
@@ -10407,8 +10460,8 @@
         </p:nvSpPr>
         <p:spPr>
           <a:xfrm>
-            <a:off x="4292498" y="1234439"/>
-            <a:ext cx="109728" cy="3246120"/>
+            <a:off x="4292498" y="1170432"/>
+            <a:ext cx="109728" cy="3721608"/>
           </a:xfrm>
           <a:prstGeom prst="rect">
             <a:avLst/>
@@ -10451,7 +10504,7 @@
         </p:nvSpPr>
         <p:spPr>
           <a:xfrm>
-            <a:off x="4475378" y="1307592"/>
+            <a:off x="4475378" y="1243584"/>
             <a:ext cx="3332378" cy="457200"/>
           </a:xfrm>
           <a:prstGeom prst="rect">
@@ -10471,13 +10524,13 @@
               </a:spcAft>
             </a:pPr>
             <a:r>
-              <a:rPr sz="2000" b="1" i="0">
+              <a:rPr sz="1800" b="1" i="0">
                 <a:solidFill>
                   <a:srgbClr val="EA580C"/>
                 </a:solidFill>
                 <a:latin typeface="Arial"/>
               </a:rPr>
-              <a:t>2  Markets are tilted</a:t>
+              <a:t>2  Thin price protection</a:t>
             </a:r>
           </a:p>
         </p:txBody>
@@ -10490,8 +10543,8 @@
         </p:nvSpPr>
         <p:spPr>
           <a:xfrm>
-            <a:off x="4475378" y="1764791"/>
-            <a:ext cx="3332378" cy="2642615"/>
+            <a:off x="4475378" y="1700784"/>
+            <a:ext cx="3332378" cy="3118104"/>
           </a:xfrm>
           <a:prstGeom prst="rect">
             <a:avLst/>
@@ -10511,13 +10564,13 @@
               <a:buChar char="•"/>
             </a:pPr>
             <a:r>
-              <a:rPr sz="1800" b="0" i="0">
+              <a:rPr sz="1600" b="0" i="0">
                 <a:solidFill>
                   <a:srgbClr val="0F172A"/>
                 </a:solidFill>
                 <a:latin typeface="Arial"/>
               </a:rPr>
-              <a:t>~5.0% cost on every trade</a:t>
+              <a:t>No house edge, but fees, spreads and pro market makers, incl. Kalshi's own ⁵</a:t>
             </a:r>
           </a:p>
           <a:p>
@@ -10528,13 +10581,13 @@
               <a:buChar char="•"/>
             </a:pPr>
             <a:r>
-              <a:rPr sz="1800" b="0" i="0">
+              <a:rPr sz="1600" b="0" i="0">
                 <a:solidFill>
                   <a:srgbClr val="0F172A"/>
                 </a:solidFill>
                 <a:latin typeface="Arial"/>
               </a:rPr>
-              <a:t>91% of the price move comes before the public news</a:t>
+              <a:t>CFTC checks integrity, not fair prices or gambling harm; 18+ ⁶</a:t>
             </a:r>
           </a:p>
           <a:p>
@@ -10545,13 +10598,30 @@
               <a:buChar char="•"/>
             </a:pPr>
             <a:r>
-              <a:rPr sz="1800" b="0" i="0">
+              <a:rPr sz="1600" b="0" i="0">
                 <a:solidFill>
                   <a:srgbClr val="0F172A"/>
                 </a:solidFill>
                 <a:latin typeface="Arial"/>
               </a:rPr>
-              <a:t>The market beats our model; never trading wins</a:t>
+              <a:t>Courts split on state power (3rd vs 9th Cir.) ⁷</a:t>
+            </a:r>
+          </a:p>
+          <a:p>
+            <a:pPr algn="l" marL="292608" indent="-256032">
+              <a:spcAft>
+                <a:spcPts val="600"/>
+              </a:spcAft>
+              <a:buChar char="•"/>
+            </a:pPr>
+            <a:r>
+              <a:rPr sz="1600" b="1" i="0">
+                <a:solidFill>
+                  <a:srgbClr val="0F172A"/>
+                </a:solidFill>
+                <a:latin typeface="Arial"/>
+              </a:rPr>
+              <a:t>Ours: ~5.0% cost per trade; 91% of the move before the news</a:t>
             </a:r>
           </a:p>
         </p:txBody>
@@ -10564,8 +10634,8 @@
         </p:nvSpPr>
         <p:spPr>
           <a:xfrm>
-            <a:off x="8127796" y="1234439"/>
-            <a:ext cx="3606698" cy="3246120"/>
+            <a:off x="8127796" y="1170432"/>
+            <a:ext cx="3606698" cy="3721608"/>
           </a:xfrm>
           <a:prstGeom prst="roundRect">
             <a:avLst>
@@ -10612,8 +10682,8 @@
         </p:nvSpPr>
         <p:spPr>
           <a:xfrm>
-            <a:off x="8127796" y="1234439"/>
-            <a:ext cx="109728" cy="3246120"/>
+            <a:off x="8127796" y="1170432"/>
+            <a:ext cx="109728" cy="3721608"/>
           </a:xfrm>
           <a:prstGeom prst="rect">
             <a:avLst/>
@@ -10656,7 +10726,7 @@
         </p:nvSpPr>
         <p:spPr>
           <a:xfrm>
-            <a:off x="8310676" y="1307592"/>
+            <a:off x="8310676" y="1243584"/>
             <a:ext cx="3332378" cy="457200"/>
           </a:xfrm>
           <a:prstGeom prst="rect">
@@ -10676,7 +10746,7 @@
               </a:spcAft>
             </a:pPr>
             <a:r>
-              <a:rPr sz="2000" b="1" i="0">
+              <a:rPr sz="1800" b="1" i="0">
                 <a:solidFill>
                   <a:srgbClr val="DC2626"/>
                 </a:solidFill>
@@ -10695,8 +10765,8 @@
         </p:nvSpPr>
         <p:spPr>
           <a:xfrm>
-            <a:off x="8310676" y="1764791"/>
-            <a:ext cx="3332378" cy="2642615"/>
+            <a:off x="8310676" y="1700784"/>
+            <a:ext cx="3332378" cy="3118104"/>
           </a:xfrm>
           <a:prstGeom prst="rect">
             <a:avLst/>
@@ -10716,13 +10786,13 @@
               <a:buChar char="•"/>
             </a:pPr>
             <a:r>
-              <a:rPr sz="1800" b="0" i="0">
+              <a:rPr sz="1600" b="0" i="0">
                 <a:solidFill>
                   <a:srgbClr val="0F172A"/>
                 </a:solidFill>
                 <a:latin typeface="Arial"/>
               </a:rPr>
-              <a:t>~80M adults with gambling disorder or problem gambling ²</a:t>
+              <a:t>~80M adults with gambling disorder or problem gambling ⁸</a:t>
             </a:r>
           </a:p>
           <a:p>
@@ -10733,122 +10803,27 @@
               <a:buChar char="•"/>
             </a:pPr>
             <a:r>
-              <a:rPr sz="1800" b="0" i="0">
+              <a:rPr sz="1600" b="0" i="0">
                 <a:solidFill>
                   <a:srgbClr val="0F172A"/>
                 </a:solidFill>
                 <a:latin typeface="Arial"/>
               </a:rPr>
-              <a:t>Online betting: credit scores −2.75 pts, bankruptcies +~10% ¹</a:t>
-            </a:r>
-          </a:p>
-          <a:p>
-            <a:pPr algn="l" marL="292608" indent="-256032">
-              <a:spcAft>
-                <a:spcPts val="600"/>
-              </a:spcAft>
-              <a:buChar char="•"/>
-            </a:pPr>
-            <a:r>
-              <a:rPr sz="1800" b="0" i="0">
-                <a:solidFill>
-                  <a:srgbClr val="0F172A"/>
-                </a:solidFill>
-                <a:latin typeface="Arial"/>
-              </a:rPr>
-              <a:t>$1 of online betting cuts investment ~$0.99 ³</a:t>
-            </a:r>
-          </a:p>
-        </p:txBody>
-      </p:sp>
-      <p:sp>
-        <p:nvSpPr>
-          <p:cNvPr id="19" name="TextBox 18"/>
-          <p:cNvSpPr txBox="1"/>
-          <p:nvPr/>
-        </p:nvSpPr>
-        <p:spPr>
-          <a:xfrm>
-            <a:off x="4292498" y="4526280"/>
-            <a:ext cx="3606698" cy="411480"/>
-          </a:xfrm>
-          <a:prstGeom prst="rect">
-            <a:avLst/>
-          </a:prstGeom>
-          <a:noFill/>
-        </p:spPr>
-        <p:txBody>
-          <a:bodyPr wrap="square" anchor="t" lIns="73152" rIns="73152" tIns="36576" bIns="36576">
-            <a:spAutoFit/>
-          </a:bodyPr>
-          <a:lstStyle/>
-          <a:p>
-            <a:pPr algn="ctr">
-              <a:spcAft>
-                <a:spcPts val="800"/>
-              </a:spcAft>
-            </a:pPr>
-            <a:r>
-              <a:rPr sz="1400" b="0" i="1">
-                <a:solidFill>
-                  <a:srgbClr val="EA580C"/>
-                </a:solidFill>
-                <a:latin typeface="Arial"/>
-              </a:rPr>
-              <a:t>Our measurements</a:t>
-            </a:r>
-          </a:p>
-        </p:txBody>
-      </p:sp>
-      <p:sp>
-        <p:nvSpPr>
-          <p:cNvPr id="20" name="TextBox 19"/>
-          <p:cNvSpPr txBox="1"/>
-          <p:nvPr/>
-        </p:nvSpPr>
-        <p:spPr>
-          <a:xfrm>
-            <a:off x="8127796" y="4526280"/>
-            <a:ext cx="3606698" cy="411480"/>
-          </a:xfrm>
-          <a:prstGeom prst="rect">
-            <a:avLst/>
-          </a:prstGeom>
-          <a:noFill/>
-        </p:spPr>
-        <p:txBody>
-          <a:bodyPr wrap="square" anchor="t" lIns="73152" rIns="73152" tIns="36576" bIns="36576">
-            <a:spAutoFit/>
-          </a:bodyPr>
-          <a:lstStyle/>
-          <a:p>
-            <a:pPr algn="ctr">
-              <a:spcAft>
-                <a:spcPts val="800"/>
-              </a:spcAft>
-            </a:pPr>
-            <a:r>
-              <a:rPr sz="1400" b="0" i="1">
-                <a:solidFill>
-                  <a:srgbClr val="DC2626"/>
-                </a:solidFill>
-                <a:latin typeface="Arial"/>
-              </a:rPr>
-              <a:t>External research</a:t>
-            </a:r>
-          </a:p>
-        </p:txBody>
-      </p:sp>
-      <p:sp>
-        <p:nvSpPr>
-          <p:cNvPr id="21" name="Rounded Rectangle 20"/>
+              <a:t>Online betting: credit scores −2.75 pts, bankruptcies +~10% ⁹</a:t>
+            </a:r>
+          </a:p>
+        </p:txBody>
+      </p:sp>
+      <p:sp>
+        <p:nvSpPr>
+          <p:cNvPr id="19" name="Rounded Rectangle 18"/>
           <p:cNvSpPr/>
           <p:nvPr/>
         </p:nvSpPr>
         <p:spPr>
           <a:xfrm>
-            <a:off x="457200" y="5074920"/>
-            <a:ext cx="11277295" cy="640080"/>
+            <a:off x="457200" y="4974336"/>
+            <a:ext cx="11277295" cy="502920"/>
           </a:xfrm>
           <a:prstGeom prst="roundRect">
             <a:avLst>
@@ -10887,14 +10862,14 @@
       </p:sp>
       <p:sp>
         <p:nvSpPr>
-          <p:cNvPr id="22" name="TextBox 21"/>
+          <p:cNvPr id="20" name="TextBox 19"/>
           <p:cNvSpPr txBox="1"/>
           <p:nvPr/>
         </p:nvSpPr>
         <p:spPr>
           <a:xfrm>
-            <a:off x="548640" y="5074920"/>
-            <a:ext cx="11094415" cy="640080"/>
+            <a:off x="548640" y="4974336"/>
+            <a:ext cx="11094415" cy="502920"/>
           </a:xfrm>
           <a:prstGeom prst="rect">
             <a:avLst/>
@@ -10913,7 +10888,7 @@
               </a:spcAft>
             </a:pPr>
             <a:r>
-              <a:rPr sz="2200" b="0" i="0">
+              <a:rPr sz="2000" b="0" i="0">
                 <a:solidFill>
                   <a:srgbClr val="0F172A"/>
                 </a:solidFill>
@@ -10926,14 +10901,14 @@
       </p:sp>
       <p:sp>
         <p:nvSpPr>
-          <p:cNvPr id="23" name="TextBox 22"/>
+          <p:cNvPr id="21" name="TextBox 20"/>
           <p:cNvSpPr txBox="1"/>
           <p:nvPr/>
         </p:nvSpPr>
         <p:spPr>
           <a:xfrm>
-            <a:off x="457200" y="5897880"/>
-            <a:ext cx="11277295" cy="457200"/>
+            <a:off x="457200" y="5513832"/>
+            <a:ext cx="11277295" cy="841248"/>
           </a:xfrm>
           <a:prstGeom prst="rect">
             <a:avLst/>
@@ -10948,17 +10923,17 @@
           <a:p>
             <a:pPr algn="l">
               <a:spcAft>
-                <a:spcPts val="800"/>
+                <a:spcPts val="0"/>
               </a:spcAft>
             </a:pPr>
             <a:r>
-              <a:rPr sz="1300" b="0" i="0">
+              <a:rPr sz="1000" b="0" i="0">
                 <a:solidFill>
                   <a:srgbClr val="64748B"/>
                 </a:solidFill>
                 <a:latin typeface="Arial"/>
               </a:rPr>
-              <a:t>¹ Hollenbeck, Larsen &amp; Proserpio 2024 (SSRN)   ² Lancet Public Health Commission on gambling 2024   ³ Baker et al. 2024 (NBER WP 33108)</a:t>
+              <a:t>¹ Pew Research, 23 Sep 2026 (The Block data)   ² NEXTPredict / TickerTracker, Sep–Oct 2026   ³ Robinhood Q2 2026 results; Coinbase, 28 Jan 2026   ⁴ Kalshi, 7 May 2026; Bloomberg, 31 Aug 2026   ⁵ Kalshi fee schedule &amp; Rule 2.12; CFTC affiliate proposal 2026   ⁶ DCM core principles; NBA letter to CFTC, 30 Apr 2026   ⁷ KalshiEX v. Flaherty (3d Cir., 6 Apr 2026); KalshiEX v. Assad (9th Cir., 28 Aug 2026)   ⁸ Lancet Public Health 2024   ⁹ Hollenbeck, Larsen &amp; Proserpio 2024 (SSRN)   Full list: docs/market_regulation.md</a:t>
             </a:r>
           </a:p>
         </p:txBody>

</xml_diff>

<commit_message>
results: LLM tool agent on DeepSeek chat and reasoner (B, C, D on the 40% test subsample)
Reasoner support in DeepSeekBackend (no temperature, max_tokens 8192, reasoning length logged,
robust JSON extraction) with an offline test; paired chat-vs-reasoner comparison; results,
README and deck updated. Prompts, tools, validation and decision points unchanged.

Co-authored-by: Cursor <cursoragent@cursor.com>
</commit_message>
<xml_diff>
--- a/presentation/nba_agent_deck.pptx
+++ b/presentation/nba_agent_deck.pptx
@@ -656,7 +656,7 @@
           <a:lstStyle/>
           <a:p>
             <a:r>
-              <a:t>We then made the agent more agentic and graded each upgrade the same way, pre-registered before scoring. Gate audit: the split gate, which judges a rule on held-out days by CLV dollars, kept 5 of 11 proposed rules where the legacy gate kept 0 of 24. Trades fell from 129 to 53 and CLV dollars improved by +$18 [+1, +34], but mean CLV per trade did not improve and it still does not beat never trading. The placebo test says why: random rules pass the split gate 57% of the time, the same as the reviewer's picks, so learning works by trading less, not by finding better rules. The kill switch is enforced but never tripped at $20 stakes; property tests show it blocks orders after a trip. Kelly sizing was not run. The Coach on simulated users with full compliance raises CLV dollars for every persona: overtrader +$88 [+65, +111], long-shot lover +$72 [+53, +90], cautious +$24 [+14, +36], price chaser +$17 [−4, +33], whose interval includes zero, and cuts trades by 66–87%. But it flags 99% of trades, so again the gain is trading less. The plain LLM made 5 trades in 304 decisions, CLV −$1, the same as never trading; the deterministic agent made 53 trades, CLV −$19. The tool agent and the sceptic are pending: the Gemini quota ran out and they are being re-run on DeepSeek. The orchestrator is built, shown on the right. The learned policy's selection step chose never trade, and the test was not scored. The rule language and memory are built and tested but not evaluated. The message: Every agentic upgrade, graded by the market, converges on the same answer: trade less. The market is hard to beat after fees, which is exactly why the product is education, not a trading bot.</a:t>
+              <a:t>We then made the agent more agentic and graded each upgrade the same way, pre-registered before scoring. Gate audit: the split gate, which judges a rule on held-out days by CLV dollars, kept 5 of 11 proposed rules where the legacy gate kept 0 of 24. Trades fell from 129 to 53 and CLV dollars improved by +$18 [+1, +34], but mean CLV per trade did not improve and it still does not beat never trading. The placebo test says why: random rules pass the split gate 57% of the time, the same as the reviewer's picks, so learning works by trading less, not by finding better rules. The kill switch is enforced but never tripped at $20 stakes; property tests show it blocks orders after a trip. Kelly sizing was not run. The Coach on simulated users with full compliance raises CLV dollars for every persona: overtrader +$88 [+65, +111], long-shot lover +$72 [+53, +90], cautious +$24 [+14, +36], price chaser +$17 [−4, +33], whose interval includes zero, and cuts trades by 66–87%. But it flags 99% of trades, so again the gain is trading less. The plain LLM made 5 trades in 304 decisions, CLV −$1, the same as never trading; the deterministic agent made 53 trades, CLV −$19. The tool agent with the sceptic, re-run on DeepSeek: DeepSeek reasoner: 2 trades, CLV $ +$4 [−3, +15] = never; sceptic vetoed 40/42 (chat: 0 trades). The orchestrator is built, shown on the right. The learned policy's selection step chose never trade, and the test was not scored. The rule language and memory are built and tested but not evaluated. The message: Every agentic upgrade, graded by the market, converges on the same answer: trade less. The market is hard to beat after fees, which is exactly why the product is education, not a trading bot.</a:t>
             </a:r>
           </a:p>
         </p:txBody>
@@ -6248,13 +6248,13 @@
                     <a:p>
                       <a:pPr algn="l"/>
                       <a:r>
-                        <a:rPr sz="1100" b="0" i="1">
+                        <a:rPr sz="1100" b="0" i="0">
                           <a:solidFill>
-                            <a:srgbClr val="64748B"/>
+                            <a:srgbClr val="0F172A"/>
                           </a:solidFill>
                           <a:latin typeface="Arial"/>
                         </a:rPr>
-                        <a:t>pending</a:t>
+                        <a:t>DeepSeek reasoner: 2 trades, CLV $ +$4 [−3, +15] = never; sceptic vetoed 40/42 (chat: 0 trades)</a:t>
                       </a:r>
                     </a:p>
                   </a:txBody>

</xml_diff>

<commit_message>
results: LLM tool agent on DeepSeek chat and reasoner (B, C, D on the 40% test subsample) (#18)
Reasoner support in DeepSeekBackend (no temperature, max_tokens 8192, reasoning length logged,
robust JSON extraction) with an offline test; paired chat-vs-reasoner comparison; results,
README and deck updated. Prompts, tools, validation and decision points unchanged.

Co-authored-by: Michael Ngan <michaelngan@ip-192-168-43-14.us-west-2.compute.internal>
Co-authored-by: Cursor <cursoragent@cursor.com>
</commit_message>
<xml_diff>
--- a/presentation/nba_agent_deck.pptx
+++ b/presentation/nba_agent_deck.pptx
@@ -656,7 +656,7 @@
           <a:lstStyle/>
           <a:p>
             <a:r>
-              <a:t>We then made the agent more agentic and graded each upgrade the same way, pre-registered before scoring. Gate audit: the split gate, which judges a rule on held-out days by CLV dollars, kept 5 of 11 proposed rules where the legacy gate kept 0 of 24. Trades fell from 129 to 53 and CLV dollars improved by +$18 [+1, +34], but mean CLV per trade did not improve and it still does not beat never trading. The placebo test says why: random rules pass the split gate 57% of the time, the same as the reviewer's picks, so learning works by trading less, not by finding better rules. The kill switch is enforced but never tripped at $20 stakes; property tests show it blocks orders after a trip. Kelly sizing was not run. The Coach on simulated users with full compliance raises CLV dollars for every persona: overtrader +$88 [+65, +111], long-shot lover +$72 [+53, +90], cautious +$24 [+14, +36], price chaser +$17 [−4, +33], whose interval includes zero, and cuts trades by 66–87%. But it flags 99% of trades, so again the gain is trading less. The plain LLM made 5 trades in 304 decisions, CLV −$1, the same as never trading; the deterministic agent made 53 trades, CLV −$19. The tool agent and the sceptic are pending: the Gemini quota ran out and they are being re-run on DeepSeek. The orchestrator is built, shown on the right. The learned policy's selection step chose never trade, and the test was not scored. The rule language and memory are built and tested but not evaluated. The message: Every agentic upgrade, graded by the market, converges on the same answer: trade less. The market is hard to beat after fees, which is exactly why the product is education, not a trading bot.</a:t>
+              <a:t>We then made the agent more agentic and graded each upgrade the same way, pre-registered before scoring. Gate audit: the split gate, which judges a rule on held-out days by CLV dollars, kept 5 of 11 proposed rules where the legacy gate kept 0 of 24. Trades fell from 129 to 53 and CLV dollars improved by +$18 [+1, +34], but mean CLV per trade did not improve and it still does not beat never trading. The placebo test says why: random rules pass the split gate 57% of the time, the same as the reviewer's picks, so learning works by trading less, not by finding better rules. The kill switch is enforced but never tripped at $20 stakes; property tests show it blocks orders after a trip. Kelly sizing was not run. The Coach on simulated users with full compliance raises CLV dollars for every persona: overtrader +$88 [+65, +111], long-shot lover +$72 [+53, +90], cautious +$24 [+14, +36], price chaser +$17 [−4, +33], whose interval includes zero, and cuts trades by 66–87%. But it flags 99% of trades, so again the gain is trading less. The plain LLM made 5 trades in 304 decisions, CLV −$1, the same as never trading; the deterministic agent made 53 trades, CLV −$19. The tool agent with the sceptic, re-run on DeepSeek: DeepSeek reasoner: 2 trades, CLV $ +$4 [−3, +15] = never; sceptic vetoed 40/42 (chat: 0 trades). The orchestrator is built, shown on the right. The learned policy's selection step chose never trade, and the test was not scored. The rule language and memory are built and tested but not evaluated. The message: Every agentic upgrade, graded by the market, converges on the same answer: trade less. The market is hard to beat after fees, which is exactly why the product is education, not a trading bot.</a:t>
             </a:r>
           </a:p>
         </p:txBody>
@@ -6248,13 +6248,13 @@
                     <a:p>
                       <a:pPr algn="l"/>
                       <a:r>
-                        <a:rPr sz="1100" b="0" i="1">
+                        <a:rPr sz="1100" b="0" i="0">
                           <a:solidFill>
-                            <a:srgbClr val="64748B"/>
+                            <a:srgbClr val="0F172A"/>
                           </a:solidFill>
                           <a:latin typeface="Arial"/>
                         </a:rPr>
-                        <a:t>pending</a:t>
+                        <a:t>DeepSeek reasoner: 2 trades, CLV $ +$4 [−3, +15] = never; sceptic vetoed 40/42 (chat: 0 trades)</a:t>
                       </a:r>
                     </a:p>
                   </a:txBody>

</xml_diff>